<commit_message>
Peña-Ardila PPT v3: fix slide 2 (why interesting) + slide 7 (conclusion first, then LR bridge)
</commit_message>
<xml_diff>
--- a/lr-slides/Presenting_Article_Pena-Ardila.pptx
+++ b/lr-slides/Presenting_Article_Pena-Ardila.pptx
@@ -3111,7 +3111,7 @@
         <p:spPr>
           <a:xfrm>
             <a:off x="0" y="0"/>
-            <a:ext cx="12191695" cy="137160"/>
+            <a:ext cx="12191695" cy="109728"/>
           </a:xfrm>
           <a:prstGeom prst="rect">
             <a:avLst/>
@@ -3321,8 +3321,8 @@
         </p:nvSpPr>
         <p:spPr>
           <a:xfrm>
-            <a:off x="0" y="6720840"/>
-            <a:ext cx="12191695" cy="19050"/>
+            <a:off x="0" y="6748272"/>
+            <a:ext cx="12191695" cy="15240"/>
           </a:xfrm>
           <a:prstGeom prst="rect">
             <a:avLst/>
@@ -3498,7 +3498,7 @@
               </a:defRPr>
             </a:pPr>
             <a:r>
-              <a:t>Why This Article?</a:t>
+              <a:t>Why Is This Topic Interesting?</a:t>
             </a:r>
           </a:p>
         </p:txBody>
@@ -3512,7 +3512,7 @@
         <p:spPr>
           <a:xfrm>
             <a:off x="731520" y="1005840"/>
-            <a:ext cx="3200400" cy="19050"/>
+            <a:ext cx="3200400" cy="15240"/>
           </a:xfrm>
           <a:prstGeom prst="rect">
             <a:avLst/>
@@ -3580,7 +3580,7 @@
               </a:defRPr>
             </a:pPr>
             <a:r>
-              <a:t>Most RECENT (2026)</a:t>
+              <a:t>Global relevance</a:t>
             </a:r>
           </a:p>
         </p:txBody>
@@ -3594,7 +3594,7 @@
         <p:spPr>
           <a:xfrm>
             <a:off x="1097280" y="1920240"/>
-            <a:ext cx="9144000" cy="548640"/>
+            <a:ext cx="9601200" cy="731520"/>
           </a:xfrm>
           <a:prstGeom prst="rect">
             <a:avLst/>
@@ -3619,7 +3619,11 @@
               </a:defRPr>
             </a:pPr>
             <a:r>
-              <a:t>Covers 2010–2018 primary research → a full map of the field</a:t>
+              <a:t>Futsal = 60M+ participants worldwide (FIFA)</a:t>
+            </a:r>
+            <a:br/>
+            <a:r>
+              <a:t>Brazilian greats — Pelé, Ronaldinho, Neymar — all credit futsal background</a:t>
             </a:r>
           </a:p>
         </p:txBody>
@@ -3632,8 +3636,8 @@
         </p:nvSpPr>
         <p:spPr>
           <a:xfrm>
-            <a:off x="1097280" y="2651760"/>
-            <a:ext cx="9144000" cy="10160"/>
+            <a:off x="1097280" y="2880360"/>
+            <a:ext cx="9601200" cy="7620"/>
           </a:xfrm>
           <a:prstGeom prst="rect">
             <a:avLst/>
@@ -3675,7 +3679,7 @@
         </p:nvSpPr>
         <p:spPr>
           <a:xfrm>
-            <a:off x="1097280" y="3108960"/>
+            <a:off x="1097280" y="3154680"/>
             <a:ext cx="9144000" cy="457200"/>
           </a:xfrm>
           <a:prstGeom prst="rect">
@@ -3701,7 +3705,7 @@
               </a:defRPr>
             </a:pPr>
             <a:r>
-              <a:t>Perfect MATCH for my LR</a:t>
+              <a:t>Concept widely believed, rarely tested</a:t>
             </a:r>
           </a:p>
         </p:txBody>
@@ -3714,8 +3718,8 @@
         </p:nvSpPr>
         <p:spPr>
           <a:xfrm>
-            <a:off x="1097280" y="3566160"/>
-            <a:ext cx="9144000" cy="548640"/>
+            <a:off x="1097280" y="3611880"/>
+            <a:ext cx="9601200" cy="731520"/>
           </a:xfrm>
           <a:prstGeom prst="rect">
             <a:avLst/>
@@ -3740,7 +3744,11 @@
               </a:defRPr>
             </a:pPr>
             <a:r>
-              <a:t>Directly tests the "donor sport" concept · systematic review + meta-analysis</a:t>
+              <a:t>Donor sport idea used in coaching for decades</a:t>
+            </a:r>
+            <a:br/>
+            <a:r>
+              <a:t>But empirical evidence is fragmented — this review tests it with numbers</a:t>
             </a:r>
           </a:p>
         </p:txBody>
@@ -3753,8 +3761,8 @@
         </p:nvSpPr>
         <p:spPr>
           <a:xfrm>
-            <a:off x="1097280" y="4297680"/>
-            <a:ext cx="9144000" cy="10160"/>
+            <a:off x="1097280" y="4572000"/>
+            <a:ext cx="9601200" cy="7620"/>
           </a:xfrm>
           <a:prstGeom prst="rect">
             <a:avLst/>
@@ -3796,7 +3804,7 @@
         </p:nvSpPr>
         <p:spPr>
           <a:xfrm>
-            <a:off x="1097280" y="4754880"/>
+            <a:off x="1097280" y="4846320"/>
             <a:ext cx="9144000" cy="457200"/>
           </a:xfrm>
           <a:prstGeom prst="rect">
@@ -3822,7 +3830,7 @@
               </a:defRPr>
             </a:pPr>
             <a:r>
-              <a:t>PRACTICAL Shortcut</a:t>
+              <a:t>Talent development stakes</a:t>
             </a:r>
           </a:p>
         </p:txBody>
@@ -3835,8 +3843,8 @@
         </p:nvSpPr>
         <p:spPr>
           <a:xfrm>
-            <a:off x="1097280" y="5212080"/>
-            <a:ext cx="9144000" cy="548640"/>
+            <a:off x="1097280" y="5303520"/>
+            <a:ext cx="9601200" cy="731520"/>
           </a:xfrm>
           <a:prstGeom prst="rect">
             <a:avLst/>
@@ -3861,7 +3869,11 @@
               </a:defRPr>
             </a:pPr>
             <a:r>
-              <a:t>One paper ≈ knowing what the whole field has done → guides further source searching</a:t>
+              <a:t>Early diversification vs. early specialization debate</a:t>
+            </a:r>
+            <a:br/>
+            <a:r>
+              <a:t>Practical guidance coaches need — what transfers, what doesn't</a:t>
             </a:r>
           </a:p>
         </p:txBody>
@@ -3983,7 +3995,7 @@
         <p:spPr>
           <a:xfrm>
             <a:off x="731520" y="1005840"/>
-            <a:ext cx="3200400" cy="19050"/>
+            <a:ext cx="3200400" cy="15240"/>
           </a:xfrm>
           <a:prstGeom prst="rect">
             <a:avLst/>
@@ -4039,129 +4051,17 @@
           </a:bodyPr>
           <a:lstStyle/>
           <a:p>
-            <a:pPr>
-              <a:spcAft>
-                <a:spcPts val="600"/>
-              </a:spcAft>
-            </a:pPr>
-            <a:r>
-              <a:rPr b="1" sz="1700">
+            <a:pPr algn="l">
+              <a:spcAft>
+                <a:spcPts val="400"/>
+              </a:spcAft>
+              <a:defRPr sz="1700" b="0">
                 <a:solidFill>
                   <a:srgbClr val="2D2240"/>
                 </a:solidFill>
                 <a:latin typeface="Segoe UI"/>
-              </a:rPr>
-              <a:t>Guideline:</a:t>
-            </a:r>
-            <a:r>
-              <a:rPr sz="1700">
-                <a:solidFill>
-                  <a:srgbClr val="2D2240"/>
-                </a:solidFill>
-                <a:latin typeface="Segoe UI"/>
-              </a:rPr>
-              <a:t> PRISMA 2020</a:t>
-            </a:r>
-          </a:p>
-          <a:p>
-            <a:pPr>
-              <a:spcAft>
-                <a:spcPts val="600"/>
-              </a:spcAft>
-            </a:pPr>
-            <a:r>
-              <a:rPr b="1" sz="1700">
-                <a:solidFill>
-                  <a:srgbClr val="2D2240"/>
-                </a:solidFill>
-                <a:latin typeface="Segoe UI"/>
-              </a:rPr>
-              <a:t>Databases:</a:t>
-            </a:r>
-            <a:r>
-              <a:rPr sz="1700">
-                <a:solidFill>
-                  <a:srgbClr val="2D2240"/>
-                </a:solidFill>
-                <a:latin typeface="Segoe UI"/>
-              </a:rPr>
-              <a:t> Scopus · ScienceDirect · Web of Science</a:t>
-            </a:r>
-          </a:p>
-          <a:p>
-            <a:pPr>
-              <a:spcAft>
-                <a:spcPts val="600"/>
-              </a:spcAft>
-            </a:pPr>
-            <a:r>
-              <a:rPr b="1" sz="1700">
-                <a:solidFill>
-                  <a:srgbClr val="2D2240"/>
-                </a:solidFill>
-                <a:latin typeface="Segoe UI"/>
-              </a:rPr>
-              <a:t>Screening:</a:t>
-            </a:r>
-            <a:r>
-              <a:rPr sz="1700">
-                <a:solidFill>
-                  <a:srgbClr val="2D2240"/>
-                </a:solidFill>
-                <a:latin typeface="Segoe UI"/>
-              </a:rPr>
-              <a:t> 780 → 683 (dedup) → 38 (full-text) → 7 studies</a:t>
-            </a:r>
-          </a:p>
-          <a:p>
-            <a:pPr>
-              <a:spcAft>
-                <a:spcPts val="600"/>
-              </a:spcAft>
-            </a:pPr>
-            <a:r>
-              <a:rPr b="1" sz="1700">
-                <a:solidFill>
-                  <a:srgbClr val="2D2240"/>
-                </a:solidFill>
-                <a:latin typeface="Segoe UI"/>
-              </a:rPr>
-              <a:t>Criteria:</a:t>
-            </a:r>
-            <a:r>
-              <a:rPr sz="1700">
-                <a:solidFill>
-                  <a:srgbClr val="2D2240"/>
-                </a:solidFill>
-                <a:latin typeface="Segoe UI"/>
-              </a:rPr>
-              <a:t> PICO(S) — population, intervention, comparison, outcome</a:t>
-            </a:r>
-          </a:p>
-          <a:p>
-            <a:pPr>
-              <a:spcAft>
-                <a:spcPts val="600"/>
-              </a:spcAft>
-            </a:pPr>
-            <a:r>
-              <a:rPr b="1" sz="1700">
-                <a:solidFill>
-                  <a:srgbClr val="2D2240"/>
-                </a:solidFill>
-                <a:latin typeface="Segoe UI"/>
-              </a:rPr>
-              <a:t>Analysis:</a:t>
-            </a:r>
-            <a:r>
-              <a:rPr sz="1700">
-                <a:solidFill>
-                  <a:srgbClr val="2D2240"/>
-                </a:solidFill>
-                <a:latin typeface="Segoe UI"/>
-              </a:rPr>
-              <a:t> Random-effects meta-analysis · Hedges' g · I²</a:t>
-            </a:r>
+              </a:defRPr>
+            </a:pPr>
           </a:p>
         </p:txBody>
       </p:sp>
@@ -4173,8 +4073,8 @@
         </p:nvSpPr>
         <p:spPr>
           <a:xfrm>
-            <a:off x="6858000" y="1371600"/>
-            <a:ext cx="4572000" cy="457200"/>
+            <a:off x="731520" y="1371600"/>
+            <a:ext cx="5486400" cy="4114800"/>
           </a:xfrm>
           <a:prstGeom prst="rect">
             <a:avLst/>
@@ -4187,19 +4087,83 @@
           </a:bodyPr>
           <a:lstStyle/>
           <a:p>
-            <a:pPr algn="l">
-              <a:spcAft>
-                <a:spcPts val="400"/>
-              </a:spcAft>
-              <a:defRPr sz="1800" b="1">
-                <a:solidFill>
-                  <a:srgbClr val="7E57C2"/>
-                </a:solidFill>
-                <a:latin typeface="Segoe UI"/>
-              </a:defRPr>
-            </a:pPr>
-            <a:r>
-              <a:t>Key Numbers at a Glance</a:t>
+            <a:pPr>
+              <a:spcAft>
+                <a:spcPts val="600"/>
+              </a:spcAft>
+              <a:defRPr sz="1700">
+                <a:solidFill>
+                  <a:srgbClr val="2D2240"/>
+                </a:solidFill>
+                <a:latin typeface="Segoe UI"/>
+              </a:defRPr>
+            </a:pPr>
+            <a:r>
+              <a:t>Guideline: PRISMA 2020</a:t>
+            </a:r>
+          </a:p>
+          <a:p>
+            <a:pPr>
+              <a:spcAft>
+                <a:spcPts val="600"/>
+              </a:spcAft>
+              <a:defRPr sz="1700">
+                <a:solidFill>
+                  <a:srgbClr val="2D2240"/>
+                </a:solidFill>
+                <a:latin typeface="Segoe UI"/>
+              </a:defRPr>
+            </a:pPr>
+            <a:r>
+              <a:t>Databases: Scopus · ScienceDirect · Web of Science</a:t>
+            </a:r>
+          </a:p>
+          <a:p>
+            <a:pPr>
+              <a:spcAft>
+                <a:spcPts val="600"/>
+              </a:spcAft>
+              <a:defRPr sz="1700">
+                <a:solidFill>
+                  <a:srgbClr val="2D2240"/>
+                </a:solidFill>
+                <a:latin typeface="Segoe UI"/>
+              </a:defRPr>
+            </a:pPr>
+            <a:r>
+              <a:t>Screening: 780 → 683 (dedup) → 38 (full-text) → 7 studies</a:t>
+            </a:r>
+          </a:p>
+          <a:p>
+            <a:pPr>
+              <a:spcAft>
+                <a:spcPts val="600"/>
+              </a:spcAft>
+              <a:defRPr sz="1700">
+                <a:solidFill>
+                  <a:srgbClr val="2D2240"/>
+                </a:solidFill>
+                <a:latin typeface="Segoe UI"/>
+              </a:defRPr>
+            </a:pPr>
+            <a:r>
+              <a:t>Criteria: PICO(S) — population, intervention, comparison, outcome</a:t>
+            </a:r>
+          </a:p>
+          <a:p>
+            <a:pPr>
+              <a:spcAft>
+                <a:spcPts val="600"/>
+              </a:spcAft>
+              <a:defRPr sz="1700">
+                <a:solidFill>
+                  <a:srgbClr val="2D2240"/>
+                </a:solidFill>
+                <a:latin typeface="Segoe UI"/>
+              </a:defRPr>
+            </a:pPr>
+            <a:r>
+              <a:t>Analysis: Random-effects meta-analysis · Hedges' g · I²</a:t>
             </a:r>
           </a:p>
         </p:txBody>
@@ -4212,8 +4176,8 @@
         </p:nvSpPr>
         <p:spPr>
           <a:xfrm>
-            <a:off x="6858000" y="2011680"/>
-            <a:ext cx="4572000" cy="365760"/>
+            <a:off x="6858000" y="1371600"/>
+            <a:ext cx="4572000" cy="457200"/>
           </a:xfrm>
           <a:prstGeom prst="rect">
             <a:avLst/>
@@ -4230,15 +4194,15 @@
               <a:spcAft>
                 <a:spcPts val="400"/>
               </a:spcAft>
-              <a:defRPr sz="1400" b="0">
-                <a:solidFill>
-                  <a:srgbClr val="999999"/>
-                </a:solidFill>
-                <a:latin typeface="Segoe UI"/>
-              </a:defRPr>
-            </a:pPr>
-            <a:r>
-              <a:t>SMD (Effect Size)</a:t>
+              <a:defRPr sz="1800" b="1">
+                <a:solidFill>
+                  <a:srgbClr val="7E57C2"/>
+                </a:solidFill>
+                <a:latin typeface="Segoe UI"/>
+              </a:defRPr>
+            </a:pPr>
+            <a:r>
+              <a:t>Key Numbers at a Glance</a:t>
             </a:r>
           </a:p>
         </p:txBody>
@@ -4251,8 +4215,8 @@
         </p:nvSpPr>
         <p:spPr>
           <a:xfrm>
-            <a:off x="6858000" y="2331720"/>
-            <a:ext cx="4572000" cy="457200"/>
+            <a:off x="6858000" y="2011680"/>
+            <a:ext cx="4572000" cy="365760"/>
           </a:xfrm>
           <a:prstGeom prst="rect">
             <a:avLst/>
@@ -4269,15 +4233,15 @@
               <a:spcAft>
                 <a:spcPts val="400"/>
               </a:spcAft>
-              <a:defRPr sz="2400" b="1">
-                <a:solidFill>
-                  <a:srgbClr val="2E7D32"/>
-                </a:solidFill>
-                <a:latin typeface="Segoe UI"/>
-              </a:defRPr>
-            </a:pPr>
-            <a:r>
-              <a:t>1.43</a:t>
+              <a:defRPr sz="1400" b="0">
+                <a:solidFill>
+                  <a:srgbClr val="999999"/>
+                </a:solidFill>
+                <a:latin typeface="Segoe UI"/>
+              </a:defRPr>
+            </a:pPr>
+            <a:r>
+              <a:t>SMD (Effect Size)</a:t>
             </a:r>
           </a:p>
         </p:txBody>
@@ -4290,7 +4254,7 @@
         </p:nvSpPr>
         <p:spPr>
           <a:xfrm>
-            <a:off x="6858000" y="2788920"/>
+            <a:off x="6858000" y="2331720"/>
             <a:ext cx="4572000" cy="457200"/>
           </a:xfrm>
           <a:prstGeom prst="rect">
@@ -4308,6 +4272,45 @@
               <a:spcAft>
                 <a:spcPts val="400"/>
               </a:spcAft>
+              <a:defRPr sz="2400" b="1">
+                <a:solidFill>
+                  <a:srgbClr val="2E7D32"/>
+                </a:solidFill>
+                <a:latin typeface="Segoe UI"/>
+              </a:defRPr>
+            </a:pPr>
+            <a:r>
+              <a:t>1.43</a:t>
+            </a:r>
+          </a:p>
+        </p:txBody>
+      </p:sp>
+      <p:sp>
+        <p:nvSpPr>
+          <p:cNvPr id="10" name="TextBox 9"/>
+          <p:cNvSpPr txBox="1"/>
+          <p:nvPr/>
+        </p:nvSpPr>
+        <p:spPr>
+          <a:xfrm>
+            <a:off x="6858000" y="2788920"/>
+            <a:ext cx="4572000" cy="457200"/>
+          </a:xfrm>
+          <a:prstGeom prst="rect">
+            <a:avLst/>
+          </a:prstGeom>
+          <a:noFill/>
+        </p:spPr>
+        <p:txBody>
+          <a:bodyPr wrap="square">
+            <a:spAutoFit/>
+          </a:bodyPr>
+          <a:lstStyle/>
+          <a:p>
+            <a:pPr algn="l">
+              <a:spcAft>
+                <a:spcPts val="400"/>
+              </a:spcAft>
               <a:defRPr sz="1400" b="0">
                 <a:solidFill>
                   <a:srgbClr val="2D2240"/>
@@ -4316,21 +4319,21 @@
               </a:defRPr>
             </a:pPr>
             <a:r>
-              <a:t>Very large effect</a:t>
-            </a:r>
-          </a:p>
-        </p:txBody>
-      </p:sp>
-      <p:sp>
-        <p:nvSpPr>
-          <p:cNvPr id="10" name="Rectangle 9"/>
+              <a:t>Very large — futsal ball &gt;&gt;&gt; normal ball</a:t>
+            </a:r>
+          </a:p>
+        </p:txBody>
+      </p:sp>
+      <p:sp>
+        <p:nvSpPr>
+          <p:cNvPr id="11" name="Rectangle 10"/>
           <p:cNvSpPr/>
           <p:nvPr/>
         </p:nvSpPr>
         <p:spPr>
           <a:xfrm>
             <a:off x="6858000" y="3337560"/>
-            <a:ext cx="4572000" cy="7620"/>
+            <a:ext cx="4572000" cy="6350"/>
           </a:xfrm>
           <a:prstGeom prst="rect">
             <a:avLst/>
@@ -4366,7 +4369,7 @@
       </p:sp>
       <p:sp>
         <p:nvSpPr>
-          <p:cNvPr id="11" name="TextBox 10"/>
+          <p:cNvPr id="12" name="TextBox 11"/>
           <p:cNvSpPr txBox="1"/>
           <p:nvPr/>
         </p:nvSpPr>
@@ -4405,7 +4408,7 @@
       </p:sp>
       <p:sp>
         <p:nvSpPr>
-          <p:cNvPr id="12" name="TextBox 11"/>
+          <p:cNvPr id="13" name="TextBox 12"/>
           <p:cNvSpPr txBox="1"/>
           <p:nvPr/>
         </p:nvSpPr>
@@ -4444,7 +4447,7 @@
       </p:sp>
       <p:sp>
         <p:nvSpPr>
-          <p:cNvPr id="13" name="TextBox 12"/>
+          <p:cNvPr id="14" name="TextBox 13"/>
           <p:cNvSpPr txBox="1"/>
           <p:nvPr/>
         </p:nvSpPr>
@@ -4476,21 +4479,21 @@
               </a:defRPr>
             </a:pPr>
             <a:r>
-              <a:t>Interval crosses zero — direction is right, need more studies</a:t>
-            </a:r>
-          </a:p>
-        </p:txBody>
-      </p:sp>
-      <p:sp>
-        <p:nvSpPr>
-          <p:cNvPr id="14" name="Rectangle 13"/>
+              <a:t>Interval crosses zero — need more studies</a:t>
+            </a:r>
+          </a:p>
+        </p:txBody>
+      </p:sp>
+      <p:sp>
+        <p:nvSpPr>
+          <p:cNvPr id="15" name="Rectangle 14"/>
           <p:cNvSpPr/>
           <p:nvPr/>
         </p:nvSpPr>
         <p:spPr>
           <a:xfrm>
             <a:off x="6858000" y="4892040"/>
-            <a:ext cx="4572000" cy="7620"/>
+            <a:ext cx="4572000" cy="6350"/>
           </a:xfrm>
           <a:prstGeom prst="rect">
             <a:avLst/>
@@ -4526,7 +4529,7 @@
       </p:sp>
       <p:sp>
         <p:nvSpPr>
-          <p:cNvPr id="15" name="TextBox 14"/>
+          <p:cNvPr id="16" name="TextBox 15"/>
           <p:cNvSpPr txBox="1"/>
           <p:nvPr/>
         </p:nvSpPr>
@@ -4565,7 +4568,7 @@
       </p:sp>
       <p:sp>
         <p:nvSpPr>
-          <p:cNvPr id="16" name="TextBox 15"/>
+          <p:cNvPr id="17" name="TextBox 16"/>
           <p:cNvSpPr txBox="1"/>
           <p:nvPr/>
         </p:nvSpPr>
@@ -4604,7 +4607,7 @@
       </p:sp>
       <p:sp>
         <p:nvSpPr>
-          <p:cNvPr id="17" name="TextBox 16"/>
+          <p:cNvPr id="18" name="TextBox 17"/>
           <p:cNvSpPr txBox="1"/>
           <p:nvPr/>
         </p:nvSpPr>
@@ -4636,7 +4639,7 @@
               </a:defRPr>
             </a:pPr>
             <a:r>
-              <a:t>Very high — methods differ greatly → field still young</a:t>
+              <a:t>Very high — methods differ → field still young</a:t>
             </a:r>
           </a:p>
         </p:txBody>
@@ -4758,7 +4761,7 @@
         <p:spPr>
           <a:xfrm>
             <a:off x="731520" y="1005840"/>
-            <a:ext cx="3200400" cy="19050"/>
+            <a:ext cx="3200400" cy="15240"/>
           </a:xfrm>
           <a:prstGeom prst="rect">
             <a:avLst/>
@@ -4840,7 +4843,7 @@
         <p:spPr>
           <a:xfrm>
             <a:off x="1463040" y="1874519"/>
-            <a:ext cx="8686800" cy="1097280"/>
+            <a:ext cx="8686800" cy="347472"/>
           </a:xfrm>
           <a:prstGeom prst="rect">
             <a:avLst/>
@@ -4853,11 +4856,11 @@
           </a:bodyPr>
           <a:lstStyle/>
           <a:p>
-            <a:pPr>
-              <a:spcAft>
-                <a:spcPts val="600"/>
-              </a:spcAft>
-              <a:defRPr sz="1600">
+            <a:pPr algn="l">
+              <a:spcAft>
+                <a:spcPts val="400"/>
+              </a:spcAft>
+              <a:defRPr sz="1600" b="0">
                 <a:solidFill>
                   <a:srgbClr val="2D2240"/>
                 </a:solidFill>
@@ -4868,12 +4871,35 @@
               <a:t>SMD = 1.43 — very large effect</a:t>
             </a:r>
           </a:p>
-          <a:p>
-            <a:pPr>
-              <a:spcAft>
-                <a:spcPts val="600"/>
-              </a:spcAft>
-              <a:defRPr sz="1600">
+        </p:txBody>
+      </p:sp>
+      <p:sp>
+        <p:nvSpPr>
+          <p:cNvPr id="7" name="TextBox 6"/>
+          <p:cNvSpPr txBox="1"/>
+          <p:nvPr/>
+        </p:nvSpPr>
+        <p:spPr>
+          <a:xfrm>
+            <a:off x="1463040" y="2221991"/>
+            <a:ext cx="8686800" cy="347472"/>
+          </a:xfrm>
+          <a:prstGeom prst="rect">
+            <a:avLst/>
+          </a:prstGeom>
+          <a:noFill/>
+        </p:spPr>
+        <p:txBody>
+          <a:bodyPr wrap="square">
+            <a:spAutoFit/>
+          </a:bodyPr>
+          <a:lstStyle/>
+          <a:p>
+            <a:pPr algn="l">
+              <a:spcAft>
+                <a:spcPts val="400"/>
+              </a:spcAft>
+              <a:defRPr sz="1600" b="0">
                 <a:solidFill>
                   <a:srgbClr val="2D2240"/>
                 </a:solidFill>
@@ -4884,12 +4910,35 @@
               <a:t>Low-bounce ball → easier control → frees attention</a:t>
             </a:r>
           </a:p>
-          <a:p>
-            <a:pPr>
-              <a:spcAft>
-                <a:spcPts val="600"/>
-              </a:spcAft>
-              <a:defRPr sz="1600">
+        </p:txBody>
+      </p:sp>
+      <p:sp>
+        <p:nvSpPr>
+          <p:cNvPr id="8" name="TextBox 7"/>
+          <p:cNvSpPr txBox="1"/>
+          <p:nvPr/>
+        </p:nvSpPr>
+        <p:spPr>
+          <a:xfrm>
+            <a:off x="1463040" y="2569463"/>
+            <a:ext cx="8686800" cy="347472"/>
+          </a:xfrm>
+          <a:prstGeom prst="rect">
+            <a:avLst/>
+          </a:prstGeom>
+          <a:noFill/>
+        </p:spPr>
+        <p:txBody>
+          <a:bodyPr wrap="square">
+            <a:spAutoFit/>
+          </a:bodyPr>
+          <a:lstStyle/>
+          <a:p>
+            <a:pPr algn="l">
+              <a:spcAft>
+                <a:spcPts val="400"/>
+              </a:spcAft>
+              <a:defRPr sz="1600" b="0">
                 <a:solidFill>
                   <a:srgbClr val="2D2240"/>
                 </a:solidFill>
@@ -4904,14 +4953,14 @@
       </p:sp>
       <p:sp>
         <p:nvSpPr>
-          <p:cNvPr id="7" name="Rectangle 6"/>
+          <p:cNvPr id="9" name="Rectangle 8"/>
           <p:cNvSpPr/>
           <p:nvPr/>
         </p:nvSpPr>
         <p:spPr>
           <a:xfrm>
             <a:off x="1097280" y="2971800"/>
-            <a:ext cx="9601200" cy="7620"/>
+            <a:ext cx="9601200" cy="6350"/>
           </a:xfrm>
           <a:prstGeom prst="rect">
             <a:avLst/>
@@ -4947,7 +4996,7 @@
       </p:sp>
       <p:sp>
         <p:nvSpPr>
-          <p:cNvPr id="8" name="TextBox 7"/>
+          <p:cNvPr id="10" name="TextBox 9"/>
           <p:cNvSpPr txBox="1"/>
           <p:nvPr/>
         </p:nvSpPr>
@@ -4986,14 +5035,14 @@
       </p:sp>
       <p:sp>
         <p:nvSpPr>
-          <p:cNvPr id="9" name="TextBox 8"/>
+          <p:cNvPr id="11" name="TextBox 10"/>
           <p:cNvSpPr txBox="1"/>
           <p:nvPr/>
         </p:nvSpPr>
         <p:spPr>
           <a:xfrm>
             <a:off x="1463040" y="3657600"/>
-            <a:ext cx="8686800" cy="1097280"/>
+            <a:ext cx="8686800" cy="347472"/>
           </a:xfrm>
           <a:prstGeom prst="rect">
             <a:avLst/>
@@ -5006,11 +5055,11 @@
           </a:bodyPr>
           <a:lstStyle/>
           <a:p>
-            <a:pPr>
-              <a:spcAft>
-                <a:spcPts val="600"/>
-              </a:spcAft>
-              <a:defRPr sz="1600">
+            <a:pPr algn="l">
+              <a:spcAft>
+                <a:spcPts val="400"/>
+              </a:spcAft>
+              <a:defRPr sz="1600" b="0">
                 <a:solidFill>
                   <a:srgbClr val="2D2240"/>
                 </a:solidFill>
@@ -5021,12 +5070,35 @@
               <a:t>Field-based tests → futsal players FASTER</a:t>
             </a:r>
           </a:p>
-          <a:p>
-            <a:pPr>
-              <a:spcAft>
-                <a:spcPts val="600"/>
-              </a:spcAft>
-              <a:defRPr sz="1600">
+        </p:txBody>
+      </p:sp>
+      <p:sp>
+        <p:nvSpPr>
+          <p:cNvPr id="12" name="TextBox 11"/>
+          <p:cNvSpPr txBox="1"/>
+          <p:nvPr/>
+        </p:nvSpPr>
+        <p:spPr>
+          <a:xfrm>
+            <a:off x="1463040" y="4005072"/>
+            <a:ext cx="8686800" cy="347472"/>
+          </a:xfrm>
+          <a:prstGeom prst="rect">
+            <a:avLst/>
+          </a:prstGeom>
+          <a:noFill/>
+        </p:spPr>
+        <p:txBody>
+          <a:bodyPr wrap="square">
+            <a:spAutoFit/>
+          </a:bodyPr>
+          <a:lstStyle/>
+          <a:p>
+            <a:pPr algn="l">
+              <a:spcAft>
+                <a:spcPts val="400"/>
+              </a:spcAft>
+              <a:defRPr sz="1600" b="0">
                 <a:solidFill>
                   <a:srgbClr val="2D2240"/>
                 </a:solidFill>
@@ -5037,12 +5109,35 @@
               <a:t>Lab-based tests → futsal = or SLOWER</a:t>
             </a:r>
           </a:p>
-          <a:p>
-            <a:pPr>
-              <a:spcAft>
-                <a:spcPts val="600"/>
-              </a:spcAft>
-              <a:defRPr sz="1600">
+        </p:txBody>
+      </p:sp>
+      <p:sp>
+        <p:nvSpPr>
+          <p:cNvPr id="13" name="TextBox 12"/>
+          <p:cNvSpPr txBox="1"/>
+          <p:nvPr/>
+        </p:nvSpPr>
+        <p:spPr>
+          <a:xfrm>
+            <a:off x="1463040" y="4352544"/>
+            <a:ext cx="8686800" cy="347472"/>
+          </a:xfrm>
+          <a:prstGeom prst="rect">
+            <a:avLst/>
+          </a:prstGeom>
+          <a:noFill/>
+        </p:spPr>
+        <p:txBody>
+          <a:bodyPr wrap="square">
+            <a:spAutoFit/>
+          </a:bodyPr>
+          <a:lstStyle/>
+          <a:p>
+            <a:pPr algn="l">
+              <a:spcAft>
+                <a:spcPts val="400"/>
+              </a:spcAft>
+              <a:defRPr sz="1600" b="0">
                 <a:solidFill>
                   <a:srgbClr val="2D2240"/>
                 </a:solidFill>
@@ -5057,14 +5152,14 @@
       </p:sp>
       <p:sp>
         <p:nvSpPr>
-          <p:cNvPr id="10" name="Rectangle 9"/>
+          <p:cNvPr id="14" name="Rectangle 13"/>
           <p:cNvSpPr/>
           <p:nvPr/>
         </p:nvSpPr>
         <p:spPr>
           <a:xfrm>
             <a:off x="1097280" y="4754880"/>
-            <a:ext cx="9601200" cy="7620"/>
+            <a:ext cx="9601200" cy="6350"/>
           </a:xfrm>
           <a:prstGeom prst="rect">
             <a:avLst/>
@@ -5100,7 +5195,7 @@
       </p:sp>
       <p:sp>
         <p:nvSpPr>
-          <p:cNvPr id="11" name="TextBox 10"/>
+          <p:cNvPr id="15" name="TextBox 14"/>
           <p:cNvSpPr txBox="1"/>
           <p:nvPr/>
         </p:nvSpPr>
@@ -5139,14 +5234,14 @@
       </p:sp>
       <p:sp>
         <p:nvSpPr>
-          <p:cNvPr id="12" name="TextBox 11"/>
+          <p:cNvPr id="16" name="TextBox 15"/>
           <p:cNvSpPr txBox="1"/>
           <p:nvPr/>
         </p:nvSpPr>
         <p:spPr>
           <a:xfrm>
             <a:off x="1463040" y="5440680"/>
-            <a:ext cx="8686800" cy="1097280"/>
+            <a:ext cx="8686800" cy="347472"/>
           </a:xfrm>
           <a:prstGeom prst="rect">
             <a:avLst/>
@@ -5159,61 +5254,89 @@
           </a:bodyPr>
           <a:lstStyle/>
           <a:p>
-            <a:pPr>
-              <a:spcAft>
-                <a:spcPts val="600"/>
-              </a:spcAft>
-            </a:pPr>
-            <a:r>
-              <a:rPr b="1" sz="1600">
+            <a:pPr algn="l">
+              <a:spcAft>
+                <a:spcPts val="400"/>
+              </a:spcAft>
+              <a:defRPr sz="1600" b="0">
                 <a:solidFill>
                   <a:srgbClr val="2D2240"/>
                 </a:solidFill>
                 <a:latin typeface="Segoe UI"/>
-              </a:rPr>
-              <a:t>Futsal:</a:t>
-            </a:r>
-            <a:r>
-              <a:rPr sz="1600">
+              </a:defRPr>
+            </a:pPr>
+            <a:r>
+              <a:t>Futsal: success = close distance + high velocity</a:t>
+            </a:r>
+          </a:p>
+        </p:txBody>
+      </p:sp>
+      <p:sp>
+        <p:nvSpPr>
+          <p:cNvPr id="17" name="TextBox 16"/>
+          <p:cNvSpPr txBox="1"/>
+          <p:nvPr/>
+        </p:nvSpPr>
+        <p:spPr>
+          <a:xfrm>
+            <a:off x="1463040" y="5788152"/>
+            <a:ext cx="8686800" cy="347472"/>
+          </a:xfrm>
+          <a:prstGeom prst="rect">
+            <a:avLst/>
+          </a:prstGeom>
+          <a:noFill/>
+        </p:spPr>
+        <p:txBody>
+          <a:bodyPr wrap="square">
+            <a:spAutoFit/>
+          </a:bodyPr>
+          <a:lstStyle/>
+          <a:p>
+            <a:pPr algn="l">
+              <a:spcAft>
+                <a:spcPts val="400"/>
+              </a:spcAft>
+              <a:defRPr sz="1600" b="0">
                 <a:solidFill>
                   <a:srgbClr val="2D2240"/>
                 </a:solidFill>
                 <a:latin typeface="Segoe UI"/>
-              </a:rPr>
-              <a:t> success = close distance + high velocity</a:t>
-            </a:r>
-          </a:p>
-          <a:p>
-            <a:pPr>
-              <a:spcAft>
-                <a:spcPts val="600"/>
-              </a:spcAft>
-            </a:pPr>
-            <a:r>
-              <a:rPr b="1" sz="1600">
-                <a:solidFill>
-                  <a:srgbClr val="2D2240"/>
-                </a:solidFill>
-                <a:latin typeface="Segoe UI"/>
-              </a:rPr>
-              <a:t>Soccer:</a:t>
-            </a:r>
-            <a:r>
-              <a:rPr sz="1600">
-                <a:solidFill>
-                  <a:srgbClr val="2D2240"/>
-                </a:solidFill>
-                <a:latin typeface="Segoe UI"/>
-              </a:rPr>
-              <a:t> success = defender's reaction time</a:t>
-            </a:r>
-          </a:p>
-          <a:p>
-            <a:pPr>
-              <a:spcAft>
-                <a:spcPts val="600"/>
-              </a:spcAft>
-              <a:defRPr sz="1600">
+              </a:defRPr>
+            </a:pPr>
+            <a:r>
+              <a:t>Soccer: success = defender's reaction time</a:t>
+            </a:r>
+          </a:p>
+        </p:txBody>
+      </p:sp>
+      <p:sp>
+        <p:nvSpPr>
+          <p:cNvPr id="18" name="TextBox 17"/>
+          <p:cNvSpPr txBox="1"/>
+          <p:nvPr/>
+        </p:nvSpPr>
+        <p:spPr>
+          <a:xfrm>
+            <a:off x="1463040" y="6135624"/>
+            <a:ext cx="8686800" cy="347472"/>
+          </a:xfrm>
+          <a:prstGeom prst="rect">
+            <a:avLst/>
+          </a:prstGeom>
+          <a:noFill/>
+        </p:spPr>
+        <p:txBody>
+          <a:bodyPr wrap="square">
+            <a:spAutoFit/>
+          </a:bodyPr>
+          <a:lstStyle/>
+          <a:p>
+            <a:pPr algn="l">
+              <a:spcAft>
+                <a:spcPts val="400"/>
+              </a:spcAft>
+              <a:defRPr sz="1600" b="0">
                 <a:solidFill>
                   <a:srgbClr val="2D2240"/>
                 </a:solidFill>
@@ -5343,7 +5466,7 @@
         <p:spPr>
           <a:xfrm>
             <a:off x="731520" y="1005840"/>
-            <a:ext cx="3200400" cy="19050"/>
+            <a:ext cx="3200400" cy="15240"/>
           </a:xfrm>
           <a:prstGeom prst="rect">
             <a:avLst/>
@@ -5654,7 +5777,7 @@
         <p:spPr>
           <a:xfrm>
             <a:off x="6583680" y="1371600"/>
-            <a:ext cx="13716" cy="3657600"/>
+            <a:ext cx="13716" cy="4114800"/>
           </a:xfrm>
           <a:prstGeom prst="rect">
             <a:avLst/>
@@ -5844,7 +5967,7 @@
         <p:spPr>
           <a:xfrm>
             <a:off x="731520" y="1005840"/>
-            <a:ext cx="3200400" cy="19050"/>
+            <a:ext cx="3200400" cy="15240"/>
           </a:xfrm>
           <a:prstGeom prst="rect">
             <a:avLst/>
@@ -6067,7 +6190,7 @@
           <a:p>
             <a:pPr>
               <a:spcAft>
-                <a:spcPts val="600"/>
+                <a:spcPts val="500"/>
               </a:spcAft>
               <a:defRPr sz="1500">
                 <a:solidFill>
@@ -6083,7 +6206,7 @@
           <a:p>
             <a:pPr>
               <a:spcAft>
-                <a:spcPts val="600"/>
+                <a:spcPts val="500"/>
               </a:spcAft>
               <a:defRPr sz="1500">
                 <a:solidFill>
@@ -6099,7 +6222,7 @@
           <a:p>
             <a:pPr>
               <a:spcAft>
-                <a:spcPts val="600"/>
+                <a:spcPts val="500"/>
               </a:spcAft>
               <a:defRPr sz="1500">
                 <a:solidFill>
@@ -6115,7 +6238,7 @@
           <a:p>
             <a:pPr>
               <a:spcAft>
-                <a:spcPts val="600"/>
+                <a:spcPts val="500"/>
               </a:spcAft>
               <a:defRPr sz="1500">
                 <a:solidFill>
@@ -6131,7 +6254,7 @@
           <a:p>
             <a:pPr>
               <a:spcAft>
-                <a:spcPts val="600"/>
+                <a:spcPts val="500"/>
               </a:spcAft>
               <a:defRPr sz="1500">
                 <a:solidFill>
@@ -6147,7 +6270,7 @@
           <a:p>
             <a:pPr>
               <a:spcAft>
-                <a:spcPts val="600"/>
+                <a:spcPts val="500"/>
               </a:spcAft>
               <a:defRPr sz="1500">
                 <a:solidFill>
@@ -6157,7 +6280,7 @@
               </a:defRPr>
             </a:pPr>
             <a:r>
-              <a:t>Offside awareness · long passing · goalkeeper</a:t>
+              <a:t>Offside awareness · long passing · goalkeeper transition</a:t>
             </a:r>
           </a:p>
         </p:txBody>
@@ -6171,7 +6294,7 @@
         <p:spPr>
           <a:xfrm>
             <a:off x="6583680" y="1371600"/>
-            <a:ext cx="13716" cy="3657600"/>
+            <a:ext cx="13716" cy="4114800"/>
           </a:xfrm>
           <a:prstGeom prst="rect">
             <a:avLst/>
@@ -6390,7 +6513,7 @@
               </a:defRPr>
             </a:pPr>
             <a:r>
-              <a:t>From This Review → My Literature Review</a:t>
+              <a:t>Conclusion</a:t>
             </a:r>
           </a:p>
         </p:txBody>
@@ -6404,7 +6527,7 @@
         <p:spPr>
           <a:xfrm>
             <a:off x="731520" y="1005840"/>
-            <a:ext cx="3200400" cy="19050"/>
+            <a:ext cx="3200400" cy="15240"/>
           </a:xfrm>
           <a:prstGeom prst="rect">
             <a:avLst/>
@@ -6440,14 +6563,57 @@
       </p:sp>
       <p:sp>
         <p:nvSpPr>
-          <p:cNvPr id="5" name="TextBox 4"/>
+          <p:cNvPr id="5" name="Rectangle 4"/>
+          <p:cNvSpPr/>
+          <p:nvPr/>
+        </p:nvSpPr>
+        <p:spPr>
+          <a:xfrm>
+            <a:off x="731520" y="1371600"/>
+            <a:ext cx="10698480" cy="1371600"/>
+          </a:xfrm>
+          <a:prstGeom prst="rect">
+            <a:avLst/>
+          </a:prstGeom>
+          <a:solidFill>
+            <a:srgbClr val="EDE7F6"/>
+          </a:solidFill>
+          <a:ln>
+            <a:noFill/>
+          </a:ln>
+        </p:spPr>
+        <p:style>
+          <a:lnRef idx="1">
+            <a:schemeClr val="accent1"/>
+          </a:lnRef>
+          <a:fillRef idx="3">
+            <a:schemeClr val="accent1"/>
+          </a:fillRef>
+          <a:effectRef idx="2">
+            <a:schemeClr val="accent1"/>
+          </a:effectRef>
+          <a:fontRef idx="minor">
+            <a:schemeClr val="lt1"/>
+          </a:fontRef>
+        </p:style>
+        <p:txBody>
+          <a:bodyPr rtlCol="0" anchor="ctr"/>
+          <a:lstStyle/>
+          <a:p>
+            <a:pPr algn="ctr"/>
+          </a:p>
+        </p:txBody>
+      </p:sp>
+      <p:sp>
+        <p:nvSpPr>
+          <p:cNvPr id="6" name="TextBox 5"/>
           <p:cNvSpPr txBox="1"/>
           <p:nvPr/>
         </p:nvSpPr>
         <p:spPr>
           <a:xfrm>
-            <a:off x="731520" y="1097280"/>
-            <a:ext cx="5349240" cy="365760"/>
+            <a:off x="1097280" y="1463040"/>
+            <a:ext cx="10058400" cy="457200"/>
           </a:xfrm>
           <a:prstGeom prst="rect">
             <a:avLst/>
@@ -6464,29 +6630,29 @@
               <a:spcAft>
                 <a:spcPts val="400"/>
               </a:spcAft>
-              <a:defRPr sz="2000" b="1">
-                <a:solidFill>
-                  <a:srgbClr val="7E57C2"/>
-                </a:solidFill>
-                <a:latin typeface="Segoe UI"/>
-              </a:defRPr>
-            </a:pPr>
-            <a:r>
-              <a:t>Peña-Ardila (2026) tells us</a:t>
-            </a:r>
-          </a:p>
-        </p:txBody>
-      </p:sp>
-      <p:sp>
-        <p:nvSpPr>
-          <p:cNvPr id="6" name="TextBox 5"/>
+              <a:defRPr sz="1800" b="1">
+                <a:solidFill>
+                  <a:srgbClr val="5B3A8C"/>
+                </a:solidFill>
+                <a:latin typeface="Segoe UI"/>
+              </a:defRPr>
+            </a:pPr>
+            <a:r>
+              <a:t>Main Message of This Article</a:t>
+            </a:r>
+          </a:p>
+        </p:txBody>
+      </p:sp>
+      <p:sp>
+        <p:nvSpPr>
+          <p:cNvPr id="7" name="TextBox 6"/>
           <p:cNvSpPr txBox="1"/>
           <p:nvPr/>
         </p:nvSpPr>
         <p:spPr>
           <a:xfrm>
-            <a:off x="6080759" y="1097280"/>
-            <a:ext cx="5349240" cy="365760"/>
+            <a:off x="1097280" y="1920240"/>
+            <a:ext cx="10058400" cy="640080"/>
           </a:xfrm>
           <a:prstGeom prst="rect">
             <a:avLst/>
@@ -6503,7 +6669,46 @@
               <a:spcAft>
                 <a:spcPts val="400"/>
               </a:spcAft>
-              <a:defRPr sz="2000" b="1">
+              <a:defRPr sz="1700" b="0">
+                <a:solidFill>
+                  <a:srgbClr val="2D2240"/>
+                </a:solidFill>
+                <a:latin typeface="Segoe UI"/>
+              </a:defRPr>
+            </a:pPr>
+            <a:r>
+              <a:t>Futsal is a proven donor sport — but transfer is SKILL-SPECIFIC. Passing transfers strongly, speed depends on context, and dribbling does NOT automatically transfer. Current evidence is promising but limited: only 7 studies, no longitudinal data.</a:t>
+            </a:r>
+          </a:p>
+        </p:txBody>
+      </p:sp>
+      <p:sp>
+        <p:nvSpPr>
+          <p:cNvPr id="8" name="TextBox 7"/>
+          <p:cNvSpPr txBox="1"/>
+          <p:nvPr/>
+        </p:nvSpPr>
+        <p:spPr>
+          <a:xfrm>
+            <a:off x="3200400" y="3017520"/>
+            <a:ext cx="5760720" cy="457200"/>
+          </a:xfrm>
+          <a:prstGeom prst="rect">
+            <a:avLst/>
+          </a:prstGeom>
+          <a:noFill/>
+        </p:spPr>
+        <p:txBody>
+          <a:bodyPr wrap="square">
+            <a:spAutoFit/>
+          </a:bodyPr>
+          <a:lstStyle/>
+          <a:p>
+            <a:pPr algn="ctr">
+              <a:spcAft>
+                <a:spcPts val="400"/>
+              </a:spcAft>
+              <a:defRPr sz="1600" b="1">
                 <a:solidFill>
                   <a:srgbClr val="7E57C2"/>
                 </a:solidFill>
@@ -6511,6 +6716,84 @@
               </a:defRPr>
             </a:pPr>
             <a:r>
+              <a:t>→ What this means for my Literature Review →</a:t>
+            </a:r>
+          </a:p>
+        </p:txBody>
+      </p:sp>
+      <p:sp>
+        <p:nvSpPr>
+          <p:cNvPr id="9" name="TextBox 8"/>
+          <p:cNvSpPr txBox="1"/>
+          <p:nvPr/>
+        </p:nvSpPr>
+        <p:spPr>
+          <a:xfrm>
+            <a:off x="731520" y="3291840"/>
+            <a:ext cx="5349240" cy="365760"/>
+          </a:xfrm>
+          <a:prstGeom prst="rect">
+            <a:avLst/>
+          </a:prstGeom>
+          <a:noFill/>
+        </p:spPr>
+        <p:txBody>
+          <a:bodyPr wrap="square">
+            <a:spAutoFit/>
+          </a:bodyPr>
+          <a:lstStyle/>
+          <a:p>
+            <a:pPr algn="l">
+              <a:spcAft>
+                <a:spcPts val="400"/>
+              </a:spcAft>
+              <a:defRPr sz="1900" b="1">
+                <a:solidFill>
+                  <a:srgbClr val="7E57C2"/>
+                </a:solidFill>
+                <a:latin typeface="Segoe UI"/>
+              </a:defRPr>
+            </a:pPr>
+            <a:r>
+              <a:t>Peña-Ardila tells us</a:t>
+            </a:r>
+          </a:p>
+        </p:txBody>
+      </p:sp>
+      <p:sp>
+        <p:nvSpPr>
+          <p:cNvPr id="10" name="TextBox 9"/>
+          <p:cNvSpPr txBox="1"/>
+          <p:nvPr/>
+        </p:nvSpPr>
+        <p:spPr>
+          <a:xfrm>
+            <a:off x="6080759" y="3291840"/>
+            <a:ext cx="5349240" cy="365760"/>
+          </a:xfrm>
+          <a:prstGeom prst="rect">
+            <a:avLst/>
+          </a:prstGeom>
+          <a:noFill/>
+        </p:spPr>
+        <p:txBody>
+          <a:bodyPr wrap="square">
+            <a:spAutoFit/>
+          </a:bodyPr>
+          <a:lstStyle/>
+          <a:p>
+            <a:pPr algn="l">
+              <a:spcAft>
+                <a:spcPts val="400"/>
+              </a:spcAft>
+              <a:defRPr sz="1900" b="1">
+                <a:solidFill>
+                  <a:srgbClr val="7E57C2"/>
+                </a:solidFill>
+                <a:latin typeface="Segoe UI"/>
+              </a:defRPr>
+            </a:pPr>
+            <a:r>
               <a:t>My LR will explore</a:t>
             </a:r>
           </a:p>
@@ -6518,14 +6801,14 @@
       </p:sp>
       <p:sp>
         <p:nvSpPr>
-          <p:cNvPr id="7" name="Rectangle 6"/>
+          <p:cNvPr id="11" name="Rectangle 10"/>
           <p:cNvSpPr/>
           <p:nvPr/>
         </p:nvSpPr>
         <p:spPr>
           <a:xfrm>
-            <a:off x="6062472" y="1463040"/>
-            <a:ext cx="0" cy="19050"/>
+            <a:off x="6071616" y="3657600"/>
+            <a:ext cx="18288" cy="2743200"/>
           </a:xfrm>
           <a:prstGeom prst="rect">
             <a:avLst/>
@@ -6561,14 +6844,14 @@
       </p:sp>
       <p:sp>
         <p:nvSpPr>
-          <p:cNvPr id="8" name="TextBox 7"/>
+          <p:cNvPr id="12" name="TextBox 11"/>
           <p:cNvSpPr txBox="1"/>
           <p:nvPr/>
         </p:nvSpPr>
         <p:spPr>
           <a:xfrm>
-            <a:off x="731520" y="1463040"/>
-            <a:ext cx="5166359" cy="4114800"/>
+            <a:off x="731520" y="3657600"/>
+            <a:ext cx="5166359" cy="2743200"/>
           </a:xfrm>
           <a:prstGeom prst="rect">
             <a:avLst/>
@@ -6585,7 +6868,7 @@
               <a:spcAft>
                 <a:spcPts val="600"/>
               </a:spcAft>
-              <a:defRPr sz="1600">
+              <a:defRPr sz="1700">
                 <a:solidFill>
                   <a:srgbClr val="2D2240"/>
                 </a:solidFill>
@@ -6601,7 +6884,7 @@
               <a:spcAft>
                 <a:spcPts val="600"/>
               </a:spcAft>
-              <a:defRPr sz="1600">
+              <a:defRPr sz="1700">
                 <a:solidFill>
                   <a:srgbClr val="2D2240"/>
                 </a:solidFill>
@@ -6617,7 +6900,7 @@
               <a:spcAft>
                 <a:spcPts val="600"/>
               </a:spcAft>
-              <a:defRPr sz="1600">
+              <a:defRPr sz="1700">
                 <a:solidFill>
                   <a:srgbClr val="2D2240"/>
                 </a:solidFill>
@@ -6625,7 +6908,7 @@
               </a:defRPr>
             </a:pPr>
             <a:r>
-              <a:t>❌  DRIBBLING is sport-specific</a:t>
+              <a:t>❌  DRIBBLING: sport-specific</a:t>
             </a:r>
           </a:p>
           <a:p>
@@ -6633,7 +6916,7 @@
               <a:spcAft>
                 <a:spcPts val="600"/>
               </a:spcAft>
-              <a:defRPr sz="1600">
+              <a:defRPr sz="1700">
                 <a:solidFill>
                   <a:srgbClr val="2D2240"/>
                 </a:solidFill>
@@ -6641,37 +6924,21 @@
               </a:defRPr>
             </a:pPr>
             <a:r>
-              <a:t>🧠  Early futsal → better adult decision-making</a:t>
-            </a:r>
-          </a:p>
-          <a:p>
-            <a:pPr>
-              <a:spcAft>
-                <a:spcPts val="600"/>
-              </a:spcAft>
-              <a:defRPr sz="1600">
-                <a:solidFill>
-                  <a:srgbClr val="2D2240"/>
-                </a:solidFill>
-                <a:latin typeface="Segoe UI"/>
-              </a:defRPr>
-            </a:pPr>
-            <a:r>
-              <a:t>⚠️  Only 7 studies · No longitudinal data · No negative transfer</a:t>
-            </a:r>
-          </a:p>
-        </p:txBody>
-      </p:sp>
-      <p:sp>
-        <p:nvSpPr>
-          <p:cNvPr id="9" name="TextBox 8"/>
+              <a:t>⚠️  No longitudinal / No negative transfer</a:t>
+            </a:r>
+          </a:p>
+        </p:txBody>
+      </p:sp>
+      <p:sp>
+        <p:nvSpPr>
+          <p:cNvPr id="13" name="TextBox 12"/>
           <p:cNvSpPr txBox="1"/>
           <p:nvPr/>
         </p:nvSpPr>
         <p:spPr>
           <a:xfrm>
-            <a:off x="6126479" y="1463040"/>
-            <a:ext cx="5166359" cy="4114800"/>
+            <a:off x="6126479" y="3657600"/>
+            <a:ext cx="5166359" cy="2743200"/>
           </a:xfrm>
           <a:prstGeom prst="rect">
             <a:avLst/>
@@ -6688,24 +6955,31 @@
               <a:spcAft>
                 <a:spcPts val="600"/>
               </a:spcAft>
-            </a:pPr>
-            <a:r>
-              <a:rPr b="1" sz="1600">
+              <a:defRPr sz="1700">
                 <a:solidFill>
                   <a:srgbClr val="2D2240"/>
                 </a:solidFill>
                 <a:latin typeface="Segoe UI"/>
-              </a:rPr>
-              <a:t>THEME 1:</a:t>
-            </a:r>
-            <a:r>
-              <a:rPr sz="1600">
+              </a:defRPr>
+            </a:pPr>
+            <a:r>
+              <a:t>THEME 1: Technical skill transfer</a:t>
+            </a:r>
+          </a:p>
+          <a:p>
+            <a:pPr>
+              <a:spcAft>
+                <a:spcPts val="600"/>
+              </a:spcAft>
+              <a:defRPr sz="1700">
                 <a:solidFill>
                   <a:srgbClr val="2D2240"/>
                 </a:solidFill>
                 <a:latin typeface="Segoe UI"/>
-              </a:rPr>
-              <a:t> Technical skill transfer mechanisms</a:t>
+              </a:defRPr>
+            </a:pPr>
+            <a:r>
+              <a:t>THEME 2: Perceptual-cognitive adaptations</a:t>
             </a:r>
           </a:p>
           <a:p>
@@ -6713,172 +6987,31 @@
               <a:spcAft>
                 <a:spcPts val="600"/>
               </a:spcAft>
-            </a:pPr>
-            <a:r>
-              <a:rPr b="1" sz="1600">
+              <a:defRPr sz="1700">
                 <a:solidFill>
                   <a:srgbClr val="2D2240"/>
                 </a:solidFill>
                 <a:latin typeface="Segoe UI"/>
-              </a:rPr>
-              <a:t>THEME 2:</a:t>
-            </a:r>
-            <a:r>
-              <a:rPr sz="1600">
+              </a:defRPr>
+            </a:pPr>
+            <a:r>
+              <a:t>THEME 3: Talent development pathways</a:t>
+            </a:r>
+          </a:p>
+          <a:p>
+            <a:pPr>
+              <a:spcAft>
+                <a:spcPts val="600"/>
+              </a:spcAft>
+              <a:defRPr sz="1700">
                 <a:solidFill>
                   <a:srgbClr val="2D2240"/>
                 </a:solidFill>
                 <a:latin typeface="Segoe UI"/>
-              </a:rPr>
-              <a:t> Perceptual-cognitive adaptations</a:t>
-            </a:r>
-          </a:p>
-          <a:p>
-            <a:pPr>
-              <a:spcAft>
-                <a:spcPts val="600"/>
-              </a:spcAft>
-            </a:pPr>
-            <a:r>
-              <a:rPr b="1" sz="1600">
-                <a:solidFill>
-                  <a:srgbClr val="2D2240"/>
-                </a:solidFill>
-                <a:latin typeface="Segoe UI"/>
-              </a:rPr>
-              <a:t>THEME 3:</a:t>
-            </a:r>
-            <a:r>
-              <a:rPr sz="1600">
-                <a:solidFill>
-                  <a:srgbClr val="2D2240"/>
-                </a:solidFill>
-                <a:latin typeface="Segoe UI"/>
-              </a:rPr>
-              <a:t> Futsal in talent development pathways</a:t>
-            </a:r>
-          </a:p>
-          <a:p>
-            <a:pPr>
-              <a:spcAft>
-                <a:spcPts val="600"/>
-              </a:spcAft>
-            </a:pPr>
-            <a:r>
-              <a:rPr b="1" sz="1600">
-                <a:solidFill>
-                  <a:srgbClr val="2D2240"/>
-                </a:solidFill>
-                <a:latin typeface="Segoe UI"/>
-              </a:rPr>
-              <a:t>➕ Plus:</a:t>
-            </a:r>
-            <a:r>
-              <a:rPr sz="1600">
-                <a:solidFill>
-                  <a:srgbClr val="2D2240"/>
-                </a:solidFill>
-                <a:latin typeface="Segoe UI"/>
-              </a:rPr>
-              <a:t> What does NOT transfer and why?</a:t>
-            </a:r>
-          </a:p>
-          <a:p>
-            <a:pPr>
-              <a:spcAft>
-                <a:spcPts val="600"/>
-              </a:spcAft>
-              <a:defRPr sz="1600">
-                <a:solidFill>
-                  <a:srgbClr val="2D2240"/>
-                </a:solidFill>
-                <a:latin typeface="Segoe UI"/>
-              </a:defRPr>
-            </a:pPr>
-            <a:r>
-              <a:t>→ Identifying research gaps is itself a contribution</a:t>
-            </a:r>
-          </a:p>
-        </p:txBody>
-      </p:sp>
-      <p:sp>
-        <p:nvSpPr>
-          <p:cNvPr id="10" name="Rectangle 9"/>
-          <p:cNvSpPr/>
-          <p:nvPr/>
-        </p:nvSpPr>
-        <p:spPr>
-          <a:xfrm>
-            <a:off x="1371600" y="5943600"/>
-            <a:ext cx="9418320" cy="45720"/>
-          </a:xfrm>
-          <a:prstGeom prst="rect">
-            <a:avLst/>
-          </a:prstGeom>
-          <a:solidFill>
-            <a:srgbClr val="7E57C2"/>
-          </a:solidFill>
-          <a:ln>
-            <a:noFill/>
-          </a:ln>
-        </p:spPr>
-        <p:style>
-          <a:lnRef idx="1">
-            <a:schemeClr val="accent1"/>
-          </a:lnRef>
-          <a:fillRef idx="3">
-            <a:schemeClr val="accent1"/>
-          </a:fillRef>
-          <a:effectRef idx="2">
-            <a:schemeClr val="accent1"/>
-          </a:effectRef>
-          <a:fontRef idx="minor">
-            <a:schemeClr val="lt1"/>
-          </a:fontRef>
-        </p:style>
-        <p:txBody>
-          <a:bodyPr rtlCol="0" anchor="ctr"/>
-          <a:lstStyle/>
-          <a:p>
-            <a:pPr algn="ctr"/>
-          </a:p>
-        </p:txBody>
-      </p:sp>
-      <p:sp>
-        <p:nvSpPr>
-          <p:cNvPr id="11" name="TextBox 10"/>
-          <p:cNvSpPr txBox="1"/>
-          <p:nvPr/>
-        </p:nvSpPr>
-        <p:spPr>
-          <a:xfrm>
-            <a:off x="1371600" y="6080760"/>
-            <a:ext cx="9418320" cy="457200"/>
-          </a:xfrm>
-          <a:prstGeom prst="rect">
-            <a:avLst/>
-          </a:prstGeom>
-          <a:noFill/>
-        </p:spPr>
-        <p:txBody>
-          <a:bodyPr wrap="square">
-            <a:spAutoFit/>
-          </a:bodyPr>
-          <a:lstStyle/>
-          <a:p>
-            <a:pPr algn="ctr">
-              <a:spcAft>
-                <a:spcPts val="400"/>
-              </a:spcAft>
-              <a:defRPr sz="1700" b="0">
-                <a:solidFill>
-                  <a:srgbClr val="7E57C2"/>
-                </a:solidFill>
-                <a:latin typeface="Segoe UI"/>
-              </a:defRPr>
-            </a:pPr>
-            <a:r>
-              <a:t>This paper maps the KNOWN — my LR fills the UNKNOWN.</a:t>
+              </a:defRPr>
+            </a:pPr>
+            <a:r>
+              <a:t>➕ What does NOT transfer — the research gap</a:t>
             </a:r>
           </a:p>
         </p:txBody>

</xml_diff>

<commit_message>
Peña-Ardila PPT v4: keywords ONLY — no explanatory text, speaker fills in
</commit_message>
<xml_diff>
--- a/lr-slides/Presenting_Article_Pena-Ardila.pptx
+++ b/lr-slides/Presenting_Article_Pena-Ardila.pptx
@@ -3111,7 +3111,7 @@
         <p:spPr>
           <a:xfrm>
             <a:off x="0" y="0"/>
-            <a:ext cx="12191695" cy="109728"/>
+            <a:ext cx="12191695" cy="91440"/>
           </a:xfrm>
           <a:prstGeom prst="rect">
             <a:avLst/>
@@ -3153,8 +3153,8 @@
         </p:nvSpPr>
         <p:spPr>
           <a:xfrm>
-            <a:off x="1371600" y="914400"/>
-            <a:ext cx="9418320" cy="1280160"/>
+            <a:off x="1371600" y="1097280"/>
+            <a:ext cx="9418320" cy="1097280"/>
           </a:xfrm>
           <a:prstGeom prst="rect">
             <a:avLst/>
@@ -3196,8 +3196,8 @@
         </p:nvSpPr>
         <p:spPr>
           <a:xfrm>
-            <a:off x="1371600" y="2377440"/>
-            <a:ext cx="9418320" cy="731520"/>
+            <a:off x="1371600" y="2468880"/>
+            <a:ext cx="9418320" cy="548640"/>
           </a:xfrm>
           <a:prstGeom prst="rect">
             <a:avLst/>
@@ -3222,11 +3222,7 @@
               </a:defRPr>
             </a:pPr>
             <a:r>
-              <a:t>A Systematic Review &amp; Meta-Analysis</a:t>
-            </a:r>
-            <a:br/>
-            <a:r>
-              <a:t>of the 'Donor Sport' Concept</a:t>
+              <a:t>A Systematic Review &amp; Meta-Analysis of the 'Donor Sport' Concept</a:t>
             </a:r>
           </a:p>
         </p:txBody>
@@ -3239,8 +3235,8 @@
         </p:nvSpPr>
         <p:spPr>
           <a:xfrm>
-            <a:off x="1371600" y="3383280"/>
-            <a:ext cx="1828800" cy="36576"/>
+            <a:off x="1371600" y="3291840"/>
+            <a:ext cx="1828800" cy="27432"/>
           </a:xfrm>
           <a:prstGeom prst="rect">
             <a:avLst/>
@@ -3282,8 +3278,8 @@
         </p:nvSpPr>
         <p:spPr>
           <a:xfrm>
-            <a:off x="1371600" y="3657600"/>
-            <a:ext cx="9418320" cy="457200"/>
+            <a:off x="1371600" y="3566160"/>
+            <a:ext cx="9418320" cy="365760"/>
           </a:xfrm>
           <a:prstGeom prst="rect">
             <a:avLst/>
@@ -3365,7 +3361,7 @@
         <p:spPr>
           <a:xfrm>
             <a:off x="1371600" y="6309360"/>
-            <a:ext cx="9418320" cy="365760"/>
+            <a:ext cx="9418320" cy="274320"/>
           </a:xfrm>
           <a:prstGeom prst="rect">
             <a:avLst/>
@@ -3382,7 +3378,7 @@
               <a:spcAft>
                 <a:spcPts val="400"/>
               </a:spcAft>
-              <a:defRPr sz="1300" b="0">
+              <a:defRPr sz="1200" b="0">
                 <a:solidFill>
                   <a:srgbClr val="999999"/>
                 </a:solidFill>
@@ -3390,7 +3386,7 @@
               </a:defRPr>
             </a:pPr>
             <a:r>
-              <a:t>Analyst: HONGXIAN AN  |  Pre-sessional Programme  |  Presenting an Article  |  Week 2</a:t>
+              <a:t>Analyst: HONGXIAN AN  |  Presenting an Article  |  Week 2</a:t>
             </a:r>
           </a:p>
         </p:txBody>
@@ -3430,7 +3426,7 @@
         <p:spPr>
           <a:xfrm>
             <a:off x="0" y="0"/>
-            <a:ext cx="12191695" cy="73152"/>
+            <a:ext cx="12191695" cy="64008"/>
           </a:xfrm>
           <a:prstGeom prst="rect">
             <a:avLst/>
@@ -3473,7 +3469,7 @@
         <p:spPr>
           <a:xfrm>
             <a:off x="731520" y="365760"/>
-            <a:ext cx="10698480" cy="640080"/>
+            <a:ext cx="10058400" cy="548640"/>
           </a:xfrm>
           <a:prstGeom prst="rect">
             <a:avLst/>
@@ -3511,8 +3507,8 @@
         </p:nvSpPr>
         <p:spPr>
           <a:xfrm>
-            <a:off x="731520" y="1005840"/>
-            <a:ext cx="3200400" cy="15240"/>
+            <a:off x="731520" y="960120"/>
+            <a:ext cx="2743200" cy="31750"/>
           </a:xfrm>
           <a:prstGeom prst="rect">
             <a:avLst/>
@@ -3554,8 +3550,8 @@
         </p:nvSpPr>
         <p:spPr>
           <a:xfrm>
-            <a:off x="1097280" y="1463040"/>
-            <a:ext cx="9144000" cy="457200"/>
+            <a:off x="731520" y="1371600"/>
+            <a:ext cx="10515600" cy="4572000"/>
           </a:xfrm>
           <a:prstGeom prst="rect">
             <a:avLst/>
@@ -3568,50 +3564,11 @@
           </a:bodyPr>
           <a:lstStyle/>
           <a:p>
-            <a:pPr algn="l">
-              <a:spcAft>
-                <a:spcPts val="400"/>
-              </a:spcAft>
-              <a:defRPr sz="2200" b="1">
-                <a:solidFill>
-                  <a:srgbClr val="7E57C2"/>
-                </a:solidFill>
-                <a:latin typeface="Segoe UI"/>
-              </a:defRPr>
-            </a:pPr>
-            <a:r>
-              <a:t>Global relevance</a:t>
-            </a:r>
-          </a:p>
-        </p:txBody>
-      </p:sp>
-      <p:sp>
-        <p:nvSpPr>
-          <p:cNvPr id="6" name="TextBox 5"/>
-          <p:cNvSpPr txBox="1"/>
-          <p:nvPr/>
-        </p:nvSpPr>
-        <p:spPr>
-          <a:xfrm>
-            <a:off x="1097280" y="1920240"/>
-            <a:ext cx="9601200" cy="731520"/>
-          </a:xfrm>
-          <a:prstGeom prst="rect">
-            <a:avLst/>
-          </a:prstGeom>
-          <a:noFill/>
-        </p:spPr>
-        <p:txBody>
-          <a:bodyPr wrap="square">
-            <a:spAutoFit/>
-          </a:bodyPr>
-          <a:lstStyle/>
-          <a:p>
-            <a:pPr algn="l">
-              <a:spcAft>
-                <a:spcPts val="400"/>
-              </a:spcAft>
-              <a:defRPr sz="1700" b="0">
+            <a:pPr>
+              <a:spcAft>
+                <a:spcPts val="800"/>
+              </a:spcAft>
+              <a:defRPr sz="2000">
                 <a:solidFill>
                   <a:srgbClr val="2D2240"/>
                 </a:solidFill>
@@ -3621,122 +3578,13 @@
             <a:r>
               <a:t>Futsal = 60M+ participants worldwide (FIFA)</a:t>
             </a:r>
-            <a:br/>
-            <a:r>
-              <a:t>Brazilian greats — Pelé, Ronaldinho, Neymar — all credit futsal background</a:t>
-            </a:r>
-          </a:p>
-        </p:txBody>
-      </p:sp>
-      <p:sp>
-        <p:nvSpPr>
-          <p:cNvPr id="7" name="Rectangle 6"/>
-          <p:cNvSpPr/>
-          <p:nvPr/>
-        </p:nvSpPr>
-        <p:spPr>
-          <a:xfrm>
-            <a:off x="1097280" y="2880360"/>
-            <a:ext cx="9601200" cy="7620"/>
-          </a:xfrm>
-          <a:prstGeom prst="rect">
-            <a:avLst/>
-          </a:prstGeom>
-          <a:solidFill>
-            <a:srgbClr val="B39DDB"/>
-          </a:solidFill>
-          <a:ln>
-            <a:noFill/>
-          </a:ln>
-        </p:spPr>
-        <p:style>
-          <a:lnRef idx="1">
-            <a:schemeClr val="accent1"/>
-          </a:lnRef>
-          <a:fillRef idx="3">
-            <a:schemeClr val="accent1"/>
-          </a:fillRef>
-          <a:effectRef idx="2">
-            <a:schemeClr val="accent1"/>
-          </a:effectRef>
-          <a:fontRef idx="minor">
-            <a:schemeClr val="lt1"/>
-          </a:fontRef>
-        </p:style>
-        <p:txBody>
-          <a:bodyPr rtlCol="0" anchor="ctr"/>
-          <a:lstStyle/>
-          <a:p>
-            <a:pPr algn="ctr"/>
-          </a:p>
-        </p:txBody>
-      </p:sp>
-      <p:sp>
-        <p:nvSpPr>
-          <p:cNvPr id="8" name="TextBox 7"/>
-          <p:cNvSpPr txBox="1"/>
-          <p:nvPr/>
-        </p:nvSpPr>
-        <p:spPr>
-          <a:xfrm>
-            <a:off x="1097280" y="3154680"/>
-            <a:ext cx="9144000" cy="457200"/>
-          </a:xfrm>
-          <a:prstGeom prst="rect">
-            <a:avLst/>
-          </a:prstGeom>
-          <a:noFill/>
-        </p:spPr>
-        <p:txBody>
-          <a:bodyPr wrap="square">
-            <a:spAutoFit/>
-          </a:bodyPr>
-          <a:lstStyle/>
-          <a:p>
-            <a:pPr algn="l">
-              <a:spcAft>
-                <a:spcPts val="400"/>
-              </a:spcAft>
-              <a:defRPr sz="2200" b="1">
-                <a:solidFill>
-                  <a:srgbClr val="7E57C2"/>
-                </a:solidFill>
-                <a:latin typeface="Segoe UI"/>
-              </a:defRPr>
-            </a:pPr>
-            <a:r>
-              <a:t>Concept widely believed, rarely tested</a:t>
-            </a:r>
-          </a:p>
-        </p:txBody>
-      </p:sp>
-      <p:sp>
-        <p:nvSpPr>
-          <p:cNvPr id="9" name="TextBox 8"/>
-          <p:cNvSpPr txBox="1"/>
-          <p:nvPr/>
-        </p:nvSpPr>
-        <p:spPr>
-          <a:xfrm>
-            <a:off x="1097280" y="3611880"/>
-            <a:ext cx="9601200" cy="731520"/>
-          </a:xfrm>
-          <a:prstGeom prst="rect">
-            <a:avLst/>
-          </a:prstGeom>
-          <a:noFill/>
-        </p:spPr>
-        <p:txBody>
-          <a:bodyPr wrap="square">
-            <a:spAutoFit/>
-          </a:bodyPr>
-          <a:lstStyle/>
-          <a:p>
-            <a:pPr algn="l">
-              <a:spcAft>
-                <a:spcPts val="400"/>
-              </a:spcAft>
-              <a:defRPr sz="1700" b="0">
+          </a:p>
+          <a:p>
+            <a:pPr>
+              <a:spcAft>
+                <a:spcPts val="800"/>
+              </a:spcAft>
+              <a:defRPr sz="2000">
                 <a:solidFill>
                   <a:srgbClr val="2D2240"/>
                 </a:solidFill>
@@ -3744,124 +3592,15 @@
               </a:defRPr>
             </a:pPr>
             <a:r>
-              <a:t>Donor sport idea used in coaching for decades</a:t>
-            </a:r>
-            <a:br/>
-            <a:r>
-              <a:t>But empirical evidence is fragmented — this review tests it with numbers</a:t>
-            </a:r>
-          </a:p>
-        </p:txBody>
-      </p:sp>
-      <p:sp>
-        <p:nvSpPr>
-          <p:cNvPr id="10" name="Rectangle 9"/>
-          <p:cNvSpPr/>
-          <p:nvPr/>
-        </p:nvSpPr>
-        <p:spPr>
-          <a:xfrm>
-            <a:off x="1097280" y="4572000"/>
-            <a:ext cx="9601200" cy="7620"/>
-          </a:xfrm>
-          <a:prstGeom prst="rect">
-            <a:avLst/>
-          </a:prstGeom>
-          <a:solidFill>
-            <a:srgbClr val="B39DDB"/>
-          </a:solidFill>
-          <a:ln>
-            <a:noFill/>
-          </a:ln>
-        </p:spPr>
-        <p:style>
-          <a:lnRef idx="1">
-            <a:schemeClr val="accent1"/>
-          </a:lnRef>
-          <a:fillRef idx="3">
-            <a:schemeClr val="accent1"/>
-          </a:fillRef>
-          <a:effectRef idx="2">
-            <a:schemeClr val="accent1"/>
-          </a:effectRef>
-          <a:fontRef idx="minor">
-            <a:schemeClr val="lt1"/>
-          </a:fontRef>
-        </p:style>
-        <p:txBody>
-          <a:bodyPr rtlCol="0" anchor="ctr"/>
-          <a:lstStyle/>
-          <a:p>
-            <a:pPr algn="ctr"/>
-          </a:p>
-        </p:txBody>
-      </p:sp>
-      <p:sp>
-        <p:nvSpPr>
-          <p:cNvPr id="11" name="TextBox 10"/>
-          <p:cNvSpPr txBox="1"/>
-          <p:nvPr/>
-        </p:nvSpPr>
-        <p:spPr>
-          <a:xfrm>
-            <a:off x="1097280" y="4846320"/>
-            <a:ext cx="9144000" cy="457200"/>
-          </a:xfrm>
-          <a:prstGeom prst="rect">
-            <a:avLst/>
-          </a:prstGeom>
-          <a:noFill/>
-        </p:spPr>
-        <p:txBody>
-          <a:bodyPr wrap="square">
-            <a:spAutoFit/>
-          </a:bodyPr>
-          <a:lstStyle/>
-          <a:p>
-            <a:pPr algn="l">
-              <a:spcAft>
-                <a:spcPts val="400"/>
-              </a:spcAft>
-              <a:defRPr sz="2200" b="1">
-                <a:solidFill>
-                  <a:srgbClr val="7E57C2"/>
-                </a:solidFill>
-                <a:latin typeface="Segoe UI"/>
-              </a:defRPr>
-            </a:pPr>
-            <a:r>
-              <a:t>Talent development stakes</a:t>
-            </a:r>
-          </a:p>
-        </p:txBody>
-      </p:sp>
-      <p:sp>
-        <p:nvSpPr>
-          <p:cNvPr id="12" name="TextBox 11"/>
-          <p:cNvSpPr txBox="1"/>
-          <p:nvPr/>
-        </p:nvSpPr>
-        <p:spPr>
-          <a:xfrm>
-            <a:off x="1097280" y="5303520"/>
-            <a:ext cx="9601200" cy="731520"/>
-          </a:xfrm>
-          <a:prstGeom prst="rect">
-            <a:avLst/>
-          </a:prstGeom>
-          <a:noFill/>
-        </p:spPr>
-        <p:txBody>
-          <a:bodyPr wrap="square">
-            <a:spAutoFit/>
-          </a:bodyPr>
-          <a:lstStyle/>
-          <a:p>
-            <a:pPr algn="l">
-              <a:spcAft>
-                <a:spcPts val="400"/>
-              </a:spcAft>
-              <a:defRPr sz="1700" b="0">
+              <a:t>Pelé · Ronaldinho · Neymar → all credit futsal background</a:t>
+            </a:r>
+          </a:p>
+          <a:p>
+            <a:pPr>
+              <a:spcAft>
+                <a:spcPts val="800"/>
+              </a:spcAft>
+              <a:defRPr sz="2000">
                 <a:solidFill>
                   <a:srgbClr val="2D2240"/>
                 </a:solidFill>
@@ -3869,11 +3608,39 @@
               </a:defRPr>
             </a:pPr>
             <a:r>
-              <a:t>Early diversification vs. early specialization debate</a:t>
-            </a:r>
-            <a:br/>
-            <a:r>
-              <a:t>Practical guidance coaches need — what transfers, what doesn't</a:t>
+              <a:t>Donor sport concept: decades of coaching belief, minimal empirical testing</a:t>
+            </a:r>
+          </a:p>
+          <a:p>
+            <a:pPr>
+              <a:spcAft>
+                <a:spcPts val="800"/>
+              </a:spcAft>
+              <a:defRPr sz="2000">
+                <a:solidFill>
+                  <a:srgbClr val="2D2240"/>
+                </a:solidFill>
+                <a:latin typeface="Segoe UI"/>
+              </a:defRPr>
+            </a:pPr>
+            <a:r>
+              <a:t>First quantitative synthesis of futsal-to-soccer transfer</a:t>
+            </a:r>
+          </a:p>
+          <a:p>
+            <a:pPr>
+              <a:spcAft>
+                <a:spcPts val="800"/>
+              </a:spcAft>
+              <a:defRPr sz="2000">
+                <a:solidFill>
+                  <a:srgbClr val="2D2240"/>
+                </a:solidFill>
+                <a:latin typeface="Segoe UI"/>
+              </a:defRPr>
+            </a:pPr>
+            <a:r>
+              <a:t>Early diversification vs. early specialization — stakes for talent development</a:t>
             </a:r>
           </a:p>
         </p:txBody>
@@ -3913,7 +3680,7 @@
         <p:spPr>
           <a:xfrm>
             <a:off x="0" y="0"/>
-            <a:ext cx="12191695" cy="73152"/>
+            <a:ext cx="12191695" cy="64008"/>
           </a:xfrm>
           <a:prstGeom prst="rect">
             <a:avLst/>
@@ -3956,7 +3723,7 @@
         <p:spPr>
           <a:xfrm>
             <a:off x="731520" y="365760"/>
-            <a:ext cx="10698480" cy="640080"/>
+            <a:ext cx="10058400" cy="548640"/>
           </a:xfrm>
           <a:prstGeom prst="rect">
             <a:avLst/>
@@ -3981,7 +3748,7 @@
               </a:defRPr>
             </a:pPr>
             <a:r>
-              <a:t>How Was It Done?</a:t>
+              <a:t>Method</a:t>
             </a:r>
           </a:p>
         </p:txBody>
@@ -3994,8 +3761,8 @@
         </p:nvSpPr>
         <p:spPr>
           <a:xfrm>
-            <a:off x="731520" y="1005840"/>
-            <a:ext cx="3200400" cy="15240"/>
+            <a:off x="731520" y="960120"/>
+            <a:ext cx="2743200" cy="31750"/>
           </a:xfrm>
           <a:prstGeom prst="rect">
             <a:avLst/>
@@ -4038,7 +3805,7 @@
         <p:spPr>
           <a:xfrm>
             <a:off x="731520" y="1371600"/>
-            <a:ext cx="5486400" cy="4114800"/>
+            <a:ext cx="5303520" cy="4114800"/>
           </a:xfrm>
           <a:prstGeom prst="rect">
             <a:avLst/>
@@ -4051,47 +3818,27 @@
           </a:bodyPr>
           <a:lstStyle/>
           <a:p>
-            <a:pPr algn="l">
-              <a:spcAft>
-                <a:spcPts val="400"/>
-              </a:spcAft>
-              <a:defRPr sz="1700" b="0">
+            <a:pPr>
+              <a:spcAft>
+                <a:spcPts val="800"/>
+              </a:spcAft>
+              <a:defRPr sz="1800">
                 <a:solidFill>
                   <a:srgbClr val="2D2240"/>
                 </a:solidFill>
                 <a:latin typeface="Segoe UI"/>
               </a:defRPr>
             </a:pPr>
-          </a:p>
-        </p:txBody>
-      </p:sp>
-      <p:sp>
-        <p:nvSpPr>
-          <p:cNvPr id="6" name="TextBox 5"/>
-          <p:cNvSpPr txBox="1"/>
-          <p:nvPr/>
-        </p:nvSpPr>
-        <p:spPr>
-          <a:xfrm>
-            <a:off x="731520" y="1371600"/>
-            <a:ext cx="5486400" cy="4114800"/>
-          </a:xfrm>
-          <a:prstGeom prst="rect">
-            <a:avLst/>
-          </a:prstGeom>
-          <a:noFill/>
-        </p:spPr>
-        <p:txBody>
-          <a:bodyPr wrap="square">
-            <a:spAutoFit/>
-          </a:bodyPr>
-          <a:lstStyle/>
+            <a:r>
+              <a:t>PRISMA 2020</a:t>
+            </a:r>
+          </a:p>
           <a:p>
             <a:pPr>
               <a:spcAft>
-                <a:spcPts val="600"/>
-              </a:spcAft>
-              <a:defRPr sz="1700">
+                <a:spcPts val="800"/>
+              </a:spcAft>
+              <a:defRPr sz="1800">
                 <a:solidFill>
                   <a:srgbClr val="2D2240"/>
                 </a:solidFill>
@@ -4099,15 +3846,15 @@
               </a:defRPr>
             </a:pPr>
             <a:r>
-              <a:t>Guideline: PRISMA 2020</a:t>
+              <a:t>3 databases: Scopus · ScienceDirect · WoS</a:t>
             </a:r>
           </a:p>
           <a:p>
             <a:pPr>
               <a:spcAft>
-                <a:spcPts val="600"/>
-              </a:spcAft>
-              <a:defRPr sz="1700">
+                <a:spcPts val="800"/>
+              </a:spcAft>
+              <a:defRPr sz="1800">
                 <a:solidFill>
                   <a:srgbClr val="2D2240"/>
                 </a:solidFill>
@@ -4115,15 +3862,15 @@
               </a:defRPr>
             </a:pPr>
             <a:r>
-              <a:t>Databases: Scopus · ScienceDirect · Web of Science</a:t>
+              <a:t>780 → 683 → 38 → 7 studies</a:t>
             </a:r>
           </a:p>
           <a:p>
             <a:pPr>
               <a:spcAft>
-                <a:spcPts val="600"/>
-              </a:spcAft>
-              <a:defRPr sz="1700">
+                <a:spcPts val="800"/>
+              </a:spcAft>
+              <a:defRPr sz="1800">
                 <a:solidFill>
                   <a:srgbClr val="2D2240"/>
                 </a:solidFill>
@@ -4131,15 +3878,15 @@
               </a:defRPr>
             </a:pPr>
             <a:r>
-              <a:t>Screening: 780 → 683 (dedup) → 38 (full-text) → 7 studies</a:t>
+              <a:t>PICO(S) criteria</a:t>
             </a:r>
           </a:p>
           <a:p>
             <a:pPr>
               <a:spcAft>
-                <a:spcPts val="600"/>
-              </a:spcAft>
-              <a:defRPr sz="1700">
+                <a:spcPts val="800"/>
+              </a:spcAft>
+              <a:defRPr sz="1800">
                 <a:solidFill>
                   <a:srgbClr val="2D2240"/>
                 </a:solidFill>
@@ -4147,193 +3894,21 @@
               </a:defRPr>
             </a:pPr>
             <a:r>
-              <a:t>Criteria: PICO(S) — population, intervention, comparison, outcome</a:t>
-            </a:r>
-          </a:p>
-          <a:p>
-            <a:pPr>
-              <a:spcAft>
-                <a:spcPts val="600"/>
-              </a:spcAft>
-              <a:defRPr sz="1700">
-                <a:solidFill>
-                  <a:srgbClr val="2D2240"/>
-                </a:solidFill>
-                <a:latin typeface="Segoe UI"/>
-              </a:defRPr>
-            </a:pPr>
-            <a:r>
-              <a:t>Analysis: Random-effects meta-analysis · Hedges' g · I²</a:t>
-            </a:r>
-          </a:p>
-        </p:txBody>
-      </p:sp>
-      <p:sp>
-        <p:nvSpPr>
-          <p:cNvPr id="7" name="TextBox 6"/>
-          <p:cNvSpPr txBox="1"/>
-          <p:nvPr/>
-        </p:nvSpPr>
-        <p:spPr>
-          <a:xfrm>
-            <a:off x="6858000" y="1371600"/>
-            <a:ext cx="4572000" cy="457200"/>
-          </a:xfrm>
-          <a:prstGeom prst="rect">
-            <a:avLst/>
-          </a:prstGeom>
-          <a:noFill/>
-        </p:spPr>
-        <p:txBody>
-          <a:bodyPr wrap="square">
-            <a:spAutoFit/>
-          </a:bodyPr>
-          <a:lstStyle/>
-          <a:p>
-            <a:pPr algn="l">
-              <a:spcAft>
-                <a:spcPts val="400"/>
-              </a:spcAft>
-              <a:defRPr sz="1800" b="1">
-                <a:solidFill>
-                  <a:srgbClr val="7E57C2"/>
-                </a:solidFill>
-                <a:latin typeface="Segoe UI"/>
-              </a:defRPr>
-            </a:pPr>
-            <a:r>
-              <a:t>Key Numbers at a Glance</a:t>
-            </a:r>
-          </a:p>
-        </p:txBody>
-      </p:sp>
-      <p:sp>
-        <p:nvSpPr>
-          <p:cNvPr id="8" name="TextBox 7"/>
-          <p:cNvSpPr txBox="1"/>
-          <p:nvPr/>
-        </p:nvSpPr>
-        <p:spPr>
-          <a:xfrm>
-            <a:off x="6858000" y="2011680"/>
-            <a:ext cx="4572000" cy="365760"/>
-          </a:xfrm>
-          <a:prstGeom prst="rect">
-            <a:avLst/>
-          </a:prstGeom>
-          <a:noFill/>
-        </p:spPr>
-        <p:txBody>
-          <a:bodyPr wrap="square">
-            <a:spAutoFit/>
-          </a:bodyPr>
-          <a:lstStyle/>
-          <a:p>
-            <a:pPr algn="l">
-              <a:spcAft>
-                <a:spcPts val="400"/>
-              </a:spcAft>
-              <a:defRPr sz="1400" b="0">
-                <a:solidFill>
-                  <a:srgbClr val="999999"/>
-                </a:solidFill>
-                <a:latin typeface="Segoe UI"/>
-              </a:defRPr>
-            </a:pPr>
-            <a:r>
-              <a:t>SMD (Effect Size)</a:t>
-            </a:r>
-          </a:p>
-        </p:txBody>
-      </p:sp>
-      <p:sp>
-        <p:nvSpPr>
-          <p:cNvPr id="9" name="TextBox 8"/>
-          <p:cNvSpPr txBox="1"/>
-          <p:nvPr/>
-        </p:nvSpPr>
-        <p:spPr>
-          <a:xfrm>
-            <a:off x="6858000" y="2331720"/>
-            <a:ext cx="4572000" cy="457200"/>
-          </a:xfrm>
-          <a:prstGeom prst="rect">
-            <a:avLst/>
-          </a:prstGeom>
-          <a:noFill/>
-        </p:spPr>
-        <p:txBody>
-          <a:bodyPr wrap="square">
-            <a:spAutoFit/>
-          </a:bodyPr>
-          <a:lstStyle/>
-          <a:p>
-            <a:pPr algn="l">
-              <a:spcAft>
-                <a:spcPts val="400"/>
-              </a:spcAft>
-              <a:defRPr sz="2400" b="1">
-                <a:solidFill>
-                  <a:srgbClr val="2E7D32"/>
-                </a:solidFill>
-                <a:latin typeface="Segoe UI"/>
-              </a:defRPr>
-            </a:pPr>
-            <a:r>
-              <a:t>1.43</a:t>
-            </a:r>
-          </a:p>
-        </p:txBody>
-      </p:sp>
-      <p:sp>
-        <p:nvSpPr>
-          <p:cNvPr id="10" name="TextBox 9"/>
-          <p:cNvSpPr txBox="1"/>
-          <p:nvPr/>
-        </p:nvSpPr>
-        <p:spPr>
-          <a:xfrm>
-            <a:off x="6858000" y="2788920"/>
-            <a:ext cx="4572000" cy="457200"/>
-          </a:xfrm>
-          <a:prstGeom prst="rect">
-            <a:avLst/>
-          </a:prstGeom>
-          <a:noFill/>
-        </p:spPr>
-        <p:txBody>
-          <a:bodyPr wrap="square">
-            <a:spAutoFit/>
-          </a:bodyPr>
-          <a:lstStyle/>
-          <a:p>
-            <a:pPr algn="l">
-              <a:spcAft>
-                <a:spcPts val="400"/>
-              </a:spcAft>
-              <a:defRPr sz="1400" b="0">
-                <a:solidFill>
-                  <a:srgbClr val="2D2240"/>
-                </a:solidFill>
-                <a:latin typeface="Segoe UI"/>
-              </a:defRPr>
-            </a:pPr>
-            <a:r>
-              <a:t>Very large — futsal ball &gt;&gt;&gt; normal ball</a:t>
-            </a:r>
-          </a:p>
-        </p:txBody>
-      </p:sp>
-      <p:sp>
-        <p:nvSpPr>
-          <p:cNvPr id="11" name="Rectangle 10"/>
+              <a:t>Random-effects meta-analysis · Hedges' g · I²</a:t>
+            </a:r>
+          </a:p>
+        </p:txBody>
+      </p:sp>
+      <p:sp>
+        <p:nvSpPr>
+          <p:cNvPr id="6" name="Rectangle 5"/>
           <p:cNvSpPr/>
           <p:nvPr/>
         </p:nvSpPr>
         <p:spPr>
           <a:xfrm>
-            <a:off x="6858000" y="3337560"/>
-            <a:ext cx="4572000" cy="6350"/>
+            <a:off x="6583680" y="1371600"/>
+            <a:ext cx="19050" cy="4572000"/>
           </a:xfrm>
           <a:prstGeom prst="rect">
             <a:avLst/>
@@ -4369,14 +3944,14 @@
       </p:sp>
       <p:sp>
         <p:nvSpPr>
-          <p:cNvPr id="12" name="TextBox 11"/>
+          <p:cNvPr id="7" name="TextBox 6"/>
           <p:cNvSpPr txBox="1"/>
           <p:nvPr/>
         </p:nvSpPr>
         <p:spPr>
           <a:xfrm>
-            <a:off x="6858000" y="3566160"/>
-            <a:ext cx="4572000" cy="365760"/>
+            <a:off x="7132320" y="1371600"/>
+            <a:ext cx="4389120" cy="365760"/>
           </a:xfrm>
           <a:prstGeom prst="rect">
             <a:avLst/>
@@ -4401,21 +3976,21 @@
               </a:defRPr>
             </a:pPr>
             <a:r>
-              <a:t>95% CI (Reliability)</a:t>
-            </a:r>
-          </a:p>
-        </p:txBody>
-      </p:sp>
-      <p:sp>
-        <p:nvSpPr>
-          <p:cNvPr id="13" name="TextBox 12"/>
+              <a:t>SMD</a:t>
+            </a:r>
+          </a:p>
+        </p:txBody>
+      </p:sp>
+      <p:sp>
+        <p:nvSpPr>
+          <p:cNvPr id="8" name="TextBox 7"/>
           <p:cNvSpPr txBox="1"/>
           <p:nvPr/>
         </p:nvSpPr>
         <p:spPr>
           <a:xfrm>
-            <a:off x="6858000" y="3886200"/>
-            <a:ext cx="4572000" cy="457200"/>
+            <a:off x="7132320" y="1645920"/>
+            <a:ext cx="4389120" cy="548640"/>
           </a:xfrm>
           <a:prstGeom prst="rect">
             <a:avLst/>
@@ -4432,29 +4007,29 @@
               <a:spcAft>
                 <a:spcPts val="400"/>
               </a:spcAft>
-              <a:defRPr sz="2400" b="1">
-                <a:solidFill>
-                  <a:srgbClr val="E65100"/>
-                </a:solidFill>
-                <a:latin typeface="Segoe UI"/>
-              </a:defRPr>
-            </a:pPr>
-            <a:r>
-              <a:t>−0.16 ~ 3.03</a:t>
-            </a:r>
-          </a:p>
-        </p:txBody>
-      </p:sp>
-      <p:sp>
-        <p:nvSpPr>
-          <p:cNvPr id="14" name="TextBox 13"/>
+              <a:defRPr sz="3000" b="1">
+                <a:solidFill>
+                  <a:srgbClr val="2E7D32"/>
+                </a:solidFill>
+                <a:latin typeface="Segoe UI"/>
+              </a:defRPr>
+            </a:pPr>
+            <a:r>
+              <a:t>1.43</a:t>
+            </a:r>
+          </a:p>
+        </p:txBody>
+      </p:sp>
+      <p:sp>
+        <p:nvSpPr>
+          <p:cNvPr id="9" name="TextBox 8"/>
           <p:cNvSpPr txBox="1"/>
           <p:nvPr/>
         </p:nvSpPr>
         <p:spPr>
           <a:xfrm>
-            <a:off x="6858000" y="4343400"/>
-            <a:ext cx="4572000" cy="457200"/>
+            <a:off x="7132320" y="2468880"/>
+            <a:ext cx="4389120" cy="365760"/>
           </a:xfrm>
           <a:prstGeom prst="rect">
             <a:avLst/>
@@ -4473,70 +4048,27 @@
               </a:spcAft>
               <a:defRPr sz="1400" b="0">
                 <a:solidFill>
-                  <a:srgbClr val="2D2240"/>
-                </a:solidFill>
-                <a:latin typeface="Segoe UI"/>
-              </a:defRPr>
-            </a:pPr>
-            <a:r>
-              <a:t>Interval crosses zero — need more studies</a:t>
-            </a:r>
-          </a:p>
-        </p:txBody>
-      </p:sp>
-      <p:sp>
-        <p:nvSpPr>
-          <p:cNvPr id="15" name="Rectangle 14"/>
-          <p:cNvSpPr/>
-          <p:nvPr/>
-        </p:nvSpPr>
-        <p:spPr>
-          <a:xfrm>
-            <a:off x="6858000" y="4892040"/>
-            <a:ext cx="4572000" cy="6350"/>
-          </a:xfrm>
-          <a:prstGeom prst="rect">
-            <a:avLst/>
-          </a:prstGeom>
-          <a:solidFill>
-            <a:srgbClr val="B39DDB"/>
-          </a:solidFill>
-          <a:ln>
-            <a:noFill/>
-          </a:ln>
-        </p:spPr>
-        <p:style>
-          <a:lnRef idx="1">
-            <a:schemeClr val="accent1"/>
-          </a:lnRef>
-          <a:fillRef idx="3">
-            <a:schemeClr val="accent1"/>
-          </a:fillRef>
-          <a:effectRef idx="2">
-            <a:schemeClr val="accent1"/>
-          </a:effectRef>
-          <a:fontRef idx="minor">
-            <a:schemeClr val="lt1"/>
-          </a:fontRef>
-        </p:style>
-        <p:txBody>
-          <a:bodyPr rtlCol="0" anchor="ctr"/>
-          <a:lstStyle/>
-          <a:p>
-            <a:pPr algn="ctr"/>
-          </a:p>
-        </p:txBody>
-      </p:sp>
-      <p:sp>
-        <p:nvSpPr>
-          <p:cNvPr id="16" name="TextBox 15"/>
+                  <a:srgbClr val="999999"/>
+                </a:solidFill>
+                <a:latin typeface="Segoe UI"/>
+              </a:defRPr>
+            </a:pPr>
+            <a:r>
+              <a:t>95% CI</a:t>
+            </a:r>
+          </a:p>
+        </p:txBody>
+      </p:sp>
+      <p:sp>
+        <p:nvSpPr>
+          <p:cNvPr id="10" name="TextBox 9"/>
           <p:cNvSpPr txBox="1"/>
           <p:nvPr/>
         </p:nvSpPr>
         <p:spPr>
           <a:xfrm>
-            <a:off x="6858000" y="5120640"/>
-            <a:ext cx="4572000" cy="365760"/>
+            <a:off x="7132320" y="2743200"/>
+            <a:ext cx="4389120" cy="548640"/>
           </a:xfrm>
           <a:prstGeom prst="rect">
             <a:avLst/>
@@ -4553,29 +4085,29 @@
               <a:spcAft>
                 <a:spcPts val="400"/>
               </a:spcAft>
-              <a:defRPr sz="1400" b="0">
-                <a:solidFill>
-                  <a:srgbClr val="999999"/>
-                </a:solidFill>
-                <a:latin typeface="Segoe UI"/>
-              </a:defRPr>
-            </a:pPr>
-            <a:r>
-              <a:t>I² (Agreement)</a:t>
-            </a:r>
-          </a:p>
-        </p:txBody>
-      </p:sp>
-      <p:sp>
-        <p:nvSpPr>
-          <p:cNvPr id="17" name="TextBox 16"/>
+              <a:defRPr sz="2600" b="1">
+                <a:solidFill>
+                  <a:srgbClr val="E65100"/>
+                </a:solidFill>
+                <a:latin typeface="Segoe UI"/>
+              </a:defRPr>
+            </a:pPr>
+            <a:r>
+              <a:t>−0.16 ~ 3.03</a:t>
+            </a:r>
+          </a:p>
+        </p:txBody>
+      </p:sp>
+      <p:sp>
+        <p:nvSpPr>
+          <p:cNvPr id="11" name="TextBox 10"/>
           <p:cNvSpPr txBox="1"/>
           <p:nvPr/>
         </p:nvSpPr>
         <p:spPr>
           <a:xfrm>
-            <a:off x="6858000" y="5440679"/>
-            <a:ext cx="4572000" cy="457200"/>
+            <a:off x="7132320" y="3566160"/>
+            <a:ext cx="4389120" cy="365760"/>
           </a:xfrm>
           <a:prstGeom prst="rect">
             <a:avLst/>
@@ -4592,29 +4124,29 @@
               <a:spcAft>
                 <a:spcPts val="400"/>
               </a:spcAft>
-              <a:defRPr sz="2400" b="1">
-                <a:solidFill>
-                  <a:srgbClr val="7E57C2"/>
-                </a:solidFill>
-                <a:latin typeface="Segoe UI"/>
-              </a:defRPr>
-            </a:pPr>
-            <a:r>
-              <a:t>86.9%</a:t>
-            </a:r>
-          </a:p>
-        </p:txBody>
-      </p:sp>
-      <p:sp>
-        <p:nvSpPr>
-          <p:cNvPr id="18" name="TextBox 17"/>
+              <a:defRPr sz="1400" b="0">
+                <a:solidFill>
+                  <a:srgbClr val="999999"/>
+                </a:solidFill>
+                <a:latin typeface="Segoe UI"/>
+              </a:defRPr>
+            </a:pPr>
+            <a:r>
+              <a:t>I²</a:t>
+            </a:r>
+          </a:p>
+        </p:txBody>
+      </p:sp>
+      <p:sp>
+        <p:nvSpPr>
+          <p:cNvPr id="12" name="TextBox 11"/>
           <p:cNvSpPr txBox="1"/>
           <p:nvPr/>
         </p:nvSpPr>
         <p:spPr>
           <a:xfrm>
-            <a:off x="6858000" y="5897879"/>
-            <a:ext cx="4572000" cy="457200"/>
+            <a:off x="7132320" y="3840480"/>
+            <a:ext cx="4389120" cy="548640"/>
           </a:xfrm>
           <a:prstGeom prst="rect">
             <a:avLst/>
@@ -4631,15 +4163,93 @@
               <a:spcAft>
                 <a:spcPts val="400"/>
               </a:spcAft>
+              <a:defRPr sz="3000" b="1">
+                <a:solidFill>
+                  <a:srgbClr val="7E57C2"/>
+                </a:solidFill>
+                <a:latin typeface="Segoe UI"/>
+              </a:defRPr>
+            </a:pPr>
+            <a:r>
+              <a:t>86.9%</a:t>
+            </a:r>
+          </a:p>
+        </p:txBody>
+      </p:sp>
+      <p:sp>
+        <p:nvSpPr>
+          <p:cNvPr id="13" name="TextBox 12"/>
+          <p:cNvSpPr txBox="1"/>
+          <p:nvPr/>
+        </p:nvSpPr>
+        <p:spPr>
+          <a:xfrm>
+            <a:off x="7132320" y="4754880"/>
+            <a:ext cx="4389120" cy="365760"/>
+          </a:xfrm>
+          <a:prstGeom prst="rect">
+            <a:avLst/>
+          </a:prstGeom>
+          <a:noFill/>
+        </p:spPr>
+        <p:txBody>
+          <a:bodyPr wrap="square">
+            <a:spAutoFit/>
+          </a:bodyPr>
+          <a:lstStyle/>
+          <a:p>
+            <a:pPr algn="l">
+              <a:spcAft>
+                <a:spcPts val="400"/>
+              </a:spcAft>
               <a:defRPr sz="1400" b="0">
                 <a:solidFill>
+                  <a:srgbClr val="999999"/>
+                </a:solidFill>
+                <a:latin typeface="Segoe UI"/>
+              </a:defRPr>
+            </a:pPr>
+            <a:r>
+              <a:t>Studies included</a:t>
+            </a:r>
+          </a:p>
+        </p:txBody>
+      </p:sp>
+      <p:sp>
+        <p:nvSpPr>
+          <p:cNvPr id="14" name="TextBox 13"/>
+          <p:cNvSpPr txBox="1"/>
+          <p:nvPr/>
+        </p:nvSpPr>
+        <p:spPr>
+          <a:xfrm>
+            <a:off x="7132320" y="5029200"/>
+            <a:ext cx="4389120" cy="548640"/>
+          </a:xfrm>
+          <a:prstGeom prst="rect">
+            <a:avLst/>
+          </a:prstGeom>
+          <a:noFill/>
+        </p:spPr>
+        <p:txBody>
+          <a:bodyPr wrap="square">
+            <a:spAutoFit/>
+          </a:bodyPr>
+          <a:lstStyle/>
+          <a:p>
+            <a:pPr algn="l">
+              <a:spcAft>
+                <a:spcPts val="400"/>
+              </a:spcAft>
+              <a:defRPr sz="3000" b="1">
+                <a:solidFill>
                   <a:srgbClr val="2D2240"/>
                 </a:solidFill>
                 <a:latin typeface="Segoe UI"/>
               </a:defRPr>
             </a:pPr>
             <a:r>
-              <a:t>Very high — methods differ → field still young</a:t>
+              <a:t>N = 7</a:t>
             </a:r>
           </a:p>
         </p:txBody>
@@ -4679,7 +4289,7 @@
         <p:spPr>
           <a:xfrm>
             <a:off x="0" y="0"/>
-            <a:ext cx="12191695" cy="73152"/>
+            <a:ext cx="12191695" cy="64008"/>
           </a:xfrm>
           <a:prstGeom prst="rect">
             <a:avLst/>
@@ -4722,7 +4332,7 @@
         <p:spPr>
           <a:xfrm>
             <a:off x="731520" y="365760"/>
-            <a:ext cx="10698480" cy="640080"/>
+            <a:ext cx="10058400" cy="548640"/>
           </a:xfrm>
           <a:prstGeom prst="rect">
             <a:avLst/>
@@ -4760,8 +4370,8 @@
         </p:nvSpPr>
         <p:spPr>
           <a:xfrm>
-            <a:off x="731520" y="1005840"/>
-            <a:ext cx="3200400" cy="15240"/>
+            <a:off x="731520" y="960120"/>
+            <a:ext cx="2743200" cy="31750"/>
           </a:xfrm>
           <a:prstGeom prst="rect">
             <a:avLst/>
@@ -4821,7 +4431,7 @@
               <a:spcAft>
                 <a:spcPts val="400"/>
               </a:spcAft>
-              <a:defRPr sz="2100" b="1">
+              <a:defRPr sz="2200" b="1">
                 <a:solidFill>
                   <a:srgbClr val="2E7D32"/>
                 </a:solidFill>
@@ -4842,8 +4452,8 @@
         </p:nvSpPr>
         <p:spPr>
           <a:xfrm>
-            <a:off x="1463040" y="1874519"/>
-            <a:ext cx="8686800" cy="347472"/>
+            <a:off x="1463040" y="1920240"/>
+            <a:ext cx="8686800" cy="320040"/>
           </a:xfrm>
           <a:prstGeom prst="rect">
             <a:avLst/>
@@ -4860,7 +4470,7 @@
               <a:spcAft>
                 <a:spcPts val="400"/>
               </a:spcAft>
-              <a:defRPr sz="1600" b="0">
+              <a:defRPr sz="1700" b="0">
                 <a:solidFill>
                   <a:srgbClr val="2D2240"/>
                 </a:solidFill>
@@ -4868,7 +4478,7 @@
               </a:defRPr>
             </a:pPr>
             <a:r>
-              <a:t>SMD = 1.43 — very large effect</a:t>
+              <a:t>SMD = 1.43</a:t>
             </a:r>
           </a:p>
         </p:txBody>
@@ -4881,8 +4491,8 @@
         </p:nvSpPr>
         <p:spPr>
           <a:xfrm>
-            <a:off x="1463040" y="2221991"/>
-            <a:ext cx="8686800" cy="347472"/>
+            <a:off x="1463040" y="2267712"/>
+            <a:ext cx="8686800" cy="320040"/>
           </a:xfrm>
           <a:prstGeom prst="rect">
             <a:avLst/>
@@ -4899,7 +4509,7 @@
               <a:spcAft>
                 <a:spcPts val="400"/>
               </a:spcAft>
-              <a:defRPr sz="1600" b="0">
+              <a:defRPr sz="1700" b="0">
                 <a:solidFill>
                   <a:srgbClr val="2D2240"/>
                 </a:solidFill>
@@ -4907,7 +4517,7 @@
               </a:defRPr>
             </a:pPr>
             <a:r>
-              <a:t>Low-bounce ball → easier control → frees attention</a:t>
+              <a:t>Low-bounce ball → ↓ control demand → ↑ attention for decisions</a:t>
             </a:r>
           </a:p>
         </p:txBody>
@@ -4920,8 +4530,8 @@
         </p:nvSpPr>
         <p:spPr>
           <a:xfrm>
-            <a:off x="1463040" y="2569463"/>
-            <a:ext cx="8686800" cy="347472"/>
+            <a:off x="1463040" y="2615184"/>
+            <a:ext cx="8686800" cy="320040"/>
           </a:xfrm>
           <a:prstGeom prst="rect">
             <a:avLst/>
@@ -4938,7 +4548,7 @@
               <a:spcAft>
                 <a:spcPts val="400"/>
               </a:spcAft>
-              <a:defRPr sz="1600" b="0">
+              <a:defRPr sz="1700" b="0">
                 <a:solidFill>
                   <a:srgbClr val="2D2240"/>
                 </a:solidFill>
@@ -4946,7 +4556,7 @@
               </a:defRPr>
             </a:pPr>
             <a:r>
-              <a:t>Passing accuracy ↑ in soccer context</a:t>
+              <a:t>Effect transfers to soccer context</a:t>
             </a:r>
           </a:p>
         </p:txBody>
@@ -5020,7 +4630,7 @@
               <a:spcAft>
                 <a:spcPts val="400"/>
               </a:spcAft>
-              <a:defRPr sz="2100" b="1">
+              <a:defRPr sz="2200" b="1">
                 <a:solidFill>
                   <a:srgbClr val="E65100"/>
                 </a:solidFill>
@@ -5041,8 +4651,8 @@
         </p:nvSpPr>
         <p:spPr>
           <a:xfrm>
-            <a:off x="1463040" y="3657600"/>
-            <a:ext cx="8686800" cy="347472"/>
+            <a:off x="1463040" y="3703320"/>
+            <a:ext cx="8686800" cy="320040"/>
           </a:xfrm>
           <a:prstGeom prst="rect">
             <a:avLst/>
@@ -5059,7 +4669,7 @@
               <a:spcAft>
                 <a:spcPts val="400"/>
               </a:spcAft>
-              <a:defRPr sz="1600" b="0">
+              <a:defRPr sz="1700" b="0">
                 <a:solidFill>
                   <a:srgbClr val="2D2240"/>
                 </a:solidFill>
@@ -5067,7 +4677,7 @@
               </a:defRPr>
             </a:pPr>
             <a:r>
-              <a:t>Field-based tests → futsal players FASTER</a:t>
+              <a:t>I² = 94.5%</a:t>
             </a:r>
           </a:p>
         </p:txBody>
@@ -5080,8 +4690,8 @@
         </p:nvSpPr>
         <p:spPr>
           <a:xfrm>
-            <a:off x="1463040" y="4005072"/>
-            <a:ext cx="8686800" cy="347472"/>
+            <a:off x="1463040" y="4050791"/>
+            <a:ext cx="8686800" cy="320040"/>
           </a:xfrm>
           <a:prstGeom prst="rect">
             <a:avLst/>
@@ -5098,7 +4708,7 @@
               <a:spcAft>
                 <a:spcPts val="400"/>
               </a:spcAft>
-              <a:defRPr sz="1600" b="0">
+              <a:defRPr sz="1700" b="0">
                 <a:solidFill>
                   <a:srgbClr val="2D2240"/>
                 </a:solidFill>
@@ -5106,7 +4716,7 @@
               </a:defRPr>
             </a:pPr>
             <a:r>
-              <a:t>Lab-based tests → futsal = or SLOWER</a:t>
+              <a:t>Field-based: futsal &gt; soccer</a:t>
             </a:r>
           </a:p>
         </p:txBody>
@@ -5119,8 +4729,8 @@
         </p:nvSpPr>
         <p:spPr>
           <a:xfrm>
-            <a:off x="1463040" y="4352544"/>
-            <a:ext cx="8686800" cy="347472"/>
+            <a:off x="1463040" y="4398264"/>
+            <a:ext cx="8686800" cy="320040"/>
           </a:xfrm>
           <a:prstGeom prst="rect">
             <a:avLst/>
@@ -5137,7 +4747,7 @@
               <a:spcAft>
                 <a:spcPts val="400"/>
               </a:spcAft>
-              <a:defRPr sz="1600" b="0">
+              <a:defRPr sz="1700" b="0">
                 <a:solidFill>
                   <a:srgbClr val="2D2240"/>
                 </a:solidFill>
@@ -5145,7 +4755,7 @@
               </a:defRPr>
             </a:pPr>
             <a:r>
-              <a:t>Futsal trains perception-action coupling, NOT raw processing speed</a:t>
+              <a:t>Lab-based: futsal ≤ soccer</a:t>
             </a:r>
           </a:p>
         </p:txBody>
@@ -5219,7 +4829,7 @@
               <a:spcAft>
                 <a:spcPts val="400"/>
               </a:spcAft>
-              <a:defRPr sz="2100" b="1">
+              <a:defRPr sz="2200" b="1">
                 <a:solidFill>
                   <a:srgbClr val="C62828"/>
                 </a:solidFill>
@@ -5240,8 +4850,8 @@
         </p:nvSpPr>
         <p:spPr>
           <a:xfrm>
-            <a:off x="1463040" y="5440680"/>
-            <a:ext cx="8686800" cy="347472"/>
+            <a:off x="1463040" y="5486400"/>
+            <a:ext cx="8686800" cy="320040"/>
           </a:xfrm>
           <a:prstGeom prst="rect">
             <a:avLst/>
@@ -5258,7 +4868,7 @@
               <a:spcAft>
                 <a:spcPts val="400"/>
               </a:spcAft>
-              <a:defRPr sz="1600" b="0">
+              <a:defRPr sz="1700" b="0">
                 <a:solidFill>
                   <a:srgbClr val="2D2240"/>
                 </a:solidFill>
@@ -5266,7 +4876,7 @@
               </a:defRPr>
             </a:pPr>
             <a:r>
-              <a:t>Futsal: success = close distance + high velocity</a:t>
+              <a:t>Futsal: close distance + high velocity</a:t>
             </a:r>
           </a:p>
         </p:txBody>
@@ -5279,8 +4889,8 @@
         </p:nvSpPr>
         <p:spPr>
           <a:xfrm>
-            <a:off x="1463040" y="5788152"/>
-            <a:ext cx="8686800" cy="347472"/>
+            <a:off x="1463040" y="5833872"/>
+            <a:ext cx="8686800" cy="320040"/>
           </a:xfrm>
           <a:prstGeom prst="rect">
             <a:avLst/>
@@ -5297,7 +4907,7 @@
               <a:spcAft>
                 <a:spcPts val="400"/>
               </a:spcAft>
-              <a:defRPr sz="1600" b="0">
+              <a:defRPr sz="1700" b="0">
                 <a:solidFill>
                   <a:srgbClr val="2D2240"/>
                 </a:solidFill>
@@ -5305,7 +4915,7 @@
               </a:defRPr>
             </a:pPr>
             <a:r>
-              <a:t>Soccer: success = defender's reaction time</a:t>
+              <a:t>Soccer: defender's RT</a:t>
             </a:r>
           </a:p>
         </p:txBody>
@@ -5318,8 +4928,8 @@
         </p:nvSpPr>
         <p:spPr>
           <a:xfrm>
-            <a:off x="1463040" y="6135624"/>
-            <a:ext cx="8686800" cy="347472"/>
+            <a:off x="1463040" y="6181344"/>
+            <a:ext cx="8686800" cy="320040"/>
           </a:xfrm>
           <a:prstGeom prst="rect">
             <a:avLst/>
@@ -5336,7 +4946,7 @@
               <a:spcAft>
                 <a:spcPts val="400"/>
               </a:spcAft>
-              <a:defRPr sz="1600" b="0">
+              <a:defRPr sz="1700" b="0">
                 <a:solidFill>
                   <a:srgbClr val="2D2240"/>
                 </a:solidFill>
@@ -5344,7 +4954,7 @@
               </a:defRPr>
             </a:pPr>
             <a:r>
-              <a:t>Different constraints → different solutions — NO automatic transfer</a:t>
+              <a:t>No automatic transfer</a:t>
             </a:r>
           </a:p>
         </p:txBody>
@@ -5384,7 +4994,7 @@
         <p:spPr>
           <a:xfrm>
             <a:off x="0" y="0"/>
-            <a:ext cx="12191695" cy="73152"/>
+            <a:ext cx="12191695" cy="64008"/>
           </a:xfrm>
           <a:prstGeom prst="rect">
             <a:avLst/>
@@ -5427,7 +5037,7 @@
         <p:spPr>
           <a:xfrm>
             <a:off x="731520" y="365760"/>
-            <a:ext cx="10698480" cy="640080"/>
+            <a:ext cx="10058400" cy="548640"/>
           </a:xfrm>
           <a:prstGeom prst="rect">
             <a:avLst/>
@@ -5465,8 +5075,8 @@
         </p:nvSpPr>
         <p:spPr>
           <a:xfrm>
-            <a:off x="731520" y="1005840"/>
-            <a:ext cx="3200400" cy="15240"/>
+            <a:off x="731520" y="960120"/>
+            <a:ext cx="2743200" cy="31750"/>
           </a:xfrm>
           <a:prstGeom prst="rect">
             <a:avLst/>
@@ -5509,7 +5119,7 @@
         <p:spPr>
           <a:xfrm>
             <a:off x="731520" y="1371600"/>
-            <a:ext cx="5486400" cy="457200"/>
+            <a:ext cx="5303520" cy="365760"/>
           </a:xfrm>
           <a:prstGeom prst="rect">
             <a:avLst/>
@@ -5534,7 +5144,7 @@
               </a:defRPr>
             </a:pPr>
             <a:r>
-              <a:t>🧠  COGNITIVE DEVELOPMENT</a:t>
+              <a:t>🧠  Cognitive Development</a:t>
             </a:r>
           </a:p>
         </p:txBody>
@@ -5547,8 +5157,8 @@
         </p:nvSpPr>
         <p:spPr>
           <a:xfrm>
-            <a:off x="1097280" y="2011680"/>
-            <a:ext cx="5029200" cy="2743200"/>
+            <a:off x="1097280" y="1920240"/>
+            <a:ext cx="4846320" cy="2743200"/>
           </a:xfrm>
           <a:prstGeom prst="rect">
             <a:avLst/>
@@ -5563,7 +5173,7 @@
           <a:p>
             <a:pPr>
               <a:spcAft>
-                <a:spcPts val="600"/>
+                <a:spcPts val="800"/>
               </a:spcAft>
               <a:defRPr sz="1700">
                 <a:solidFill>
@@ -5579,7 +5189,7 @@
           <a:p>
             <a:pPr>
               <a:spcAft>
-                <a:spcPts val="600"/>
+                <a:spcPts val="800"/>
               </a:spcAft>
               <a:defRPr sz="1700">
                 <a:solidFill>
@@ -5589,13 +5199,13 @@
               </a:defRPr>
             </a:pPr>
             <a:r>
-              <a:t>→ higher offensive decision-making quality in adulthood</a:t>
+              <a:t>→ Higher offensive decision-making quality (adult)</a:t>
             </a:r>
           </a:p>
           <a:p>
             <a:pPr>
               <a:spcAft>
-                <a:spcPts val="600"/>
+                <a:spcPts val="800"/>
               </a:spcAft>
               <a:defRPr sz="1700">
                 <a:solidFill>
@@ -5611,7 +5221,7 @@
           <a:p>
             <a:pPr>
               <a:spcAft>
-                <a:spcPts val="600"/>
+                <a:spcPts val="800"/>
               </a:spcAft>
               <a:defRPr sz="1700">
                 <a:solidFill>
@@ -5628,156 +5238,14 @@
       </p:sp>
       <p:sp>
         <p:nvSpPr>
-          <p:cNvPr id="7" name="TextBox 6"/>
-          <p:cNvSpPr txBox="1"/>
-          <p:nvPr/>
-        </p:nvSpPr>
-        <p:spPr>
-          <a:xfrm>
-            <a:off x="6858000" y="1371600"/>
-            <a:ext cx="4572000" cy="457200"/>
-          </a:xfrm>
-          <a:prstGeom prst="rect">
-            <a:avLst/>
-          </a:prstGeom>
-          <a:noFill/>
-        </p:spPr>
-        <p:txBody>
-          <a:bodyPr wrap="square">
-            <a:spAutoFit/>
-          </a:bodyPr>
-          <a:lstStyle/>
-          <a:p>
-            <a:pPr algn="l">
-              <a:spcAft>
-                <a:spcPts val="400"/>
-              </a:spcAft>
-              <a:defRPr sz="2000" b="1">
-                <a:solidFill>
-                  <a:srgbClr val="E65100"/>
-                </a:solidFill>
-                <a:latin typeface="Segoe UI"/>
-              </a:defRPr>
-            </a:pPr>
-            <a:r>
-              <a:t>⚠️  LIMITATIONS</a:t>
-            </a:r>
-          </a:p>
-        </p:txBody>
-      </p:sp>
-      <p:sp>
-        <p:nvSpPr>
-          <p:cNvPr id="8" name="TextBox 7"/>
-          <p:cNvSpPr txBox="1"/>
-          <p:nvPr/>
-        </p:nvSpPr>
-        <p:spPr>
-          <a:xfrm>
-            <a:off x="7132320" y="2011680"/>
-            <a:ext cx="4572000" cy="3200400"/>
-          </a:xfrm>
-          <a:prstGeom prst="rect">
-            <a:avLst/>
-          </a:prstGeom>
-          <a:noFill/>
-        </p:spPr>
-        <p:txBody>
-          <a:bodyPr wrap="square">
-            <a:spAutoFit/>
-          </a:bodyPr>
-          <a:lstStyle/>
-          <a:p>
-            <a:pPr>
-              <a:spcAft>
-                <a:spcPts val="600"/>
-              </a:spcAft>
-              <a:defRPr sz="1600">
-                <a:solidFill>
-                  <a:srgbClr val="2D2240"/>
-                </a:solidFill>
-                <a:latin typeface="Segoe UI"/>
-              </a:defRPr>
-            </a:pPr>
-            <a:r>
-              <a:t>Small sample: only 7 studies</a:t>
-            </a:r>
-          </a:p>
-          <a:p>
-            <a:pPr>
-              <a:spcAft>
-                <a:spcPts val="600"/>
-              </a:spcAft>
-              <a:defRPr sz="1600">
-                <a:solidFill>
-                  <a:srgbClr val="2D2240"/>
-                </a:solidFill>
-                <a:latin typeface="Segoe UI"/>
-              </a:defRPr>
-            </a:pPr>
-            <a:r>
-              <a:t>Mostly cross-sectional — no longitudinal tracking</a:t>
-            </a:r>
-          </a:p>
-          <a:p>
-            <a:pPr>
-              <a:spcAft>
-                <a:spcPts val="600"/>
-              </a:spcAft>
-              <a:defRPr sz="1600">
-                <a:solidFill>
-                  <a:srgbClr val="2D2240"/>
-                </a:solidFill>
-                <a:latin typeface="Segoe UI"/>
-              </a:defRPr>
-            </a:pPr>
-            <a:r>
-              <a:t>Dose-response unknown: how much futsal is enough?</a:t>
-            </a:r>
-          </a:p>
-          <a:p>
-            <a:pPr>
-              <a:spcAft>
-                <a:spcPts val="600"/>
-              </a:spcAft>
-              <a:defRPr sz="1600">
-                <a:solidFill>
-                  <a:srgbClr val="2D2240"/>
-                </a:solidFill>
-                <a:latin typeface="Segoe UI"/>
-              </a:defRPr>
-            </a:pPr>
-            <a:r>
-              <a:t>Language restriction: EN / ES / PT only</a:t>
-            </a:r>
-          </a:p>
-          <a:p>
-            <a:pPr>
-              <a:spcAft>
-                <a:spcPts val="600"/>
-              </a:spcAft>
-              <a:defRPr sz="1600">
-                <a:solidFill>
-                  <a:srgbClr val="2D2240"/>
-                </a:solidFill>
-                <a:latin typeface="Segoe UI"/>
-              </a:defRPr>
-            </a:pPr>
-            <a:r>
-              <a:t>Inter-rater reliability not computed</a:t>
-            </a:r>
-          </a:p>
-        </p:txBody>
-      </p:sp>
-      <p:sp>
-        <p:nvSpPr>
-          <p:cNvPr id="9" name="Rectangle 8"/>
+          <p:cNvPr id="7" name="Rectangle 6"/>
           <p:cNvSpPr/>
           <p:nvPr/>
         </p:nvSpPr>
         <p:spPr>
           <a:xfrm>
             <a:off x="6583680" y="1371600"/>
-            <a:ext cx="13716" cy="4114800"/>
+            <a:ext cx="19050" cy="4572000"/>
           </a:xfrm>
           <a:prstGeom prst="rect">
             <a:avLst/>
@@ -5813,14 +5281,14 @@
       </p:sp>
       <p:sp>
         <p:nvSpPr>
-          <p:cNvPr id="10" name="TextBox 9"/>
+          <p:cNvPr id="8" name="TextBox 7"/>
           <p:cNvSpPr txBox="1"/>
           <p:nvPr/>
         </p:nvSpPr>
         <p:spPr>
           <a:xfrm>
-            <a:off x="731520" y="5760720"/>
-            <a:ext cx="10698480" cy="457200"/>
+            <a:off x="7132320" y="1371600"/>
+            <a:ext cx="4389120" cy="365760"/>
           </a:xfrm>
           <a:prstGeom prst="rect">
             <a:avLst/>
@@ -5837,7 +5305,149 @@
               <a:spcAft>
                 <a:spcPts val="400"/>
               </a:spcAft>
-              <a:defRPr sz="1500" b="0">
+              <a:defRPr sz="2000" b="1">
+                <a:solidFill>
+                  <a:srgbClr val="E65100"/>
+                </a:solidFill>
+                <a:latin typeface="Segoe UI"/>
+              </a:defRPr>
+            </a:pPr>
+            <a:r>
+              <a:t>⚠️  Limitations</a:t>
+            </a:r>
+          </a:p>
+        </p:txBody>
+      </p:sp>
+      <p:sp>
+        <p:nvSpPr>
+          <p:cNvPr id="9" name="TextBox 8"/>
+          <p:cNvSpPr txBox="1"/>
+          <p:nvPr/>
+        </p:nvSpPr>
+        <p:spPr>
+          <a:xfrm>
+            <a:off x="7132320" y="1920240"/>
+            <a:ext cx="4389120" cy="3657600"/>
+          </a:xfrm>
+          <a:prstGeom prst="rect">
+            <a:avLst/>
+          </a:prstGeom>
+          <a:noFill/>
+        </p:spPr>
+        <p:txBody>
+          <a:bodyPr wrap="square">
+            <a:spAutoFit/>
+          </a:bodyPr>
+          <a:lstStyle/>
+          <a:p>
+            <a:pPr>
+              <a:spcAft>
+                <a:spcPts val="800"/>
+              </a:spcAft>
+              <a:defRPr sz="1600">
+                <a:solidFill>
+                  <a:srgbClr val="2D2240"/>
+                </a:solidFill>
+                <a:latin typeface="Segoe UI"/>
+              </a:defRPr>
+            </a:pPr>
+            <a:r>
+              <a:t>N = 7 only</a:t>
+            </a:r>
+          </a:p>
+          <a:p>
+            <a:pPr>
+              <a:spcAft>
+                <a:spcPts val="800"/>
+              </a:spcAft>
+              <a:defRPr sz="1600">
+                <a:solidFill>
+                  <a:srgbClr val="2D2240"/>
+                </a:solidFill>
+                <a:latin typeface="Segoe UI"/>
+              </a:defRPr>
+            </a:pPr>
+            <a:r>
+              <a:t>Cross-sectional (no longitudinal)</a:t>
+            </a:r>
+          </a:p>
+          <a:p>
+            <a:pPr>
+              <a:spcAft>
+                <a:spcPts val="800"/>
+              </a:spcAft>
+              <a:defRPr sz="1600">
+                <a:solidFill>
+                  <a:srgbClr val="2D2240"/>
+                </a:solidFill>
+                <a:latin typeface="Segoe UI"/>
+              </a:defRPr>
+            </a:pPr>
+            <a:r>
+              <a:t>Dose-response unknown</a:t>
+            </a:r>
+          </a:p>
+          <a:p>
+            <a:pPr>
+              <a:spcAft>
+                <a:spcPts val="800"/>
+              </a:spcAft>
+              <a:defRPr sz="1600">
+                <a:solidFill>
+                  <a:srgbClr val="2D2240"/>
+                </a:solidFill>
+                <a:latin typeface="Segoe UI"/>
+              </a:defRPr>
+            </a:pPr>
+            <a:r>
+              <a:t>Language: EN/ES/PT</a:t>
+            </a:r>
+          </a:p>
+          <a:p>
+            <a:pPr>
+              <a:spcAft>
+                <a:spcPts val="800"/>
+              </a:spcAft>
+              <a:defRPr sz="1600">
+                <a:solidFill>
+                  <a:srgbClr val="2D2240"/>
+                </a:solidFill>
+                <a:latin typeface="Segoe UI"/>
+              </a:defRPr>
+            </a:pPr>
+            <a:r>
+              <a:t>Inter-rater reliability: n/a</a:t>
+            </a:r>
+          </a:p>
+        </p:txBody>
+      </p:sp>
+      <p:sp>
+        <p:nvSpPr>
+          <p:cNvPr id="10" name="TextBox 9"/>
+          <p:cNvSpPr txBox="1"/>
+          <p:nvPr/>
+        </p:nvSpPr>
+        <p:spPr>
+          <a:xfrm>
+            <a:off x="731520" y="5760720"/>
+            <a:ext cx="10515600" cy="274320"/>
+          </a:xfrm>
+          <a:prstGeom prst="rect">
+            <a:avLst/>
+          </a:prstGeom>
+          <a:noFill/>
+        </p:spPr>
+        <p:txBody>
+          <a:bodyPr wrap="square">
+            <a:spAutoFit/>
+          </a:bodyPr>
+          <a:lstStyle/>
+          <a:p>
+            <a:pPr algn="l">
+              <a:spcAft>
+                <a:spcPts val="400"/>
+              </a:spcAft>
+              <a:defRPr sz="1400" b="0">
                 <a:solidFill>
                   <a:srgbClr val="999999"/>
                 </a:solidFill>
@@ -5845,7 +5455,7 @@
               </a:defRPr>
             </a:pPr>
             <a:r>
-              <a:t>→ Authors openly acknowledge these gaps — this is where my LR can contribute</a:t>
+              <a:t>→ Authors openly acknowledge these gaps</a:t>
             </a:r>
           </a:p>
         </p:txBody>
@@ -5885,7 +5495,7 @@
         <p:spPr>
           <a:xfrm>
             <a:off x="0" y="0"/>
-            <a:ext cx="12191695" cy="73152"/>
+            <a:ext cx="12191695" cy="64008"/>
           </a:xfrm>
           <a:prstGeom prst="rect">
             <a:avLst/>
@@ -5928,7 +5538,7 @@
         <p:spPr>
           <a:xfrm>
             <a:off x="731520" y="365760"/>
-            <a:ext cx="10698480" cy="640080"/>
+            <a:ext cx="10058400" cy="548640"/>
           </a:xfrm>
           <a:prstGeom prst="rect">
             <a:avLst/>
@@ -5966,8 +5576,8 @@
         </p:nvSpPr>
         <p:spPr>
           <a:xfrm>
-            <a:off x="731520" y="1005840"/>
-            <a:ext cx="3200400" cy="15240"/>
+            <a:off x="731520" y="960120"/>
+            <a:ext cx="2743200" cy="31750"/>
           </a:xfrm>
           <a:prstGeom prst="rect">
             <a:avLst/>
@@ -6010,7 +5620,7 @@
         <p:spPr>
           <a:xfrm>
             <a:off x="731520" y="1371600"/>
-            <a:ext cx="5303520" cy="457200"/>
+            <a:ext cx="5303520" cy="365760"/>
           </a:xfrm>
           <a:prstGeom prst="rect">
             <a:avLst/>
@@ -6035,7 +5645,7 @@
               </a:defRPr>
             </a:pPr>
             <a:r>
-              <a:t>✅  What I Can Use</a:t>
+              <a:t>✅  Actionable</a:t>
             </a:r>
           </a:p>
         </p:txBody>
@@ -6064,7 +5674,7 @@
           <a:p>
             <a:pPr>
               <a:spcAft>
-                <a:spcPts val="600"/>
+                <a:spcPts val="800"/>
               </a:spcAft>
               <a:defRPr sz="1700">
                 <a:solidFill>
@@ -6080,7 +5690,7 @@
           <a:p>
             <a:pPr>
               <a:spcAft>
-                <a:spcPts val="600"/>
+                <a:spcPts val="800"/>
               </a:spcAft>
               <a:defRPr sz="1700">
                 <a:solidFill>
@@ -6090,13 +5700,13 @@
               </a:defRPr>
             </a:pPr>
             <a:r>
-              <a:t>Small-sided constraints → force quick decisions</a:t>
+              <a:t>Small-sided constraints → quick decisions</a:t>
             </a:r>
           </a:p>
           <a:p>
             <a:pPr>
               <a:spcAft>
-                <a:spcPts val="600"/>
+                <a:spcPts val="800"/>
               </a:spcAft>
               <a:defRPr sz="1700">
                 <a:solidFill>
@@ -6106,13 +5716,13 @@
               </a:defRPr>
             </a:pPr>
             <a:r>
-              <a:t>Early futsal exposure → talent development</a:t>
+              <a:t>Early futsal exposure in talent pathway</a:t>
             </a:r>
           </a:p>
           <a:p>
             <a:pPr>
               <a:spcAft>
-                <a:spcPts val="600"/>
+                <a:spcPts val="800"/>
               </a:spcAft>
               <a:defRPr sz="1700">
                 <a:solidFill>
@@ -6122,179 +5732,21 @@
               </a:defRPr>
             </a:pPr>
             <a:r>
-              <a:t>Field-based reactive agility tests (RVS-T), NOT lab RT</a:t>
-            </a:r>
-          </a:p>
-        </p:txBody>
-      </p:sp>
-      <p:sp>
-        <p:nvSpPr>
-          <p:cNvPr id="7" name="TextBox 6"/>
-          <p:cNvSpPr txBox="1"/>
-          <p:nvPr/>
-        </p:nvSpPr>
-        <p:spPr>
-          <a:xfrm>
-            <a:off x="6858000" y="1371600"/>
-            <a:ext cx="4572000" cy="457200"/>
-          </a:xfrm>
-          <a:prstGeom prst="rect">
-            <a:avLst/>
-          </a:prstGeom>
-          <a:noFill/>
-        </p:spPr>
-        <p:txBody>
-          <a:bodyPr wrap="square">
-            <a:spAutoFit/>
-          </a:bodyPr>
-          <a:lstStyle/>
-          <a:p>
-            <a:pPr algn="l">
-              <a:spcAft>
-                <a:spcPts val="400"/>
-              </a:spcAft>
-              <a:defRPr sz="2000" b="1">
-                <a:solidFill>
-                  <a:srgbClr val="C62828"/>
-                </a:solidFill>
-                <a:latin typeface="Segoe UI"/>
-              </a:defRPr>
-            </a:pPr>
-            <a:r>
-              <a:t>❓  Unanswered Questions</a:t>
-            </a:r>
-          </a:p>
-        </p:txBody>
-      </p:sp>
-      <p:sp>
-        <p:nvSpPr>
-          <p:cNvPr id="8" name="TextBox 7"/>
-          <p:cNvSpPr txBox="1"/>
-          <p:nvPr/>
-        </p:nvSpPr>
-        <p:spPr>
-          <a:xfrm>
-            <a:off x="7132320" y="1920240"/>
-            <a:ext cx="4572000" cy="3200400"/>
-          </a:xfrm>
-          <a:prstGeom prst="rect">
-            <a:avLst/>
-          </a:prstGeom>
-          <a:noFill/>
-        </p:spPr>
-        <p:txBody>
-          <a:bodyPr wrap="square">
-            <a:spAutoFit/>
-          </a:bodyPr>
-          <a:lstStyle/>
-          <a:p>
-            <a:pPr>
-              <a:spcAft>
-                <a:spcPts val="500"/>
-              </a:spcAft>
-              <a:defRPr sz="1500">
-                <a:solidFill>
-                  <a:srgbClr val="2D2240"/>
-                </a:solidFill>
-                <a:latin typeface="Segoe UI"/>
-              </a:defRPr>
-            </a:pPr>
-            <a:r>
-              <a:t>WHEN to introduce futsal? At what age?</a:t>
-            </a:r>
-          </a:p>
-          <a:p>
-            <a:pPr>
-              <a:spcAft>
-                <a:spcPts val="500"/>
-              </a:spcAft>
-              <a:defRPr sz="1500">
-                <a:solidFill>
-                  <a:srgbClr val="2D2240"/>
-                </a:solidFill>
-                <a:latin typeface="Segoe UI"/>
-              </a:defRPr>
-            </a:pPr>
-            <a:r>
-              <a:t>WHEN to transition to larger-sided games?</a:t>
-            </a:r>
-          </a:p>
-          <a:p>
-            <a:pPr>
-              <a:spcAft>
-                <a:spcPts val="500"/>
-              </a:spcAft>
-              <a:defRPr sz="1500">
-                <a:solidFill>
-                  <a:srgbClr val="2D2240"/>
-                </a:solidFill>
-                <a:latin typeface="Segoe UI"/>
-              </a:defRPr>
-            </a:pPr>
-            <a:r>
-              <a:t>Must low-bounce drills be INDOOR?</a:t>
-            </a:r>
-          </a:p>
-          <a:p>
-            <a:pPr>
-              <a:spcAft>
-                <a:spcPts val="500"/>
-              </a:spcAft>
-              <a:defRPr sz="1500">
-                <a:solidFill>
-                  <a:srgbClr val="2D2240"/>
-                </a:solidFill>
-                <a:latin typeface="Segoe UI"/>
-              </a:defRPr>
-            </a:pPr>
-            <a:r>
-              <a:t>Does GRASS FRICTION affect transfer?</a:t>
-            </a:r>
-          </a:p>
-          <a:p>
-            <a:pPr>
-              <a:spcAft>
-                <a:spcPts val="500"/>
-              </a:spcAft>
-              <a:defRPr sz="1500">
-                <a:solidFill>
-                  <a:srgbClr val="2D2240"/>
-                </a:solidFill>
-                <a:latin typeface="Segoe UI"/>
-              </a:defRPr>
-            </a:pPr>
-            <a:r>
-              <a:t>Weaknesses of adult futsal → 11-a-side?</a:t>
-            </a:r>
-          </a:p>
-          <a:p>
-            <a:pPr>
-              <a:spcAft>
-                <a:spcPts val="500"/>
-              </a:spcAft>
-              <a:defRPr sz="1500">
-                <a:solidFill>
-                  <a:srgbClr val="2D2240"/>
-                </a:solidFill>
-                <a:latin typeface="Segoe UI"/>
-              </a:defRPr>
-            </a:pPr>
-            <a:r>
-              <a:t>Offside awareness · long passing · goalkeeper transition</a:t>
-            </a:r>
-          </a:p>
-        </p:txBody>
-      </p:sp>
-      <p:sp>
-        <p:nvSpPr>
-          <p:cNvPr id="9" name="Rectangle 8"/>
+              <a:t>Field-based testing (RVS-T), not lab RT</a:t>
+            </a:r>
+          </a:p>
+        </p:txBody>
+      </p:sp>
+      <p:sp>
+        <p:nvSpPr>
+          <p:cNvPr id="7" name="Rectangle 6"/>
           <p:cNvSpPr/>
           <p:nvPr/>
         </p:nvSpPr>
         <p:spPr>
           <a:xfrm>
             <a:off x="6583680" y="1371600"/>
-            <a:ext cx="13716" cy="4114800"/>
+            <a:ext cx="19050" cy="4572000"/>
           </a:xfrm>
           <a:prstGeom prst="rect">
             <a:avLst/>
@@ -6330,6 +5782,148 @@
       </p:sp>
       <p:sp>
         <p:nvSpPr>
+          <p:cNvPr id="8" name="TextBox 7"/>
+          <p:cNvSpPr txBox="1"/>
+          <p:nvPr/>
+        </p:nvSpPr>
+        <p:spPr>
+          <a:xfrm>
+            <a:off x="7132320" y="1371600"/>
+            <a:ext cx="4389120" cy="365760"/>
+          </a:xfrm>
+          <a:prstGeom prst="rect">
+            <a:avLst/>
+          </a:prstGeom>
+          <a:noFill/>
+        </p:spPr>
+        <p:txBody>
+          <a:bodyPr wrap="square">
+            <a:spAutoFit/>
+          </a:bodyPr>
+          <a:lstStyle/>
+          <a:p>
+            <a:pPr algn="l">
+              <a:spcAft>
+                <a:spcPts val="400"/>
+              </a:spcAft>
+              <a:defRPr sz="2000" b="1">
+                <a:solidFill>
+                  <a:srgbClr val="C62828"/>
+                </a:solidFill>
+                <a:latin typeface="Segoe UI"/>
+              </a:defRPr>
+            </a:pPr>
+            <a:r>
+              <a:t>❓  Unanswered</a:t>
+            </a:r>
+          </a:p>
+        </p:txBody>
+      </p:sp>
+      <p:sp>
+        <p:nvSpPr>
+          <p:cNvPr id="9" name="TextBox 8"/>
+          <p:cNvSpPr txBox="1"/>
+          <p:nvPr/>
+        </p:nvSpPr>
+        <p:spPr>
+          <a:xfrm>
+            <a:off x="7132320" y="1920240"/>
+            <a:ext cx="4389120" cy="3200400"/>
+          </a:xfrm>
+          <a:prstGeom prst="rect">
+            <a:avLst/>
+          </a:prstGeom>
+          <a:noFill/>
+        </p:spPr>
+        <p:txBody>
+          <a:bodyPr wrap="square">
+            <a:spAutoFit/>
+          </a:bodyPr>
+          <a:lstStyle/>
+          <a:p>
+            <a:pPr>
+              <a:spcAft>
+                <a:spcPts val="800"/>
+              </a:spcAft>
+              <a:defRPr sz="1500">
+                <a:solidFill>
+                  <a:srgbClr val="2D2240"/>
+                </a:solidFill>
+                <a:latin typeface="Segoe UI"/>
+              </a:defRPr>
+            </a:pPr>
+            <a:r>
+              <a:t>Age to introduce futsal?</a:t>
+            </a:r>
+          </a:p>
+          <a:p>
+            <a:pPr>
+              <a:spcAft>
+                <a:spcPts val="800"/>
+              </a:spcAft>
+              <a:defRPr sz="1500">
+                <a:solidFill>
+                  <a:srgbClr val="2D2240"/>
+                </a:solidFill>
+                <a:latin typeface="Segoe UI"/>
+              </a:defRPr>
+            </a:pPr>
+            <a:r>
+              <a:t>When to transition → 11-a-side?</a:t>
+            </a:r>
+          </a:p>
+          <a:p>
+            <a:pPr>
+              <a:spcAft>
+                <a:spcPts val="800"/>
+              </a:spcAft>
+              <a:defRPr sz="1500">
+                <a:solidFill>
+                  <a:srgbClr val="2D2240"/>
+                </a:solidFill>
+                <a:latin typeface="Segoe UI"/>
+              </a:defRPr>
+            </a:pPr>
+            <a:r>
+              <a:t>Indoor only? Grass friction?</a:t>
+            </a:r>
+          </a:p>
+          <a:p>
+            <a:pPr>
+              <a:spcAft>
+                <a:spcPts val="800"/>
+              </a:spcAft>
+              <a:defRPr sz="1500">
+                <a:solidFill>
+                  <a:srgbClr val="2D2240"/>
+                </a:solidFill>
+                <a:latin typeface="Segoe UI"/>
+              </a:defRPr>
+            </a:pPr>
+            <a:r>
+              <a:t>Adult futsal → football: weaknesses?</a:t>
+            </a:r>
+          </a:p>
+          <a:p>
+            <a:pPr>
+              <a:spcAft>
+                <a:spcPts val="800"/>
+              </a:spcAft>
+              <a:defRPr sz="1500">
+                <a:solidFill>
+                  <a:srgbClr val="2D2240"/>
+                </a:solidFill>
+                <a:latin typeface="Segoe UI"/>
+              </a:defRPr>
+            </a:pPr>
+            <a:r>
+              <a:t>Offside · long passing · goalkeeping</a:t>
+            </a:r>
+          </a:p>
+        </p:txBody>
+      </p:sp>
+      <p:sp>
+        <p:nvSpPr>
           <p:cNvPr id="10" name="Rectangle 9"/>
           <p:cNvSpPr/>
           <p:nvPr/>
@@ -6397,7 +5991,7 @@
               <a:spcAft>
                 <a:spcPts val="400"/>
               </a:spcAft>
-              <a:defRPr sz="1600" b="1">
+              <a:defRPr sz="1700" b="1">
                 <a:solidFill>
                   <a:srgbClr val="5B3A8C"/>
                 </a:solidFill>
@@ -6405,7 +5999,7 @@
               </a:defRPr>
             </a:pPr>
             <a:r>
-              <a:t>💡  Key gap: Almost NO research on NEGATIVE TRANSFER — does futsal create bad habits for football?</a:t>
+              <a:t>💡  Key gap: NEGATIVE TRANSFER — does futsal create bad habits for football?</a:t>
             </a:r>
           </a:p>
         </p:txBody>
@@ -6445,7 +6039,7 @@
         <p:spPr>
           <a:xfrm>
             <a:off x="0" y="0"/>
-            <a:ext cx="12191695" cy="73152"/>
+            <a:ext cx="12191695" cy="64008"/>
           </a:xfrm>
           <a:prstGeom prst="rect">
             <a:avLst/>
@@ -6488,7 +6082,7 @@
         <p:spPr>
           <a:xfrm>
             <a:off x="731520" y="365760"/>
-            <a:ext cx="10698480" cy="640080"/>
+            <a:ext cx="10058400" cy="548640"/>
           </a:xfrm>
           <a:prstGeom prst="rect">
             <a:avLst/>
@@ -6526,8 +6120,8 @@
         </p:nvSpPr>
         <p:spPr>
           <a:xfrm>
-            <a:off x="731520" y="1005840"/>
-            <a:ext cx="3200400" cy="15240"/>
+            <a:off x="731520" y="960120"/>
+            <a:ext cx="2743200" cy="31750"/>
           </a:xfrm>
           <a:prstGeom prst="rect">
             <a:avLst/>
@@ -6613,7 +6207,7 @@
         <p:spPr>
           <a:xfrm>
             <a:off x="1097280" y="1463040"/>
-            <a:ext cx="10058400" cy="457200"/>
+            <a:ext cx="10058400" cy="365760"/>
           </a:xfrm>
           <a:prstGeom prst="rect">
             <a:avLst/>
@@ -6638,7 +6232,7 @@
               </a:defRPr>
             </a:pPr>
             <a:r>
-              <a:t>Main Message of This Article</a:t>
+              <a:t>Main Message</a:t>
             </a:r>
           </a:p>
         </p:txBody>
@@ -6652,7 +6246,7 @@
         <p:spPr>
           <a:xfrm>
             <a:off x="1097280" y="1920240"/>
-            <a:ext cx="10058400" cy="640080"/>
+            <a:ext cx="10058400" cy="731520"/>
           </a:xfrm>
           <a:prstGeom prst="rect">
             <a:avLst/>
@@ -6665,11 +6259,11 @@
           </a:bodyPr>
           <a:lstStyle/>
           <a:p>
-            <a:pPr algn="l">
-              <a:spcAft>
-                <a:spcPts val="400"/>
-              </a:spcAft>
-              <a:defRPr sz="1700" b="0">
+            <a:pPr>
+              <a:spcAft>
+                <a:spcPts val="800"/>
+              </a:spcAft>
+              <a:defRPr sz="1800">
                 <a:solidFill>
                   <a:srgbClr val="2D2240"/>
                 </a:solidFill>
@@ -6677,7 +6271,39 @@
               </a:defRPr>
             </a:pPr>
             <a:r>
-              <a:t>Futsal is a proven donor sport — but transfer is SKILL-SPECIFIC. Passing transfers strongly, speed depends on context, and dribbling does NOT automatically transfer. Current evidence is promising but limited: only 7 studies, no longitudinal data.</a:t>
+              <a:t>Futsal = proven donor sport — but transfer is SKILL-SPECIFIC</a:t>
+            </a:r>
+          </a:p>
+          <a:p>
+            <a:pPr>
+              <a:spcAft>
+                <a:spcPts val="800"/>
+              </a:spcAft>
+              <a:defRPr sz="1800">
+                <a:solidFill>
+                  <a:srgbClr val="2D2240"/>
+                </a:solidFill>
+                <a:latin typeface="Segoe UI"/>
+              </a:defRPr>
+            </a:pPr>
+            <a:r>
+              <a:t>Passing ✅ | Speed ⚠️ (context) | Dribbling ❌ (no auto transfer)</a:t>
+            </a:r>
+          </a:p>
+          <a:p>
+            <a:pPr>
+              <a:spcAft>
+                <a:spcPts val="800"/>
+              </a:spcAft>
+              <a:defRPr sz="1800">
+                <a:solidFill>
+                  <a:srgbClr val="2D2240"/>
+                </a:solidFill>
+                <a:latin typeface="Segoe UI"/>
+              </a:defRPr>
+            </a:pPr>
+            <a:r>
+              <a:t>Only 7 studies — promising but limited evidence base</a:t>
             </a:r>
           </a:p>
         </p:txBody>
@@ -6691,7 +6317,7 @@
         <p:spPr>
           <a:xfrm>
             <a:off x="3200400" y="3017520"/>
-            <a:ext cx="5760720" cy="457200"/>
+            <a:ext cx="5760720" cy="365760"/>
           </a:xfrm>
           <a:prstGeom prst="rect">
             <a:avLst/>
@@ -6708,7 +6334,7 @@
               <a:spcAft>
                 <a:spcPts val="400"/>
               </a:spcAft>
-              <a:defRPr sz="1600" b="1">
+              <a:defRPr sz="1700" b="1">
                 <a:solidFill>
                   <a:srgbClr val="7E57C2"/>
                 </a:solidFill>
@@ -6716,7 +6342,7 @@
               </a:defRPr>
             </a:pPr>
             <a:r>
-              <a:t>→ What this means for my Literature Review →</a:t>
+              <a:t>→ My Literature Review →</a:t>
             </a:r>
           </a:p>
         </p:txBody>
@@ -6729,8 +6355,8 @@
         </p:nvSpPr>
         <p:spPr>
           <a:xfrm>
-            <a:off x="731520" y="3291840"/>
-            <a:ext cx="5349240" cy="365760"/>
+            <a:off x="731520" y="3657600"/>
+            <a:ext cx="5029200" cy="2560320"/>
           </a:xfrm>
           <a:prstGeom prst="rect">
             <a:avLst/>
@@ -6743,19 +6369,79 @@
           </a:bodyPr>
           <a:lstStyle/>
           <a:p>
-            <a:pPr algn="l">
-              <a:spcAft>
-                <a:spcPts val="400"/>
-              </a:spcAft>
-              <a:defRPr sz="1900" b="1">
-                <a:solidFill>
-                  <a:srgbClr val="7E57C2"/>
-                </a:solidFill>
-                <a:latin typeface="Segoe UI"/>
-              </a:defRPr>
-            </a:pPr>
-            <a:r>
-              <a:t>Peña-Ardila tells us</a:t>
+            <a:pPr>
+              <a:spcAft>
+                <a:spcPts val="800"/>
+              </a:spcAft>
+              <a:defRPr sz="1800">
+                <a:solidFill>
+                  <a:srgbClr val="2D2240"/>
+                </a:solidFill>
+                <a:latin typeface="Segoe UI"/>
+              </a:defRPr>
+            </a:pPr>
+            <a:r>
+              <a:t>✅  Passing transfers</a:t>
+            </a:r>
+            <a:br/>
+            <a:r>
+              <a:t>     SMD = 1.43</a:t>
+            </a:r>
+          </a:p>
+          <a:p>
+            <a:pPr>
+              <a:spcAft>
+                <a:spcPts val="800"/>
+              </a:spcAft>
+              <a:defRPr sz="1800">
+                <a:solidFill>
+                  <a:srgbClr val="2D2240"/>
+                </a:solidFill>
+                <a:latin typeface="Segoe UI"/>
+              </a:defRPr>
+            </a:pPr>
+            <a:r>
+              <a:t>⚠️  Speed depends on context</a:t>
+            </a:r>
+            <a:br/>
+            <a:r>
+              <a:t>     I² = 94.5%</a:t>
+            </a:r>
+          </a:p>
+          <a:p>
+            <a:pPr>
+              <a:spcAft>
+                <a:spcPts val="800"/>
+              </a:spcAft>
+              <a:defRPr sz="1800">
+                <a:solidFill>
+                  <a:srgbClr val="2D2240"/>
+                </a:solidFill>
+                <a:latin typeface="Segoe UI"/>
+              </a:defRPr>
+            </a:pPr>
+            <a:r>
+              <a:t>❌  Dribbling: sport-specific</a:t>
+            </a:r>
+          </a:p>
+          <a:p>
+            <a:pPr>
+              <a:spcAft>
+                <a:spcPts val="800"/>
+              </a:spcAft>
+              <a:defRPr sz="1800">
+                <a:solidFill>
+                  <a:srgbClr val="2D2240"/>
+                </a:solidFill>
+                <a:latin typeface="Segoe UI"/>
+              </a:defRPr>
+            </a:pPr>
+            <a:r>
+              <a:t>⚠️  No longitudinal</a:t>
+            </a:r>
+            <a:br/>
+            <a:r>
+              <a:t>     No negative transfer</a:t>
             </a:r>
           </a:p>
         </p:txBody>
@@ -6768,8 +6454,8 @@
         </p:nvSpPr>
         <p:spPr>
           <a:xfrm>
-            <a:off x="6080759" y="3291840"/>
-            <a:ext cx="5349240" cy="365760"/>
+            <a:off x="6858000" y="3657600"/>
+            <a:ext cx="5029200" cy="2560320"/>
           </a:xfrm>
           <a:prstGeom prst="rect">
             <a:avLst/>
@@ -6782,19 +6468,83 @@
           </a:bodyPr>
           <a:lstStyle/>
           <a:p>
-            <a:pPr algn="l">
-              <a:spcAft>
-                <a:spcPts val="400"/>
-              </a:spcAft>
-              <a:defRPr sz="1900" b="1">
-                <a:solidFill>
-                  <a:srgbClr val="7E57C2"/>
-                </a:solidFill>
-                <a:latin typeface="Segoe UI"/>
-              </a:defRPr>
-            </a:pPr>
-            <a:r>
-              <a:t>My LR will explore</a:t>
+            <a:pPr>
+              <a:spcAft>
+                <a:spcPts val="800"/>
+              </a:spcAft>
+              <a:defRPr sz="1800">
+                <a:solidFill>
+                  <a:srgbClr val="2D2240"/>
+                </a:solidFill>
+                <a:latin typeface="Segoe UI"/>
+              </a:defRPr>
+            </a:pPr>
+            <a:r>
+              <a:t>Theme 1</a:t>
+            </a:r>
+            <a:br/>
+            <a:r>
+              <a:t>Technical skill transfer</a:t>
+            </a:r>
+          </a:p>
+          <a:p>
+            <a:pPr>
+              <a:spcAft>
+                <a:spcPts val="800"/>
+              </a:spcAft>
+              <a:defRPr sz="1800">
+                <a:solidFill>
+                  <a:srgbClr val="2D2240"/>
+                </a:solidFill>
+                <a:latin typeface="Segoe UI"/>
+              </a:defRPr>
+            </a:pPr>
+            <a:r>
+              <a:t>Theme 2</a:t>
+            </a:r>
+            <a:br/>
+            <a:r>
+              <a:t>Perceptual-cognitive adaptation</a:t>
+            </a:r>
+          </a:p>
+          <a:p>
+            <a:pPr>
+              <a:spcAft>
+                <a:spcPts val="800"/>
+              </a:spcAft>
+              <a:defRPr sz="1800">
+                <a:solidFill>
+                  <a:srgbClr val="2D2240"/>
+                </a:solidFill>
+                <a:latin typeface="Segoe UI"/>
+              </a:defRPr>
+            </a:pPr>
+            <a:r>
+              <a:t>Theme 3</a:t>
+            </a:r>
+            <a:br/>
+            <a:r>
+              <a:t>Talent development pathways</a:t>
+            </a:r>
+          </a:p>
+          <a:p>
+            <a:pPr>
+              <a:spcAft>
+                <a:spcPts val="800"/>
+              </a:spcAft>
+              <a:defRPr sz="1800">
+                <a:solidFill>
+                  <a:srgbClr val="2D2240"/>
+                </a:solidFill>
+                <a:latin typeface="Segoe UI"/>
+              </a:defRPr>
+            </a:pPr>
+            <a:r>
+              <a:t>➕  What does NOT transfer?</a:t>
+            </a:r>
+            <a:br/>
+            <a:r>
+              <a:t>     The research gap</a:t>
             </a:r>
           </a:p>
         </p:txBody>
@@ -6807,8 +6557,8 @@
         </p:nvSpPr>
         <p:spPr>
           <a:xfrm>
-            <a:off x="6071616" y="3657600"/>
-            <a:ext cx="18288" cy="2743200"/>
+            <a:off x="6583680" y="3657600"/>
+            <a:ext cx="19050" cy="2560320"/>
           </a:xfrm>
           <a:prstGeom prst="rect">
             <a:avLst/>
@@ -6850,8 +6600,8 @@
         </p:nvSpPr>
         <p:spPr>
           <a:xfrm>
-            <a:off x="731520" y="3657600"/>
-            <a:ext cx="5166359" cy="2743200"/>
+            <a:off x="731520" y="3246120"/>
+            <a:ext cx="5029200" cy="320040"/>
           </a:xfrm>
           <a:prstGeom prst="rect">
             <a:avLst/>
@@ -6864,67 +6614,19 @@
           </a:bodyPr>
           <a:lstStyle/>
           <a:p>
-            <a:pPr>
-              <a:spcAft>
-                <a:spcPts val="600"/>
-              </a:spcAft>
-              <a:defRPr sz="1700">
-                <a:solidFill>
-                  <a:srgbClr val="2D2240"/>
-                </a:solidFill>
-                <a:latin typeface="Segoe UI"/>
-              </a:defRPr>
-            </a:pPr>
-            <a:r>
-              <a:t>✅  PASSING transfers (SMD=1.43)</a:t>
-            </a:r>
-          </a:p>
-          <a:p>
-            <a:pPr>
-              <a:spcAft>
-                <a:spcPts val="600"/>
-              </a:spcAft>
-              <a:defRPr sz="1700">
-                <a:solidFill>
-                  <a:srgbClr val="2D2240"/>
-                </a:solidFill>
-                <a:latin typeface="Segoe UI"/>
-              </a:defRPr>
-            </a:pPr>
-            <a:r>
-              <a:t>⚠️  SPEED depends on context</a:t>
-            </a:r>
-          </a:p>
-          <a:p>
-            <a:pPr>
-              <a:spcAft>
-                <a:spcPts val="600"/>
-              </a:spcAft>
-              <a:defRPr sz="1700">
-                <a:solidFill>
-                  <a:srgbClr val="2D2240"/>
-                </a:solidFill>
-                <a:latin typeface="Segoe UI"/>
-              </a:defRPr>
-            </a:pPr>
-            <a:r>
-              <a:t>❌  DRIBBLING: sport-specific</a:t>
-            </a:r>
-          </a:p>
-          <a:p>
-            <a:pPr>
-              <a:spcAft>
-                <a:spcPts val="600"/>
-              </a:spcAft>
-              <a:defRPr sz="1700">
-                <a:solidFill>
-                  <a:srgbClr val="2D2240"/>
-                </a:solidFill>
-                <a:latin typeface="Segoe UI"/>
-              </a:defRPr>
-            </a:pPr>
-            <a:r>
-              <a:t>⚠️  No longitudinal / No negative transfer</a:t>
+            <a:pPr algn="l">
+              <a:spcAft>
+                <a:spcPts val="400"/>
+              </a:spcAft>
+              <a:defRPr sz="1700" b="1">
+                <a:solidFill>
+                  <a:srgbClr val="7E57C2"/>
+                </a:solidFill>
+                <a:latin typeface="Segoe UI"/>
+              </a:defRPr>
+            </a:pPr>
+            <a:r>
+              <a:t>Peña-Ardila tells us</a:t>
             </a:r>
           </a:p>
         </p:txBody>
@@ -6937,8 +6639,8 @@
         </p:nvSpPr>
         <p:spPr>
           <a:xfrm>
-            <a:off x="6126479" y="3657600"/>
-            <a:ext cx="5166359" cy="2743200"/>
+            <a:off x="6858000" y="3246120"/>
+            <a:ext cx="5029200" cy="320040"/>
           </a:xfrm>
           <a:prstGeom prst="rect">
             <a:avLst/>
@@ -6951,67 +6653,19 @@
           </a:bodyPr>
           <a:lstStyle/>
           <a:p>
-            <a:pPr>
-              <a:spcAft>
-                <a:spcPts val="600"/>
-              </a:spcAft>
-              <a:defRPr sz="1700">
-                <a:solidFill>
-                  <a:srgbClr val="2D2240"/>
-                </a:solidFill>
-                <a:latin typeface="Segoe UI"/>
-              </a:defRPr>
-            </a:pPr>
-            <a:r>
-              <a:t>THEME 1: Technical skill transfer</a:t>
-            </a:r>
-          </a:p>
-          <a:p>
-            <a:pPr>
-              <a:spcAft>
-                <a:spcPts val="600"/>
-              </a:spcAft>
-              <a:defRPr sz="1700">
-                <a:solidFill>
-                  <a:srgbClr val="2D2240"/>
-                </a:solidFill>
-                <a:latin typeface="Segoe UI"/>
-              </a:defRPr>
-            </a:pPr>
-            <a:r>
-              <a:t>THEME 2: Perceptual-cognitive adaptations</a:t>
-            </a:r>
-          </a:p>
-          <a:p>
-            <a:pPr>
-              <a:spcAft>
-                <a:spcPts val="600"/>
-              </a:spcAft>
-              <a:defRPr sz="1700">
-                <a:solidFill>
-                  <a:srgbClr val="2D2240"/>
-                </a:solidFill>
-                <a:latin typeface="Segoe UI"/>
-              </a:defRPr>
-            </a:pPr>
-            <a:r>
-              <a:t>THEME 3: Talent development pathways</a:t>
-            </a:r>
-          </a:p>
-          <a:p>
-            <a:pPr>
-              <a:spcAft>
-                <a:spcPts val="600"/>
-              </a:spcAft>
-              <a:defRPr sz="1700">
-                <a:solidFill>
-                  <a:srgbClr val="2D2240"/>
-                </a:solidFill>
-                <a:latin typeface="Segoe UI"/>
-              </a:defRPr>
-            </a:pPr>
-            <a:r>
-              <a:t>➕ What does NOT transfer — the research gap</a:t>
+            <a:pPr algn="l">
+              <a:spcAft>
+                <a:spcPts val="400"/>
+              </a:spcAft>
+              <a:defRPr sz="1700" b="1">
+                <a:solidFill>
+                  <a:srgbClr val="7E57C2"/>
+                </a:solidFill>
+                <a:latin typeface="Segoe UI"/>
+              </a:defRPr>
+            </a:pPr>
+            <a:r>
+              <a:t>My LR will explore</a:t>
             </a:r>
           </a:p>
         </p:txBody>

</xml_diff>

<commit_message>
Peña-Ardila PPT v5: max 25 words/slide, keywords only, no sentences
</commit_message>
<xml_diff>
--- a/lr-slides/Presenting_Article_Pena-Ardila.pptx
+++ b/lr-slides/Presenting_Article_Pena-Ardila.pptx
@@ -3153,8 +3153,8 @@
         </p:nvSpPr>
         <p:spPr>
           <a:xfrm>
-            <a:off x="1371600" y="1097280"/>
-            <a:ext cx="9418320" cy="1097280"/>
+            <a:off x="1371600" y="1371600"/>
+            <a:ext cx="9418320" cy="914400"/>
           </a:xfrm>
           <a:prstGeom prst="rect">
             <a:avLst/>
@@ -3169,9 +3169,9 @@
           <a:p>
             <a:pPr algn="l">
               <a:spcAft>
-                <a:spcPts val="400"/>
-              </a:spcAft>
-              <a:defRPr sz="3400" b="1">
+                <a:spcPts val="200"/>
+              </a:spcAft>
+              <a:defRPr sz="3600" b="1">
                 <a:solidFill>
                   <a:srgbClr val="5B3A8C"/>
                 </a:solidFill>
@@ -3179,7 +3179,7 @@
               </a:defRPr>
             </a:pPr>
             <a:r>
-              <a:t>Transfer of Technical &amp; Tactical Skills</a:t>
+              <a:t>Technical &amp; Tactical Skill Transfer</a:t>
             </a:r>
             <a:br/>
             <a:r>
@@ -3196,8 +3196,8 @@
         </p:nvSpPr>
         <p:spPr>
           <a:xfrm>
-            <a:off x="1371600" y="2468880"/>
-            <a:ext cx="9418320" cy="548640"/>
+            <a:off x="1371600" y="2560320"/>
+            <a:ext cx="9418320" cy="457200"/>
           </a:xfrm>
           <a:prstGeom prst="rect">
             <a:avLst/>
@@ -3212,7 +3212,7 @@
           <a:p>
             <a:pPr algn="l">
               <a:spcAft>
-                <a:spcPts val="400"/>
+                <a:spcPts val="200"/>
               </a:spcAft>
               <a:defRPr sz="2200" b="0">
                 <a:solidFill>
@@ -3222,7 +3222,7 @@
               </a:defRPr>
             </a:pPr>
             <a:r>
-              <a:t>A Systematic Review &amp; Meta-Analysis of the 'Donor Sport' Concept</a:t>
+              <a:t>A Systematic Review &amp; Meta-Analysis</a:t>
             </a:r>
           </a:p>
         </p:txBody>
@@ -3235,7 +3235,7 @@
         </p:nvSpPr>
         <p:spPr>
           <a:xfrm>
-            <a:off x="1371600" y="3291840"/>
+            <a:off x="1371600" y="3200400"/>
             <a:ext cx="1828800" cy="27432"/>
           </a:xfrm>
           <a:prstGeom prst="rect">
@@ -3278,8 +3278,8 @@
         </p:nvSpPr>
         <p:spPr>
           <a:xfrm>
-            <a:off x="1371600" y="3566160"/>
-            <a:ext cx="9418320" cy="365760"/>
+            <a:off x="1371600" y="3474720"/>
+            <a:ext cx="9418320" cy="274320"/>
           </a:xfrm>
           <a:prstGeom prst="rect">
             <a:avLst/>
@@ -3294,9 +3294,9 @@
           <a:p>
             <a:pPr algn="l">
               <a:spcAft>
-                <a:spcPts val="400"/>
-              </a:spcAft>
-              <a:defRPr sz="1700" b="0">
+                <a:spcPts val="200"/>
+              </a:spcAft>
+              <a:defRPr sz="1600" b="0">
                 <a:solidFill>
                   <a:srgbClr val="999999"/>
                 </a:solidFill>
@@ -3304,7 +3304,7 @@
               </a:defRPr>
             </a:pPr>
             <a:r>
-              <a:t>Peña-Ardila, E.F. (2026) · Perceptual and Motor Skills</a:t>
+              <a:t>Peña-Ardila (2026) · Perceptual and Motor Skills</a:t>
             </a:r>
           </a:p>
         </p:txBody>
@@ -3376,7 +3376,7 @@
           <a:p>
             <a:pPr algn="l">
               <a:spcAft>
-                <a:spcPts val="400"/>
+                <a:spcPts val="200"/>
               </a:spcAft>
               <a:defRPr sz="1200" b="0">
                 <a:solidFill>
@@ -3386,7 +3386,7 @@
               </a:defRPr>
             </a:pPr>
             <a:r>
-              <a:t>Analyst: HONGXIAN AN  |  Presenting an Article  |  Week 2</a:t>
+              <a:t>HONGXIAN AN · Presenting an Article · Week 2</a:t>
             </a:r>
           </a:p>
         </p:txBody>
@@ -3469,7 +3469,7 @@
         <p:spPr>
           <a:xfrm>
             <a:off x="731520" y="365760"/>
-            <a:ext cx="10058400" cy="548640"/>
+            <a:ext cx="10058400" cy="457200"/>
           </a:xfrm>
           <a:prstGeom prst="rect">
             <a:avLst/>
@@ -3484,7 +3484,7 @@
           <a:p>
             <a:pPr algn="l">
               <a:spcAft>
-                <a:spcPts val="400"/>
+                <a:spcPts val="200"/>
               </a:spcAft>
               <a:defRPr sz="3000" b="1">
                 <a:solidFill>
@@ -3494,7 +3494,7 @@
               </a:defRPr>
             </a:pPr>
             <a:r>
-              <a:t>Why Is This Topic Interesting?</a:t>
+              <a:t>Why Interesting?</a:t>
             </a:r>
           </a:p>
         </p:txBody>
@@ -3507,8 +3507,8 @@
         </p:nvSpPr>
         <p:spPr>
           <a:xfrm>
-            <a:off x="731520" y="960120"/>
-            <a:ext cx="2743200" cy="31750"/>
+            <a:off x="731520" y="868680"/>
+            <a:ext cx="2286000" cy="31750"/>
           </a:xfrm>
           <a:prstGeom prst="rect">
             <a:avLst/>
@@ -3550,7 +3550,7 @@
         </p:nvSpPr>
         <p:spPr>
           <a:xfrm>
-            <a:off x="731520" y="1371600"/>
+            <a:off x="731520" y="1463040"/>
             <a:ext cx="10515600" cy="4572000"/>
           </a:xfrm>
           <a:prstGeom prst="rect">
@@ -3566,9 +3566,9 @@
           <a:p>
             <a:pPr>
               <a:spcAft>
-                <a:spcPts val="800"/>
-              </a:spcAft>
-              <a:defRPr sz="2000">
+                <a:spcPts val="1000"/>
+              </a:spcAft>
+              <a:defRPr sz="2200">
                 <a:solidFill>
                   <a:srgbClr val="2D2240"/>
                 </a:solidFill>
@@ -3576,15 +3576,15 @@
               </a:defRPr>
             </a:pPr>
             <a:r>
-              <a:t>Futsal = 60M+ participants worldwide (FIFA)</a:t>
+              <a:t>60M+ futsal participants worldwide (FIFA)</a:t>
             </a:r>
           </a:p>
           <a:p>
             <a:pPr>
               <a:spcAft>
-                <a:spcPts val="800"/>
-              </a:spcAft>
-              <a:defRPr sz="2000">
+                <a:spcPts val="1000"/>
+              </a:spcAft>
+              <a:defRPr sz="2200">
                 <a:solidFill>
                   <a:srgbClr val="2D2240"/>
                 </a:solidFill>
@@ -3592,15 +3592,15 @@
               </a:defRPr>
             </a:pPr>
             <a:r>
-              <a:t>Pelé · Ronaldinho · Neymar → all credit futsal background</a:t>
+              <a:t>Pelé · Ronaldinho · Neymar — futsal background</a:t>
             </a:r>
           </a:p>
           <a:p>
             <a:pPr>
               <a:spcAft>
-                <a:spcPts val="800"/>
-              </a:spcAft>
-              <a:defRPr sz="2000">
+                <a:spcPts val="1000"/>
+              </a:spcAft>
+              <a:defRPr sz="2200">
                 <a:solidFill>
                   <a:srgbClr val="2D2240"/>
                 </a:solidFill>
@@ -3608,15 +3608,15 @@
               </a:defRPr>
             </a:pPr>
             <a:r>
-              <a:t>Donor sport concept: decades of coaching belief, minimal empirical testing</a:t>
+              <a:t>Donor sport: decades of belief, minimal evidence</a:t>
             </a:r>
           </a:p>
           <a:p>
             <a:pPr>
               <a:spcAft>
-                <a:spcPts val="800"/>
-              </a:spcAft>
-              <a:defRPr sz="2000">
+                <a:spcPts val="1000"/>
+              </a:spcAft>
+              <a:defRPr sz="2200">
                 <a:solidFill>
                   <a:srgbClr val="2D2240"/>
                 </a:solidFill>
@@ -3624,15 +3624,15 @@
               </a:defRPr>
             </a:pPr>
             <a:r>
-              <a:t>First quantitative synthesis of futsal-to-soccer transfer</a:t>
+              <a:t>First quantitative synthesis of this topic</a:t>
             </a:r>
           </a:p>
           <a:p>
             <a:pPr>
               <a:spcAft>
-                <a:spcPts val="800"/>
-              </a:spcAft>
-              <a:defRPr sz="2000">
+                <a:spcPts val="1000"/>
+              </a:spcAft>
+              <a:defRPr sz="2200">
                 <a:solidFill>
                   <a:srgbClr val="2D2240"/>
                 </a:solidFill>
@@ -3640,7 +3640,7 @@
               </a:defRPr>
             </a:pPr>
             <a:r>
-              <a:t>Early diversification vs. early specialization — stakes for talent development</a:t>
+              <a:t>Early diversification vs. specialization debate</a:t>
             </a:r>
           </a:p>
         </p:txBody>
@@ -3723,7 +3723,7 @@
         <p:spPr>
           <a:xfrm>
             <a:off x="731520" y="365760"/>
-            <a:ext cx="10058400" cy="548640"/>
+            <a:ext cx="10058400" cy="457200"/>
           </a:xfrm>
           <a:prstGeom prst="rect">
             <a:avLst/>
@@ -3738,7 +3738,7 @@
           <a:p>
             <a:pPr algn="l">
               <a:spcAft>
-                <a:spcPts val="400"/>
+                <a:spcPts val="200"/>
               </a:spcAft>
               <a:defRPr sz="3000" b="1">
                 <a:solidFill>
@@ -3761,8 +3761,8 @@
         </p:nvSpPr>
         <p:spPr>
           <a:xfrm>
-            <a:off x="731520" y="960120"/>
-            <a:ext cx="2743200" cy="31750"/>
+            <a:off x="731520" y="868680"/>
+            <a:ext cx="2286000" cy="31750"/>
           </a:xfrm>
           <a:prstGeom prst="rect">
             <a:avLst/>
@@ -3805,7 +3805,7 @@
         <p:spPr>
           <a:xfrm>
             <a:off x="731520" y="1371600"/>
-            <a:ext cx="5303520" cy="4114800"/>
+            <a:ext cx="5303520" cy="4572000"/>
           </a:xfrm>
           <a:prstGeom prst="rect">
             <a:avLst/>
@@ -3820,9 +3820,9 @@
           <a:p>
             <a:pPr>
               <a:spcAft>
-                <a:spcPts val="800"/>
-              </a:spcAft>
-              <a:defRPr sz="1800">
+                <a:spcPts val="1000"/>
+              </a:spcAft>
+              <a:defRPr sz="2000">
                 <a:solidFill>
                   <a:srgbClr val="2D2240"/>
                 </a:solidFill>
@@ -3836,9 +3836,9 @@
           <a:p>
             <a:pPr>
               <a:spcAft>
-                <a:spcPts val="800"/>
-              </a:spcAft>
-              <a:defRPr sz="1800">
+                <a:spcPts val="1000"/>
+              </a:spcAft>
+              <a:defRPr sz="2000">
                 <a:solidFill>
                   <a:srgbClr val="2D2240"/>
                 </a:solidFill>
@@ -3846,15 +3846,15 @@
               </a:defRPr>
             </a:pPr>
             <a:r>
-              <a:t>3 databases: Scopus · ScienceDirect · WoS</a:t>
+              <a:t>3 databases</a:t>
             </a:r>
           </a:p>
           <a:p>
             <a:pPr>
               <a:spcAft>
-                <a:spcPts val="800"/>
-              </a:spcAft>
-              <a:defRPr sz="1800">
+                <a:spcPts val="1000"/>
+              </a:spcAft>
+              <a:defRPr sz="2000">
                 <a:solidFill>
                   <a:srgbClr val="2D2240"/>
                 </a:solidFill>
@@ -3868,9 +3868,9 @@
           <a:p>
             <a:pPr>
               <a:spcAft>
-                <a:spcPts val="800"/>
-              </a:spcAft>
-              <a:defRPr sz="1800">
+                <a:spcPts val="1000"/>
+              </a:spcAft>
+              <a:defRPr sz="2000">
                 <a:solidFill>
                   <a:srgbClr val="2D2240"/>
                 </a:solidFill>
@@ -3884,9 +3884,9 @@
           <a:p>
             <a:pPr>
               <a:spcAft>
-                <a:spcPts val="800"/>
-              </a:spcAft>
-              <a:defRPr sz="1800">
+                <a:spcPts val="1000"/>
+              </a:spcAft>
+              <a:defRPr sz="2000">
                 <a:solidFill>
                   <a:srgbClr val="2D2240"/>
                 </a:solidFill>
@@ -3894,7 +3894,7 @@
               </a:defRPr>
             </a:pPr>
             <a:r>
-              <a:t>Random-effects meta-analysis · Hedges' g · I²</a:t>
+              <a:t>Random-effects · Hedges' g · I²</a:t>
             </a:r>
           </a:p>
         </p:txBody>
@@ -3908,7 +3908,7 @@
         <p:spPr>
           <a:xfrm>
             <a:off x="6583680" y="1371600"/>
-            <a:ext cx="19050" cy="4572000"/>
+            <a:ext cx="19050" cy="4754880"/>
           </a:xfrm>
           <a:prstGeom prst="rect">
             <a:avLst/>
@@ -3951,7 +3951,7 @@
         <p:spPr>
           <a:xfrm>
             <a:off x="7132320" y="1371600"/>
-            <a:ext cx="4389120" cy="365760"/>
+            <a:ext cx="4389120" cy="274320"/>
           </a:xfrm>
           <a:prstGeom prst="rect">
             <a:avLst/>
@@ -3966,9 +3966,9 @@
           <a:p>
             <a:pPr algn="l">
               <a:spcAft>
-                <a:spcPts val="400"/>
-              </a:spcAft>
-              <a:defRPr sz="1400" b="0">
+                <a:spcPts val="200"/>
+              </a:spcAft>
+              <a:defRPr sz="1300" b="0">
                 <a:solidFill>
                   <a:srgbClr val="999999"/>
                 </a:solidFill>
@@ -3989,8 +3989,8 @@
         </p:nvSpPr>
         <p:spPr>
           <a:xfrm>
-            <a:off x="7132320" y="1645920"/>
-            <a:ext cx="4389120" cy="548640"/>
+            <a:off x="7132320" y="1737360"/>
+            <a:ext cx="4389120" cy="640080"/>
           </a:xfrm>
           <a:prstGeom prst="rect">
             <a:avLst/>
@@ -4005,9 +4005,9 @@
           <a:p>
             <a:pPr algn="l">
               <a:spcAft>
-                <a:spcPts val="400"/>
-              </a:spcAft>
-              <a:defRPr sz="3000" b="1">
+                <a:spcPts val="200"/>
+              </a:spcAft>
+              <a:defRPr sz="3600" b="1">
                 <a:solidFill>
                   <a:srgbClr val="2E7D32"/>
                 </a:solidFill>
@@ -4028,8 +4028,8 @@
         </p:nvSpPr>
         <p:spPr>
           <a:xfrm>
-            <a:off x="7132320" y="2468880"/>
-            <a:ext cx="4389120" cy="365760"/>
+            <a:off x="7132320" y="2560320"/>
+            <a:ext cx="4389120" cy="274320"/>
           </a:xfrm>
           <a:prstGeom prst="rect">
             <a:avLst/>
@@ -4044,9 +4044,9 @@
           <a:p>
             <a:pPr algn="l">
               <a:spcAft>
-                <a:spcPts val="400"/>
-              </a:spcAft>
-              <a:defRPr sz="1400" b="0">
+                <a:spcPts val="200"/>
+              </a:spcAft>
+              <a:defRPr sz="1300" b="0">
                 <a:solidFill>
                   <a:srgbClr val="999999"/>
                 </a:solidFill>
@@ -4067,8 +4067,8 @@
         </p:nvSpPr>
         <p:spPr>
           <a:xfrm>
-            <a:off x="7132320" y="2743200"/>
-            <a:ext cx="4389120" cy="548640"/>
+            <a:off x="7132320" y="2926080"/>
+            <a:ext cx="4389120" cy="640080"/>
           </a:xfrm>
           <a:prstGeom prst="rect">
             <a:avLst/>
@@ -4083,9 +4083,9 @@
           <a:p>
             <a:pPr algn="l">
               <a:spcAft>
-                <a:spcPts val="400"/>
-              </a:spcAft>
-              <a:defRPr sz="2600" b="1">
+                <a:spcPts val="200"/>
+              </a:spcAft>
+              <a:defRPr sz="3000" b="1">
                 <a:solidFill>
                   <a:srgbClr val="E65100"/>
                 </a:solidFill>
@@ -4106,8 +4106,8 @@
         </p:nvSpPr>
         <p:spPr>
           <a:xfrm>
-            <a:off x="7132320" y="3566160"/>
-            <a:ext cx="4389120" cy="365760"/>
+            <a:off x="7132320" y="3749039"/>
+            <a:ext cx="4389120" cy="274320"/>
           </a:xfrm>
           <a:prstGeom prst="rect">
             <a:avLst/>
@@ -4122,9 +4122,9 @@
           <a:p>
             <a:pPr algn="l">
               <a:spcAft>
-                <a:spcPts val="400"/>
-              </a:spcAft>
-              <a:defRPr sz="1400" b="0">
+                <a:spcPts val="200"/>
+              </a:spcAft>
+              <a:defRPr sz="1300" b="0">
                 <a:solidFill>
                   <a:srgbClr val="999999"/>
                 </a:solidFill>
@@ -4145,8 +4145,8 @@
         </p:nvSpPr>
         <p:spPr>
           <a:xfrm>
-            <a:off x="7132320" y="3840480"/>
-            <a:ext cx="4389120" cy="548640"/>
+            <a:off x="7132320" y="4114800"/>
+            <a:ext cx="4389120" cy="640080"/>
           </a:xfrm>
           <a:prstGeom prst="rect">
             <a:avLst/>
@@ -4161,9 +4161,9 @@
           <a:p>
             <a:pPr algn="l">
               <a:spcAft>
-                <a:spcPts val="400"/>
-              </a:spcAft>
-              <a:defRPr sz="3000" b="1">
+                <a:spcPts val="200"/>
+              </a:spcAft>
+              <a:defRPr sz="3600" b="1">
                 <a:solidFill>
                   <a:srgbClr val="7E57C2"/>
                 </a:solidFill>
@@ -4184,8 +4184,8 @@
         </p:nvSpPr>
         <p:spPr>
           <a:xfrm>
-            <a:off x="7132320" y="4754880"/>
-            <a:ext cx="4389120" cy="365760"/>
+            <a:off x="7132320" y="5029200"/>
+            <a:ext cx="4389120" cy="274320"/>
           </a:xfrm>
           <a:prstGeom prst="rect">
             <a:avLst/>
@@ -4200,9 +4200,9 @@
           <a:p>
             <a:pPr algn="l">
               <a:spcAft>
-                <a:spcPts val="400"/>
-              </a:spcAft>
-              <a:defRPr sz="1400" b="0">
+                <a:spcPts val="200"/>
+              </a:spcAft>
+              <a:defRPr sz="1300" b="0">
                 <a:solidFill>
                   <a:srgbClr val="999999"/>
                 </a:solidFill>
@@ -4210,7 +4210,7 @@
               </a:defRPr>
             </a:pPr>
             <a:r>
-              <a:t>Studies included</a:t>
+              <a:t>N</a:t>
             </a:r>
           </a:p>
         </p:txBody>
@@ -4223,8 +4223,8 @@
         </p:nvSpPr>
         <p:spPr>
           <a:xfrm>
-            <a:off x="7132320" y="5029200"/>
-            <a:ext cx="4389120" cy="548640"/>
+            <a:off x="7132320" y="5394960"/>
+            <a:ext cx="4389120" cy="640080"/>
           </a:xfrm>
           <a:prstGeom prst="rect">
             <a:avLst/>
@@ -4239,9 +4239,9 @@
           <a:p>
             <a:pPr algn="l">
               <a:spcAft>
-                <a:spcPts val="400"/>
-              </a:spcAft>
-              <a:defRPr sz="3000" b="1">
+                <a:spcPts val="200"/>
+              </a:spcAft>
+              <a:defRPr sz="3600" b="1">
                 <a:solidFill>
                   <a:srgbClr val="2D2240"/>
                 </a:solidFill>
@@ -4249,7 +4249,7 @@
               </a:defRPr>
             </a:pPr>
             <a:r>
-              <a:t>N = 7</a:t>
+              <a:t>7</a:t>
             </a:r>
           </a:p>
         </p:txBody>
@@ -4332,7 +4332,7 @@
         <p:spPr>
           <a:xfrm>
             <a:off x="731520" y="365760"/>
-            <a:ext cx="10058400" cy="548640"/>
+            <a:ext cx="10058400" cy="457200"/>
           </a:xfrm>
           <a:prstGeom prst="rect">
             <a:avLst/>
@@ -4347,7 +4347,7 @@
           <a:p>
             <a:pPr algn="l">
               <a:spcAft>
-                <a:spcPts val="400"/>
+                <a:spcPts val="200"/>
               </a:spcAft>
               <a:defRPr sz="3000" b="1">
                 <a:solidFill>
@@ -4370,8 +4370,8 @@
         </p:nvSpPr>
         <p:spPr>
           <a:xfrm>
-            <a:off x="731520" y="960120"/>
-            <a:ext cx="2743200" cy="31750"/>
+            <a:off x="731520" y="868680"/>
+            <a:ext cx="2286000" cy="31750"/>
           </a:xfrm>
           <a:prstGeom prst="rect">
             <a:avLst/>
@@ -4429,9 +4429,9 @@
           <a:p>
             <a:pPr algn="l">
               <a:spcAft>
-                <a:spcPts val="400"/>
-              </a:spcAft>
-              <a:defRPr sz="2200" b="1">
+                <a:spcPts val="200"/>
+              </a:spcAft>
+              <a:defRPr sz="2400" b="1">
                 <a:solidFill>
                   <a:srgbClr val="2E7D32"/>
                 </a:solidFill>
@@ -4439,7 +4439,7 @@
               </a:defRPr>
             </a:pPr>
             <a:r>
-              <a:t>✅  PASSING: Strong Transfer</a:t>
+              <a:t>✅  PASSING</a:t>
             </a:r>
           </a:p>
         </p:txBody>
@@ -4452,7 +4452,7 @@
         </p:nvSpPr>
         <p:spPr>
           <a:xfrm>
-            <a:off x="1463040" y="1920240"/>
+            <a:off x="1463040" y="1965960"/>
             <a:ext cx="8686800" cy="320040"/>
           </a:xfrm>
           <a:prstGeom prst="rect">
@@ -4468,9 +4468,9 @@
           <a:p>
             <a:pPr algn="l">
               <a:spcAft>
-                <a:spcPts val="400"/>
-              </a:spcAft>
-              <a:defRPr sz="1700" b="0">
+                <a:spcPts val="200"/>
+              </a:spcAft>
+              <a:defRPr sz="1800" b="0">
                 <a:solidFill>
                   <a:srgbClr val="2D2240"/>
                 </a:solidFill>
@@ -4491,7 +4491,7 @@
         </p:nvSpPr>
         <p:spPr>
           <a:xfrm>
-            <a:off x="1463040" y="2267712"/>
+            <a:off x="1463040" y="2313432"/>
             <a:ext cx="8686800" cy="320040"/>
           </a:xfrm>
           <a:prstGeom prst="rect">
@@ -4507,9 +4507,9 @@
           <a:p>
             <a:pPr algn="l">
               <a:spcAft>
-                <a:spcPts val="400"/>
-              </a:spcAft>
-              <a:defRPr sz="1700" b="0">
+                <a:spcPts val="200"/>
+              </a:spcAft>
+              <a:defRPr sz="1800" b="0">
                 <a:solidFill>
                   <a:srgbClr val="2D2240"/>
                 </a:solidFill>
@@ -4517,7 +4517,7 @@
               </a:defRPr>
             </a:pPr>
             <a:r>
-              <a:t>Low-bounce ball → ↓ control demand → ↑ attention for decisions</a:t>
+              <a:t>Low-bounce ball → easier control</a:t>
             </a:r>
           </a:p>
         </p:txBody>
@@ -4530,7 +4530,7 @@
         </p:nvSpPr>
         <p:spPr>
           <a:xfrm>
-            <a:off x="1463040" y="2615184"/>
+            <a:off x="1463040" y="2660904"/>
             <a:ext cx="8686800" cy="320040"/>
           </a:xfrm>
           <a:prstGeom prst="rect">
@@ -4546,9 +4546,9 @@
           <a:p>
             <a:pPr algn="l">
               <a:spcAft>
-                <a:spcPts val="400"/>
-              </a:spcAft>
-              <a:defRPr sz="1700" b="0">
+                <a:spcPts val="200"/>
+              </a:spcAft>
+              <a:defRPr sz="1800" b="0">
                 <a:solidFill>
                   <a:srgbClr val="2D2240"/>
                 </a:solidFill>
@@ -4556,7 +4556,7 @@
               </a:defRPr>
             </a:pPr>
             <a:r>
-              <a:t>Effect transfers to soccer context</a:t>
+              <a:t>Transfers to soccer</a:t>
             </a:r>
           </a:p>
         </p:txBody>
@@ -4569,7 +4569,7 @@
         </p:nvSpPr>
         <p:spPr>
           <a:xfrm>
-            <a:off x="1097280" y="2971800"/>
+            <a:off x="1097280" y="3017520"/>
             <a:ext cx="9601200" cy="6350"/>
           </a:xfrm>
           <a:prstGeom prst="rect">
@@ -4628,9 +4628,9 @@
           <a:p>
             <a:pPr algn="l">
               <a:spcAft>
-                <a:spcPts val="400"/>
-              </a:spcAft>
-              <a:defRPr sz="2200" b="1">
+                <a:spcPts val="200"/>
+              </a:spcAft>
+              <a:defRPr sz="2400" b="1">
                 <a:solidFill>
                   <a:srgbClr val="E65100"/>
                 </a:solidFill>
@@ -4638,7 +4638,7 @@
               </a:defRPr>
             </a:pPr>
             <a:r>
-              <a:t>⚠️  SPEED &amp; AGILITY: Context-Dependent</a:t>
+              <a:t>⚠️  SPEED &amp; AGILITY</a:t>
             </a:r>
           </a:p>
         </p:txBody>
@@ -4651,7 +4651,7 @@
         </p:nvSpPr>
         <p:spPr>
           <a:xfrm>
-            <a:off x="1463040" y="3703320"/>
+            <a:off x="1463040" y="3749040"/>
             <a:ext cx="8686800" cy="320040"/>
           </a:xfrm>
           <a:prstGeom prst="rect">
@@ -4667,9 +4667,9 @@
           <a:p>
             <a:pPr algn="l">
               <a:spcAft>
-                <a:spcPts val="400"/>
-              </a:spcAft>
-              <a:defRPr sz="1700" b="0">
+                <a:spcPts val="200"/>
+              </a:spcAft>
+              <a:defRPr sz="1800" b="0">
                 <a:solidFill>
                   <a:srgbClr val="2D2240"/>
                 </a:solidFill>
@@ -4690,7 +4690,7 @@
         </p:nvSpPr>
         <p:spPr>
           <a:xfrm>
-            <a:off x="1463040" y="4050791"/>
+            <a:off x="1463040" y="4096512"/>
             <a:ext cx="8686800" cy="320040"/>
           </a:xfrm>
           <a:prstGeom prst="rect">
@@ -4706,9 +4706,9 @@
           <a:p>
             <a:pPr algn="l">
               <a:spcAft>
-                <a:spcPts val="400"/>
-              </a:spcAft>
-              <a:defRPr sz="1700" b="0">
+                <a:spcPts val="200"/>
+              </a:spcAft>
+              <a:defRPr sz="1800" b="0">
                 <a:solidFill>
                   <a:srgbClr val="2D2240"/>
                 </a:solidFill>
@@ -4716,7 +4716,7 @@
               </a:defRPr>
             </a:pPr>
             <a:r>
-              <a:t>Field-based: futsal &gt; soccer</a:t>
+              <a:t>Field: futsal &gt; soccer</a:t>
             </a:r>
           </a:p>
         </p:txBody>
@@ -4729,7 +4729,7 @@
         </p:nvSpPr>
         <p:spPr>
           <a:xfrm>
-            <a:off x="1463040" y="4398264"/>
+            <a:off x="1463040" y="4443984"/>
             <a:ext cx="8686800" cy="320040"/>
           </a:xfrm>
           <a:prstGeom prst="rect">
@@ -4745,9 +4745,9 @@
           <a:p>
             <a:pPr algn="l">
               <a:spcAft>
-                <a:spcPts val="400"/>
-              </a:spcAft>
-              <a:defRPr sz="1700" b="0">
+                <a:spcPts val="200"/>
+              </a:spcAft>
+              <a:defRPr sz="1800" b="0">
                 <a:solidFill>
                   <a:srgbClr val="2D2240"/>
                 </a:solidFill>
@@ -4755,7 +4755,7 @@
               </a:defRPr>
             </a:pPr>
             <a:r>
-              <a:t>Lab-based: futsal ≤ soccer</a:t>
+              <a:t>Lab: futsal ≤ soccer</a:t>
             </a:r>
           </a:p>
         </p:txBody>
@@ -4768,7 +4768,7 @@
         </p:nvSpPr>
         <p:spPr>
           <a:xfrm>
-            <a:off x="1097280" y="4754880"/>
+            <a:off x="1097280" y="4800600"/>
             <a:ext cx="9601200" cy="6350"/>
           </a:xfrm>
           <a:prstGeom prst="rect">
@@ -4827,9 +4827,9 @@
           <a:p>
             <a:pPr algn="l">
               <a:spcAft>
-                <a:spcPts val="400"/>
-              </a:spcAft>
-              <a:defRPr sz="2200" b="1">
+                <a:spcPts val="200"/>
+              </a:spcAft>
+              <a:defRPr sz="2400" b="1">
                 <a:solidFill>
                   <a:srgbClr val="C62828"/>
                 </a:solidFill>
@@ -4837,7 +4837,7 @@
               </a:defRPr>
             </a:pPr>
             <a:r>
-              <a:t>❌  DRIBBLING: Sport-Specific</a:t>
+              <a:t>❌  DRIBBLING</a:t>
             </a:r>
           </a:p>
         </p:txBody>
@@ -4850,7 +4850,7 @@
         </p:nvSpPr>
         <p:spPr>
           <a:xfrm>
-            <a:off x="1463040" y="5486400"/>
+            <a:off x="1463040" y="5532120"/>
             <a:ext cx="8686800" cy="320040"/>
           </a:xfrm>
           <a:prstGeom prst="rect">
@@ -4866,9 +4866,9 @@
           <a:p>
             <a:pPr algn="l">
               <a:spcAft>
-                <a:spcPts val="400"/>
-              </a:spcAft>
-              <a:defRPr sz="1700" b="0">
+                <a:spcPts val="200"/>
+              </a:spcAft>
+              <a:defRPr sz="1800" b="0">
                 <a:solidFill>
                   <a:srgbClr val="2D2240"/>
                 </a:solidFill>
@@ -4876,7 +4876,7 @@
               </a:defRPr>
             </a:pPr>
             <a:r>
-              <a:t>Futsal: close distance + high velocity</a:t>
+              <a:t>Futsal: distance + velocity</a:t>
             </a:r>
           </a:p>
         </p:txBody>
@@ -4889,7 +4889,7 @@
         </p:nvSpPr>
         <p:spPr>
           <a:xfrm>
-            <a:off x="1463040" y="5833872"/>
+            <a:off x="1463040" y="5879592"/>
             <a:ext cx="8686800" cy="320040"/>
           </a:xfrm>
           <a:prstGeom prst="rect">
@@ -4905,9 +4905,9 @@
           <a:p>
             <a:pPr algn="l">
               <a:spcAft>
-                <a:spcPts val="400"/>
-              </a:spcAft>
-              <a:defRPr sz="1700" b="0">
+                <a:spcPts val="200"/>
+              </a:spcAft>
+              <a:defRPr sz="1800" b="0">
                 <a:solidFill>
                   <a:srgbClr val="2D2240"/>
                 </a:solidFill>
@@ -4915,7 +4915,7 @@
               </a:defRPr>
             </a:pPr>
             <a:r>
-              <a:t>Soccer: defender's RT</a:t>
+              <a:t>Soccer: defender RT</a:t>
             </a:r>
           </a:p>
         </p:txBody>
@@ -4928,7 +4928,7 @@
         </p:nvSpPr>
         <p:spPr>
           <a:xfrm>
-            <a:off x="1463040" y="6181344"/>
+            <a:off x="1463040" y="6227064"/>
             <a:ext cx="8686800" cy="320040"/>
           </a:xfrm>
           <a:prstGeom prst="rect">
@@ -4944,9 +4944,9 @@
           <a:p>
             <a:pPr algn="l">
               <a:spcAft>
-                <a:spcPts val="400"/>
-              </a:spcAft>
-              <a:defRPr sz="1700" b="0">
+                <a:spcPts val="200"/>
+              </a:spcAft>
+              <a:defRPr sz="1800" b="0">
                 <a:solidFill>
                   <a:srgbClr val="2D2240"/>
                 </a:solidFill>
@@ -5037,7 +5037,7 @@
         <p:spPr>
           <a:xfrm>
             <a:off x="731520" y="365760"/>
-            <a:ext cx="10058400" cy="548640"/>
+            <a:ext cx="10058400" cy="457200"/>
           </a:xfrm>
           <a:prstGeom prst="rect">
             <a:avLst/>
@@ -5052,7 +5052,7 @@
           <a:p>
             <a:pPr algn="l">
               <a:spcAft>
-                <a:spcPts val="400"/>
+                <a:spcPts val="200"/>
               </a:spcAft>
               <a:defRPr sz="3000" b="1">
                 <a:solidFill>
@@ -5075,8 +5075,8 @@
         </p:nvSpPr>
         <p:spPr>
           <a:xfrm>
-            <a:off x="731520" y="960120"/>
-            <a:ext cx="2743200" cy="31750"/>
+            <a:off x="731520" y="868680"/>
+            <a:ext cx="2286000" cy="31750"/>
           </a:xfrm>
           <a:prstGeom prst="rect">
             <a:avLst/>
@@ -5134,7 +5134,7 @@
           <a:p>
             <a:pPr algn="l">
               <a:spcAft>
-                <a:spcPts val="400"/>
+                <a:spcPts val="200"/>
               </a:spcAft>
               <a:defRPr sz="2000" b="1">
                 <a:solidFill>
@@ -5144,7 +5144,7 @@
               </a:defRPr>
             </a:pPr>
             <a:r>
-              <a:t>🧠  Cognitive Development</a:t>
+              <a:t>🧠  Cognitive</a:t>
             </a:r>
           </a:p>
         </p:txBody>
@@ -5158,7 +5158,7 @@
         <p:spPr>
           <a:xfrm>
             <a:off x="1097280" y="1920240"/>
-            <a:ext cx="4846320" cy="2743200"/>
+            <a:ext cx="4846320" cy="3200400"/>
           </a:xfrm>
           <a:prstGeom prst="rect">
             <a:avLst/>
@@ -5173,9 +5173,9 @@
           <a:p>
             <a:pPr>
               <a:spcAft>
-                <a:spcPts val="800"/>
-              </a:spcAft>
-              <a:defRPr sz="1700">
+                <a:spcPts val="1000"/>
+              </a:spcAft>
+              <a:defRPr sz="1800">
                 <a:solidFill>
                   <a:srgbClr val="2D2240"/>
                 </a:solidFill>
@@ -5183,15 +5183,15 @@
               </a:defRPr>
             </a:pPr>
             <a:r>
-              <a:t>Early futsal deliberate practice (6–12y, 13–15y)</a:t>
+              <a:t>Early futsal practice (6–15y)</a:t>
             </a:r>
           </a:p>
           <a:p>
             <a:pPr>
               <a:spcAft>
-                <a:spcPts val="800"/>
-              </a:spcAft>
-              <a:defRPr sz="1700">
+                <a:spcPts val="1000"/>
+              </a:spcAft>
+              <a:defRPr sz="1800">
                 <a:solidFill>
                   <a:srgbClr val="2D2240"/>
                 </a:solidFill>
@@ -5199,15 +5199,15 @@
               </a:defRPr>
             </a:pPr>
             <a:r>
-              <a:t>→ Higher offensive decision-making quality (adult)</a:t>
+              <a:t>→ Adult decision-making quality ↑</a:t>
             </a:r>
           </a:p>
           <a:p>
             <a:pPr>
               <a:spcAft>
-                <a:spcPts val="800"/>
-              </a:spcAft>
-              <a:defRPr sz="1700">
+                <a:spcPts val="1000"/>
+              </a:spcAft>
+              <a:defRPr sz="1800">
                 <a:solidFill>
                   <a:srgbClr val="2D2240"/>
                 </a:solidFill>
@@ -5216,22 +5216,6 @@
             </a:pPr>
             <a:r>
               <a:t>Machado et al. (2023, 2024)</a:t>
-            </a:r>
-          </a:p>
-          <a:p>
-            <a:pPr>
-              <a:spcAft>
-                <a:spcPts val="800"/>
-              </a:spcAft>
-              <a:defRPr sz="1700">
-                <a:solidFill>
-                  <a:srgbClr val="2D2240"/>
-                </a:solidFill>
-                <a:latin typeface="Segoe UI"/>
-              </a:defRPr>
-            </a:pPr>
-            <a:r>
-              <a:t>Brazilian professional female players</a:t>
             </a:r>
           </a:p>
         </p:txBody>
@@ -5303,7 +5287,7 @@
           <a:p>
             <a:pPr algn="l">
               <a:spcAft>
-                <a:spcPts val="400"/>
+                <a:spcPts val="200"/>
               </a:spcAft>
               <a:defRPr sz="2000" b="1">
                 <a:solidFill>
@@ -5342,7 +5326,7 @@
           <a:p>
             <a:pPr>
               <a:spcAft>
-                <a:spcPts val="800"/>
+                <a:spcPts val="1000"/>
               </a:spcAft>
               <a:defRPr sz="1600">
                 <a:solidFill>
@@ -5352,13 +5336,13 @@
               </a:defRPr>
             </a:pPr>
             <a:r>
-              <a:t>N = 7 only</a:t>
+              <a:t>N = 7</a:t>
             </a:r>
           </a:p>
           <a:p>
             <a:pPr>
               <a:spcAft>
-                <a:spcPts val="800"/>
+                <a:spcPts val="1000"/>
               </a:spcAft>
               <a:defRPr sz="1600">
                 <a:solidFill>
@@ -5368,13 +5352,13 @@
               </a:defRPr>
             </a:pPr>
             <a:r>
-              <a:t>Cross-sectional (no longitudinal)</a:t>
+              <a:t>Cross-sectional</a:t>
             </a:r>
           </a:p>
           <a:p>
             <a:pPr>
               <a:spcAft>
-                <a:spcPts val="800"/>
+                <a:spcPts val="1000"/>
               </a:spcAft>
               <a:defRPr sz="1600">
                 <a:solidFill>
@@ -5384,13 +5368,13 @@
               </a:defRPr>
             </a:pPr>
             <a:r>
-              <a:t>Dose-response unknown</a:t>
+              <a:t>No longitudinal</a:t>
             </a:r>
           </a:p>
           <a:p>
             <a:pPr>
               <a:spcAft>
-                <a:spcPts val="800"/>
+                <a:spcPts val="1000"/>
               </a:spcAft>
               <a:defRPr sz="1600">
                 <a:solidFill>
@@ -5400,13 +5384,13 @@
               </a:defRPr>
             </a:pPr>
             <a:r>
-              <a:t>Language: EN/ES/PT</a:t>
+              <a:t>Dose-response: unknown</a:t>
             </a:r>
           </a:p>
           <a:p>
             <a:pPr>
               <a:spcAft>
-                <a:spcPts val="800"/>
+                <a:spcPts val="1000"/>
               </a:spcAft>
               <a:defRPr sz="1600">
                 <a:solidFill>
@@ -5416,46 +5400,7 @@
               </a:defRPr>
             </a:pPr>
             <a:r>
-              <a:t>Inter-rater reliability: n/a</a:t>
-            </a:r>
-          </a:p>
-        </p:txBody>
-      </p:sp>
-      <p:sp>
-        <p:nvSpPr>
-          <p:cNvPr id="10" name="TextBox 9"/>
-          <p:cNvSpPr txBox="1"/>
-          <p:nvPr/>
-        </p:nvSpPr>
-        <p:spPr>
-          <a:xfrm>
-            <a:off x="731520" y="5760720"/>
-            <a:ext cx="10515600" cy="274320"/>
-          </a:xfrm>
-          <a:prstGeom prst="rect">
-            <a:avLst/>
-          </a:prstGeom>
-          <a:noFill/>
-        </p:spPr>
-        <p:txBody>
-          <a:bodyPr wrap="square">
-            <a:spAutoFit/>
-          </a:bodyPr>
-          <a:lstStyle/>
-          <a:p>
-            <a:pPr algn="l">
-              <a:spcAft>
-                <a:spcPts val="400"/>
-              </a:spcAft>
-              <a:defRPr sz="1400" b="0">
-                <a:solidFill>
-                  <a:srgbClr val="999999"/>
-                </a:solidFill>
-                <a:latin typeface="Segoe UI"/>
-              </a:defRPr>
-            </a:pPr>
-            <a:r>
-              <a:t>→ Authors openly acknowledge these gaps</a:t>
+              <a:t>No negative transfer data</a:t>
             </a:r>
           </a:p>
         </p:txBody>
@@ -5538,7 +5483,7 @@
         <p:spPr>
           <a:xfrm>
             <a:off x="731520" y="365760"/>
-            <a:ext cx="10058400" cy="548640"/>
+            <a:ext cx="10058400" cy="457200"/>
           </a:xfrm>
           <a:prstGeom prst="rect">
             <a:avLst/>
@@ -5553,7 +5498,7 @@
           <a:p>
             <a:pPr algn="l">
               <a:spcAft>
-                <a:spcPts val="400"/>
+                <a:spcPts val="200"/>
               </a:spcAft>
               <a:defRPr sz="3000" b="1">
                 <a:solidFill>
@@ -5576,8 +5521,8 @@
         </p:nvSpPr>
         <p:spPr>
           <a:xfrm>
-            <a:off x="731520" y="960120"/>
-            <a:ext cx="2743200" cy="31750"/>
+            <a:off x="731520" y="868680"/>
+            <a:ext cx="2286000" cy="31750"/>
           </a:xfrm>
           <a:prstGeom prst="rect">
             <a:avLst/>
@@ -5620,7 +5565,7 @@
         <p:spPr>
           <a:xfrm>
             <a:off x="731520" y="1371600"/>
-            <a:ext cx="5303520" cy="365760"/>
+            <a:ext cx="5029200" cy="365760"/>
           </a:xfrm>
           <a:prstGeom prst="rect">
             <a:avLst/>
@@ -5635,7 +5580,7 @@
           <a:p>
             <a:pPr algn="l">
               <a:spcAft>
-                <a:spcPts val="400"/>
+                <a:spcPts val="200"/>
               </a:spcAft>
               <a:defRPr sz="2000" b="1">
                 <a:solidFill>
@@ -5674,9 +5619,9 @@
           <a:p>
             <a:pPr>
               <a:spcAft>
-                <a:spcPts val="800"/>
-              </a:spcAft>
-              <a:defRPr sz="1700">
+                <a:spcPts val="1000"/>
+              </a:spcAft>
+              <a:defRPr sz="1800">
                 <a:solidFill>
                   <a:srgbClr val="2D2240"/>
                 </a:solidFill>
@@ -5684,15 +5629,15 @@
               </a:defRPr>
             </a:pPr>
             <a:r>
-              <a:t>Low-bounce ball in youth training</a:t>
+              <a:t>Low-bounce ball training</a:t>
             </a:r>
           </a:p>
           <a:p>
             <a:pPr>
               <a:spcAft>
-                <a:spcPts val="800"/>
-              </a:spcAft>
-              <a:defRPr sz="1700">
+                <a:spcPts val="1000"/>
+              </a:spcAft>
+              <a:defRPr sz="1800">
                 <a:solidFill>
                   <a:srgbClr val="2D2240"/>
                 </a:solidFill>
@@ -5700,15 +5645,15 @@
               </a:defRPr>
             </a:pPr>
             <a:r>
-              <a:t>Small-sided constraints → quick decisions</a:t>
+              <a:t>Small-sided constraints</a:t>
             </a:r>
           </a:p>
           <a:p>
             <a:pPr>
               <a:spcAft>
-                <a:spcPts val="800"/>
-              </a:spcAft>
-              <a:defRPr sz="1700">
+                <a:spcPts val="1000"/>
+              </a:spcAft>
+              <a:defRPr sz="1800">
                 <a:solidFill>
                   <a:srgbClr val="2D2240"/>
                 </a:solidFill>
@@ -5716,15 +5661,15 @@
               </a:defRPr>
             </a:pPr>
             <a:r>
-              <a:t>Early futsal exposure in talent pathway</a:t>
+              <a:t>Early futsal exposure</a:t>
             </a:r>
           </a:p>
           <a:p>
             <a:pPr>
               <a:spcAft>
-                <a:spcPts val="800"/>
-              </a:spcAft>
-              <a:defRPr sz="1700">
+                <a:spcPts val="1000"/>
+              </a:spcAft>
+              <a:defRPr sz="1800">
                 <a:solidFill>
                   <a:srgbClr val="2D2240"/>
                 </a:solidFill>
@@ -5732,7 +5677,7 @@
               </a:defRPr>
             </a:pPr>
             <a:r>
-              <a:t>Field-based testing (RVS-T), not lab RT</a:t>
+              <a:t>Field-based testing (RVS-T)</a:t>
             </a:r>
           </a:p>
         </p:txBody>
@@ -5804,7 +5749,7 @@
           <a:p>
             <a:pPr algn="l">
               <a:spcAft>
-                <a:spcPts val="400"/>
+                <a:spcPts val="200"/>
               </a:spcAft>
               <a:defRPr sz="2000" b="1">
                 <a:solidFill>
@@ -5843,7 +5788,7 @@
           <a:p>
             <a:pPr>
               <a:spcAft>
-                <a:spcPts val="800"/>
+                <a:spcPts val="1000"/>
               </a:spcAft>
               <a:defRPr sz="1500">
                 <a:solidFill>
@@ -5853,13 +5798,13 @@
               </a:defRPr>
             </a:pPr>
             <a:r>
-              <a:t>Age to introduce futsal?</a:t>
+              <a:t>Optimal age to start?</a:t>
             </a:r>
           </a:p>
           <a:p>
             <a:pPr>
               <a:spcAft>
-                <a:spcPts val="800"/>
+                <a:spcPts val="1000"/>
               </a:spcAft>
               <a:defRPr sz="1500">
                 <a:solidFill>
@@ -5869,13 +5814,13 @@
               </a:defRPr>
             </a:pPr>
             <a:r>
-              <a:t>When to transition → 11-a-side?</a:t>
+              <a:t>When to transition out?</a:t>
             </a:r>
           </a:p>
           <a:p>
             <a:pPr>
               <a:spcAft>
-                <a:spcPts val="800"/>
+                <a:spcPts val="1000"/>
               </a:spcAft>
               <a:defRPr sz="1500">
                 <a:solidFill>
@@ -5891,7 +5836,7 @@
           <a:p>
             <a:pPr>
               <a:spcAft>
-                <a:spcPts val="800"/>
+                <a:spcPts val="1000"/>
               </a:spcAft>
               <a:defRPr sz="1500">
                 <a:solidFill>
@@ -5901,13 +5846,13 @@
               </a:defRPr>
             </a:pPr>
             <a:r>
-              <a:t>Adult futsal → football: weaknesses?</a:t>
+              <a:t>Weaknesses of futsal → football?</a:t>
             </a:r>
           </a:p>
           <a:p>
             <a:pPr>
               <a:spcAft>
-                <a:spcPts val="800"/>
+                <a:spcPts val="1000"/>
               </a:spcAft>
               <a:defRPr sz="1500">
                 <a:solidFill>
@@ -5917,7 +5862,7 @@
               </a:defRPr>
             </a:pPr>
             <a:r>
-              <a:t>Offside · long passing · goalkeeping</a:t>
+              <a:t>Negative transfer evidence?</a:t>
             </a:r>
           </a:p>
         </p:txBody>
@@ -5931,7 +5876,7 @@
         <p:spPr>
           <a:xfrm>
             <a:off x="914400" y="5303520"/>
-            <a:ext cx="10332720" cy="731520"/>
+            <a:ext cx="10332720" cy="640080"/>
           </a:xfrm>
           <a:prstGeom prst="rect">
             <a:avLst/>
@@ -5973,8 +5918,8 @@
         </p:nvSpPr>
         <p:spPr>
           <a:xfrm>
-            <a:off x="1188720" y="5394960"/>
-            <a:ext cx="9784080" cy="548640"/>
+            <a:off x="1188720" y="5440680"/>
+            <a:ext cx="9784080" cy="411480"/>
           </a:xfrm>
           <a:prstGeom prst="rect">
             <a:avLst/>
@@ -5989,9 +5934,9 @@
           <a:p>
             <a:pPr algn="l">
               <a:spcAft>
-                <a:spcPts val="400"/>
-              </a:spcAft>
-              <a:defRPr sz="1700" b="1">
+                <a:spcPts val="200"/>
+              </a:spcAft>
+              <a:defRPr sz="1800" b="1">
                 <a:solidFill>
                   <a:srgbClr val="5B3A8C"/>
                 </a:solidFill>
@@ -5999,7 +5944,7 @@
               </a:defRPr>
             </a:pPr>
             <a:r>
-              <a:t>💡  Key gap: NEGATIVE TRANSFER — does futsal create bad habits for football?</a:t>
+              <a:t>💡  Almost no research on NEGATIVE TRANSFER</a:t>
             </a:r>
           </a:p>
         </p:txBody>
@@ -6082,7 +6027,7 @@
         <p:spPr>
           <a:xfrm>
             <a:off x="731520" y="365760"/>
-            <a:ext cx="10058400" cy="548640"/>
+            <a:ext cx="10058400" cy="457200"/>
           </a:xfrm>
           <a:prstGeom prst="rect">
             <a:avLst/>
@@ -6097,7 +6042,7 @@
           <a:p>
             <a:pPr algn="l">
               <a:spcAft>
-                <a:spcPts val="400"/>
+                <a:spcPts val="200"/>
               </a:spcAft>
               <a:defRPr sz="3000" b="1">
                 <a:solidFill>
@@ -6120,8 +6065,8 @@
         </p:nvSpPr>
         <p:spPr>
           <a:xfrm>
-            <a:off x="731520" y="960120"/>
-            <a:ext cx="2743200" cy="31750"/>
+            <a:off x="731520" y="868680"/>
+            <a:ext cx="2286000" cy="31750"/>
           </a:xfrm>
           <a:prstGeom prst="rect">
             <a:avLst/>
@@ -6164,7 +6109,7 @@
         <p:spPr>
           <a:xfrm>
             <a:off x="731520" y="1371600"/>
-            <a:ext cx="10698480" cy="1371600"/>
+            <a:ext cx="10698480" cy="1097280"/>
           </a:xfrm>
           <a:prstGeom prst="rect">
             <a:avLst/>
@@ -6207,7 +6152,7 @@
         <p:spPr>
           <a:xfrm>
             <a:off x="1097280" y="1463040"/>
-            <a:ext cx="10058400" cy="365760"/>
+            <a:ext cx="10058400" cy="274320"/>
           </a:xfrm>
           <a:prstGeom prst="rect">
             <a:avLst/>
@@ -6222,9 +6167,9 @@
           <a:p>
             <a:pPr algn="l">
               <a:spcAft>
-                <a:spcPts val="400"/>
-              </a:spcAft>
-              <a:defRPr sz="1800" b="1">
+                <a:spcPts val="200"/>
+              </a:spcAft>
+              <a:defRPr sz="1600" b="1">
                 <a:solidFill>
                   <a:srgbClr val="5B3A8C"/>
                 </a:solidFill>
@@ -6245,8 +6190,8 @@
         </p:nvSpPr>
         <p:spPr>
           <a:xfrm>
-            <a:off x="1097280" y="1920240"/>
-            <a:ext cx="10058400" cy="731520"/>
+            <a:off x="1097280" y="1828800"/>
+            <a:ext cx="10058400" cy="548640"/>
           </a:xfrm>
           <a:prstGeom prst="rect">
             <a:avLst/>
@@ -6261,9 +6206,9 @@
           <a:p>
             <a:pPr>
               <a:spcAft>
-                <a:spcPts val="800"/>
-              </a:spcAft>
-              <a:defRPr sz="1800">
+                <a:spcPts val="1000"/>
+              </a:spcAft>
+              <a:defRPr sz="1900">
                 <a:solidFill>
                   <a:srgbClr val="2D2240"/>
                 </a:solidFill>
@@ -6271,15 +6216,15 @@
               </a:defRPr>
             </a:pPr>
             <a:r>
-              <a:t>Futsal = proven donor sport — but transfer is SKILL-SPECIFIC</a:t>
+              <a:t>Futsal = proven donor sport — but skill-specific</a:t>
             </a:r>
           </a:p>
           <a:p>
             <a:pPr>
               <a:spcAft>
-                <a:spcPts val="800"/>
-              </a:spcAft>
-              <a:defRPr sz="1800">
+                <a:spcPts val="1000"/>
+              </a:spcAft>
+              <a:defRPr sz="1900">
                 <a:solidFill>
                   <a:srgbClr val="2D2240"/>
                 </a:solidFill>
@@ -6287,23 +6232,7 @@
               </a:defRPr>
             </a:pPr>
             <a:r>
-              <a:t>Passing ✅ | Speed ⚠️ (context) | Dribbling ❌ (no auto transfer)</a:t>
-            </a:r>
-          </a:p>
-          <a:p>
-            <a:pPr>
-              <a:spcAft>
-                <a:spcPts val="800"/>
-              </a:spcAft>
-              <a:defRPr sz="1800">
-                <a:solidFill>
-                  <a:srgbClr val="2D2240"/>
-                </a:solidFill>
-                <a:latin typeface="Segoe UI"/>
-              </a:defRPr>
-            </a:pPr>
-            <a:r>
-              <a:t>Only 7 studies — promising but limited evidence base</a:t>
+              <a:t>Passing ✅ | Speed ⚠️ | Dribbling ❌</a:t>
             </a:r>
           </a:p>
         </p:txBody>
@@ -6316,7 +6245,7 @@
         </p:nvSpPr>
         <p:spPr>
           <a:xfrm>
-            <a:off x="3200400" y="3017520"/>
+            <a:off x="3200400" y="2743200"/>
             <a:ext cx="5760720" cy="365760"/>
           </a:xfrm>
           <a:prstGeom prst="rect">
@@ -6332,9 +6261,9 @@
           <a:p>
             <a:pPr algn="ctr">
               <a:spcAft>
-                <a:spcPts val="400"/>
-              </a:spcAft>
-              <a:defRPr sz="1700" b="1">
+                <a:spcPts val="200"/>
+              </a:spcAft>
+              <a:defRPr sz="1600" b="1">
                 <a:solidFill>
                   <a:srgbClr val="7E57C2"/>
                 </a:solidFill>
@@ -6355,8 +6284,8 @@
         </p:nvSpPr>
         <p:spPr>
           <a:xfrm>
-            <a:off x="731520" y="3657600"/>
-            <a:ext cx="5029200" cy="2560320"/>
+            <a:off x="731520" y="3200400"/>
+            <a:ext cx="5029200" cy="274320"/>
           </a:xfrm>
           <a:prstGeom prst="rect">
             <a:avLst/>
@@ -6369,79 +6298,19 @@
           </a:bodyPr>
           <a:lstStyle/>
           <a:p>
-            <a:pPr>
-              <a:spcAft>
-                <a:spcPts val="800"/>
-              </a:spcAft>
-              <a:defRPr sz="1800">
-                <a:solidFill>
-                  <a:srgbClr val="2D2240"/>
-                </a:solidFill>
-                <a:latin typeface="Segoe UI"/>
-              </a:defRPr>
-            </a:pPr>
-            <a:r>
-              <a:t>✅  Passing transfers</a:t>
-            </a:r>
-            <a:br/>
-            <a:r>
-              <a:t>     SMD = 1.43</a:t>
-            </a:r>
-          </a:p>
-          <a:p>
-            <a:pPr>
-              <a:spcAft>
-                <a:spcPts val="800"/>
-              </a:spcAft>
-              <a:defRPr sz="1800">
-                <a:solidFill>
-                  <a:srgbClr val="2D2240"/>
-                </a:solidFill>
-                <a:latin typeface="Segoe UI"/>
-              </a:defRPr>
-            </a:pPr>
-            <a:r>
-              <a:t>⚠️  Speed depends on context</a:t>
-            </a:r>
-            <a:br/>
-            <a:r>
-              <a:t>     I² = 94.5%</a:t>
-            </a:r>
-          </a:p>
-          <a:p>
-            <a:pPr>
-              <a:spcAft>
-                <a:spcPts val="800"/>
-              </a:spcAft>
-              <a:defRPr sz="1800">
-                <a:solidFill>
-                  <a:srgbClr val="2D2240"/>
-                </a:solidFill>
-                <a:latin typeface="Segoe UI"/>
-              </a:defRPr>
-            </a:pPr>
-            <a:r>
-              <a:t>❌  Dribbling: sport-specific</a:t>
-            </a:r>
-          </a:p>
-          <a:p>
-            <a:pPr>
-              <a:spcAft>
-                <a:spcPts val="800"/>
-              </a:spcAft>
-              <a:defRPr sz="1800">
-                <a:solidFill>
-                  <a:srgbClr val="2D2240"/>
-                </a:solidFill>
-                <a:latin typeface="Segoe UI"/>
-              </a:defRPr>
-            </a:pPr>
-            <a:r>
-              <a:t>⚠️  No longitudinal</a:t>
-            </a:r>
-            <a:br/>
-            <a:r>
-              <a:t>     No negative transfer</a:t>
+            <a:pPr algn="l">
+              <a:spcAft>
+                <a:spcPts val="200"/>
+              </a:spcAft>
+              <a:defRPr sz="1600" b="1">
+                <a:solidFill>
+                  <a:srgbClr val="7E57C2"/>
+                </a:solidFill>
+                <a:latin typeface="Segoe UI"/>
+              </a:defRPr>
+            </a:pPr>
+            <a:r>
+              <a:t>This Review</a:t>
             </a:r>
           </a:p>
         </p:txBody>
@@ -6454,8 +6323,8 @@
         </p:nvSpPr>
         <p:spPr>
           <a:xfrm>
-            <a:off x="6858000" y="3657600"/>
-            <a:ext cx="5029200" cy="2560320"/>
+            <a:off x="1097280" y="3657600"/>
+            <a:ext cx="4572000" cy="2286000"/>
           </a:xfrm>
           <a:prstGeom prst="rect">
             <a:avLst/>
@@ -6470,9 +6339,9 @@
           <a:p>
             <a:pPr>
               <a:spcAft>
-                <a:spcPts val="800"/>
-              </a:spcAft>
-              <a:defRPr sz="1800">
+                <a:spcPts val="1000"/>
+              </a:spcAft>
+              <a:defRPr sz="1700">
                 <a:solidFill>
                   <a:srgbClr val="2D2240"/>
                 </a:solidFill>
@@ -6480,19 +6349,15 @@
               </a:defRPr>
             </a:pPr>
             <a:r>
-              <a:t>Theme 1</a:t>
-            </a:r>
-            <a:br/>
-            <a:r>
-              <a:t>Technical skill transfer</a:t>
+              <a:t>Passing: SMD = 1.43</a:t>
             </a:r>
           </a:p>
           <a:p>
             <a:pPr>
               <a:spcAft>
-                <a:spcPts val="800"/>
-              </a:spcAft>
-              <a:defRPr sz="1800">
+                <a:spcPts val="1000"/>
+              </a:spcAft>
+              <a:defRPr sz="1700">
                 <a:solidFill>
                   <a:srgbClr val="2D2240"/>
                 </a:solidFill>
@@ -6500,19 +6365,15 @@
               </a:defRPr>
             </a:pPr>
             <a:r>
-              <a:t>Theme 2</a:t>
-            </a:r>
-            <a:br/>
-            <a:r>
-              <a:t>Perceptual-cognitive adaptation</a:t>
+              <a:t>Speed: context-dependent</a:t>
             </a:r>
           </a:p>
           <a:p>
             <a:pPr>
               <a:spcAft>
-                <a:spcPts val="800"/>
-              </a:spcAft>
-              <a:defRPr sz="1800">
+                <a:spcPts val="1000"/>
+              </a:spcAft>
+              <a:defRPr sz="1700">
                 <a:solidFill>
                   <a:srgbClr val="2D2240"/>
                 </a:solidFill>
@@ -6520,19 +6381,15 @@
               </a:defRPr>
             </a:pPr>
             <a:r>
-              <a:t>Theme 3</a:t>
-            </a:r>
-            <a:br/>
-            <a:r>
-              <a:t>Talent development pathways</a:t>
+              <a:t>Dribbling: sport-specific</a:t>
             </a:r>
           </a:p>
           <a:p>
             <a:pPr>
               <a:spcAft>
-                <a:spcPts val="800"/>
-              </a:spcAft>
-              <a:defRPr sz="1800">
+                <a:spcPts val="1000"/>
+              </a:spcAft>
+              <a:defRPr sz="1700">
                 <a:solidFill>
                   <a:srgbClr val="2D2240"/>
                 </a:solidFill>
@@ -6540,11 +6397,7 @@
               </a:defRPr>
             </a:pPr>
             <a:r>
-              <a:t>➕  What does NOT transfer?</a:t>
-            </a:r>
-            <a:br/>
-            <a:r>
-              <a:t>     The research gap</a:t>
+              <a:t>No longitudinal data</a:t>
             </a:r>
           </a:p>
         </p:txBody>
@@ -6557,8 +6410,8 @@
         </p:nvSpPr>
         <p:spPr>
           <a:xfrm>
-            <a:off x="6583680" y="3657600"/>
-            <a:ext cx="19050" cy="2560320"/>
+            <a:off x="6583680" y="3200400"/>
+            <a:ext cx="19050" cy="3200400"/>
           </a:xfrm>
           <a:prstGeom prst="rect">
             <a:avLst/>
@@ -6600,8 +6453,8 @@
         </p:nvSpPr>
         <p:spPr>
           <a:xfrm>
-            <a:off x="731520" y="3246120"/>
-            <a:ext cx="5029200" cy="320040"/>
+            <a:off x="7132320" y="3200400"/>
+            <a:ext cx="4572000" cy="274320"/>
           </a:xfrm>
           <a:prstGeom prst="rect">
             <a:avLst/>
@@ -6616,9 +6469,9 @@
           <a:p>
             <a:pPr algn="l">
               <a:spcAft>
-                <a:spcPts val="400"/>
-              </a:spcAft>
-              <a:defRPr sz="1700" b="1">
+                <a:spcPts val="200"/>
+              </a:spcAft>
+              <a:defRPr sz="1600" b="1">
                 <a:solidFill>
                   <a:srgbClr val="7E57C2"/>
                 </a:solidFill>
@@ -6626,7 +6479,7 @@
               </a:defRPr>
             </a:pPr>
             <a:r>
-              <a:t>Peña-Ardila tells us</a:t>
+              <a:t>My LR</a:t>
             </a:r>
           </a:p>
         </p:txBody>
@@ -6639,8 +6492,8 @@
         </p:nvSpPr>
         <p:spPr>
           <a:xfrm>
-            <a:off x="6858000" y="3246120"/>
-            <a:ext cx="5029200" cy="320040"/>
+            <a:off x="7498079" y="3657600"/>
+            <a:ext cx="4389120" cy="2286000"/>
           </a:xfrm>
           <a:prstGeom prst="rect">
             <a:avLst/>
@@ -6653,19 +6506,67 @@
           </a:bodyPr>
           <a:lstStyle/>
           <a:p>
-            <a:pPr algn="l">
-              <a:spcAft>
-                <a:spcPts val="400"/>
-              </a:spcAft>
-              <a:defRPr sz="1700" b="1">
-                <a:solidFill>
-                  <a:srgbClr val="7E57C2"/>
-                </a:solidFill>
-                <a:latin typeface="Segoe UI"/>
-              </a:defRPr>
-            </a:pPr>
-            <a:r>
-              <a:t>My LR will explore</a:t>
+            <a:pPr>
+              <a:spcAft>
+                <a:spcPts val="1000"/>
+              </a:spcAft>
+              <a:defRPr sz="1700">
+                <a:solidFill>
+                  <a:srgbClr val="2D2240"/>
+                </a:solidFill>
+                <a:latin typeface="Segoe UI"/>
+              </a:defRPr>
+            </a:pPr>
+            <a:r>
+              <a:t>Theme 1: Technical transfer</a:t>
+            </a:r>
+          </a:p>
+          <a:p>
+            <a:pPr>
+              <a:spcAft>
+                <a:spcPts val="1000"/>
+              </a:spcAft>
+              <a:defRPr sz="1700">
+                <a:solidFill>
+                  <a:srgbClr val="2D2240"/>
+                </a:solidFill>
+                <a:latin typeface="Segoe UI"/>
+              </a:defRPr>
+            </a:pPr>
+            <a:r>
+              <a:t>Theme 2: Perceptual-cognitive</a:t>
+            </a:r>
+          </a:p>
+          <a:p>
+            <a:pPr>
+              <a:spcAft>
+                <a:spcPts val="1000"/>
+              </a:spcAft>
+              <a:defRPr sz="1700">
+                <a:solidFill>
+                  <a:srgbClr val="2D2240"/>
+                </a:solidFill>
+                <a:latin typeface="Segoe UI"/>
+              </a:defRPr>
+            </a:pPr>
+            <a:r>
+              <a:t>Theme 3: Talent development</a:t>
+            </a:r>
+          </a:p>
+          <a:p>
+            <a:pPr>
+              <a:spcAft>
+                <a:spcPts val="1000"/>
+              </a:spcAft>
+              <a:defRPr sz="1700">
+                <a:solidFill>
+                  <a:srgbClr val="2D2240"/>
+                </a:solidFill>
+                <a:latin typeface="Segoe UI"/>
+              </a:defRPr>
+            </a:pPr>
+            <a:r>
+              <a:t>➕  What does NOT transfer?</a:t>
             </a:r>
           </a:p>
         </p:txBody>

</xml_diff>